<commit_message>
QDR slides: carry the Nahunta two-stage tally distinction
- Slide 1 takeaways note the two-stage visits (8/26: SH tech 9/18 -> QC 8;
  9/9: SH tech 2/19, QC confirmed both)
- Slide 2 marks the two-stage batches with a dagger + footnote (final QC
  outcome shown)
- New slide 4: the two-stage format explained - stage table (SH-tech yield
  50% -> 10.5%, QC accept 88.9-100%, final FPY), definitions, and what the
  stage split shows. Deck is now 4 slides; validation passed.

Co-Authored-By: Claude Fable 5 <noreply@anthropic.com>
Claude-Session: https://claude.ai/code/session_014UGcEfvuC9NvQ5rauRTTbR
</commit_message>
<xml_diff>
--- a/QC inspections suppliers/QDR_Slides_AugSep2026.pptx
+++ b/QC inspections suppliers/QDR_Slides_AugSep2026.pptx
@@ -8,9 +8,10 @@
     <p:sldId id="256" r:id="rId2"/>
     <p:sldId id="257" r:id="rId3"/>
     <p:sldId id="258" r:id="rId4"/>
+    <p:sldId id="259" r:id="rId5"/>
   </p:sldIdLst>
   <p:notesMasterIdLst>
-    <p:notesMasterId r:id="rId5"/>
+    <p:notesMasterId r:id="rId6"/>
   </p:notesMasterIdLst>
   <p:sldSz cx="12192000" cy="6858000"/>
   <p:notesSz cx="6858000" cy="12192000"/>
@@ -2222,6 +2223,94 @@
 </p:notes>
 </file>
 
+<file path=ppt/notesSlides/notesSlide4.xml><?xml version="1.0" encoding="utf-8"?>
+<p:notes xmlns:a="http://schemas.openxmlformats.org/drawingml/2006/main" xmlns:r="http://schemas.openxmlformats.org/officeDocument/2006/relationships" xmlns:p="http://schemas.openxmlformats.org/presentationml/2006/main">
+  <p:cSld>
+    <p:spTree>
+      <p:nvGrpSpPr>
+        <p:cNvPr id="1" name=""/>
+        <p:cNvGrpSpPr/>
+        <p:nvPr/>
+      </p:nvGrpSpPr>
+      <p:grpSpPr>
+        <a:xfrm>
+          <a:off x="0" y="0"/>
+          <a:ext cx="0" cy="0"/>
+          <a:chOff x="0" y="0"/>
+          <a:chExt cx="0" cy="0"/>
+        </a:xfrm>
+      </p:grpSpPr>
+      <p:sp>
+        <p:nvSpPr>
+          <p:cNvPr id="2" name="Slide Image Placeholder 1"/>
+          <p:cNvSpPr>
+            <a:spLocks noGrp="1" noRot="1" noChangeAspect="1"/>
+          </p:cNvSpPr>
+          <p:nvPr>
+            <p:ph type="sldImg"/>
+          </p:nvPr>
+        </p:nvSpPr>
+        <p:spPr/>
+      </p:sp>
+      <p:sp>
+        <p:nvSpPr>
+          <p:cNvPr id="3" name="Notes Placeholder 2"/>
+          <p:cNvSpPr>
+            <a:spLocks noGrp="1"/>
+          </p:cNvSpPr>
+          <p:nvPr>
+            <p:ph type="body" idx="1"/>
+          </p:nvPr>
+        </p:nvSpPr>
+        <p:spPr/>
+        <p:txBody>
+          <a:bodyPr/>
+          <a:lstStyle/>
+          <a:p>
+            <a:r>
+              <a:rPr lang="en-US" dirty="0"/>
+              <a:t/>
+            </a:r>
+            <a:endParaRPr lang="en-US" dirty="0"/>
+          </a:p>
+        </p:txBody>
+      </p:sp>
+      <p:sp>
+        <p:nvSpPr>
+          <p:cNvPr id="4" name="Slide Number Placeholder 3"/>
+          <p:cNvSpPr>
+            <a:spLocks noGrp="1"/>
+          </p:cNvSpPr>
+          <p:nvPr>
+            <p:ph type="sldNum" sz="quarter" idx="10"/>
+          </p:nvPr>
+        </p:nvSpPr>
+        <p:spPr/>
+        <p:txBody>
+          <a:bodyPr/>
+          <a:lstStyle/>
+          <a:p>
+            <a:fld id="{F7021451-1387-4CA6-816F-3879F97B5CBC}" type="slidenum">
+              <a:rPr lang="en-US"/>
+              <a:t>4</a:t>
+            </a:fld>
+            <a:endParaRPr lang="en-US"/>
+          </a:p>
+        </p:txBody>
+      </p:sp>
+    </p:spTree>
+    <p:extLst>
+      <p:ext uri="{BB962C8B-B14F-4D97-AF65-F5344CB8AC3E}">
+        <p14:creationId xmlns:p14="http://schemas.microsoft.com/office/powerpoint/2010/main" val="1024086991"/>
+      </p:ext>
+    </p:extLst>
+  </p:cSld>
+  <p:clrMapOvr>
+    <a:masterClrMapping/>
+  </p:clrMapOvr>
+</p:notes>
+</file>
+
 <file path=ppt/slideLayouts/slideLayout1.xml><?xml version="1.0" encoding="utf-8"?>
 <p:sldLayout xmlns:a="http://schemas.openxmlformats.org/drawingml/2006/main" xmlns:r="http://schemas.openxmlformats.org/officeDocument/2006/relationships" xmlns:p="http://schemas.openxmlformats.org/presentationml/2006/main" preserve="1">
   <p:cSld name="DEFAULT">
@@ -6412,7 +6501,7 @@
                 <a:ea typeface="Calibri" pitchFamily="34" charset="-122"/>
                 <a:cs typeface="Calibri" pitchFamily="34" charset="-120"/>
               </a:rPr>
-              <a:t>666521 (Thoracic @ Nahunta): 21.3% FPY on 75 across 4 visits — lung lacerations (39) and heart damage (21) persist, but 8/26 rebounded to 44% after Francisco's team engagement.</a:t>
+              <a:t>666521 (Thoracic @ Nahunta): 21.3% FPY on 75 across 4 visits — lung lacerations (39) and heart damage (21) persist; 8/26 rebounded to 44% (two-stage tally: SH tech passed 9/18, QC confirmed 8) after Francisco's team engagement.</a:t>
             </a:r>
             <a:endParaRPr lang="en-US" sz="840" dirty="0"/>
           </a:p>
@@ -6454,7 +6543,7 @@
                 <a:ea typeface="Calibri" pitchFamily="34" charset="-122"/>
                 <a:cs typeface="Calibri" pitchFamily="34" charset="-120"/>
               </a:rPr>
-              <a:t>September to date (9/9): thoracic 10.5% on 19 — NEW failure mode: 9 missing trachea (SH harvesting tracheas for another buyer).</a:t>
+              <a:t>September to date (9/9, two-stage): SH tech passed only 2/19 and QC confirmed both — NEW failure mode: 9 missing trachea (SH harvesting tracheas for another buyer).</a:t>
             </a:r>
             <a:endParaRPr lang="en-US" sz="840" dirty="0"/>
           </a:p>
@@ -15601,7 +15690,7 @@
                           <a:ea typeface="Calibri" pitchFamily="34" charset="-122"/>
                           <a:cs typeface="Calibri" pitchFamily="34" charset="-120"/>
                         </a:rPr>
-                        <a:t>5502539375</a:t>
+                        <a:t>5502539375 †</a:t>
                       </a:r>
                       <a:endParaRPr lang="en-US" sz="760" dirty="0">
                         <a:latin typeface="Calibri" charset="0"/>
@@ -16215,7 +16304,7 @@
                           <a:ea typeface="Calibri" pitchFamily="34" charset="-122"/>
                           <a:cs typeface="Calibri" pitchFamily="34" charset="-120"/>
                         </a:rPr>
-                        <a:t>5502550281</a:t>
+                        <a:t>5502550281 †</a:t>
                       </a:r>
                       <a:endParaRPr lang="en-US" sz="760" dirty="0">
                         <a:latin typeface="Calibri" charset="0"/>
@@ -16818,6 +16907,45 @@
       <p:sp>
         <p:nvSpPr>
           <p:cNvPr id="6" name="Text 2"/>
+          <p:cNvSpPr/>
+          <p:nvPr/>
+        </p:nvSpPr>
+        <p:spPr>
+          <a:xfrm>
+            <a:off x="502920" y="6272784"/>
+            <a:ext cx="11155680" cy="201168"/>
+          </a:xfrm>
+          <a:prstGeom prst="rect">
+            <a:avLst/>
+          </a:prstGeom>
+          <a:noFill/>
+          <a:ln/>
+        </p:spPr>
+        <p:txBody>
+          <a:bodyPr wrap="square" lIns="0" tIns="0" rIns="0" bIns="0" rtlCol="0" anchor="ctr"/>
+          <a:lstStyle/>
+          <a:p>
+            <a:pPr indent="0" marL="0">
+              <a:buNone/>
+            </a:pPr>
+            <a:r>
+              <a:rPr lang="en-US" sz="780" i="1" dirty="0">
+                <a:solidFill>
+                  <a:srgbClr val="6B7280"/>
+                </a:solidFill>
+                <a:latin typeface="Calibri" pitchFamily="34" charset="0"/>
+                <a:ea typeface="Calibri" pitchFamily="34" charset="-122"/>
+                <a:cs typeface="Calibri" pitchFamily="34" charset="-120"/>
+              </a:rPr>
+              <a:t>† Inspected under Nahunta's new two-stage tally (SH tech screens, then QC inspects) — SH I/P/F shown is the final QC outcome; stage detail on the two-stage slide.</a:t>
+            </a:r>
+            <a:endParaRPr lang="en-US" sz="780" dirty="0"/>
+          </a:p>
+        </p:txBody>
+      </p:sp>
+      <p:sp>
+        <p:nvSpPr>
+          <p:cNvPr id="7" name="Text 3"/>
           <p:cNvSpPr/>
           <p:nvPr/>
         </p:nvSpPr>
@@ -16856,7 +16984,7 @@
       </p:sp>
       <p:sp>
         <p:nvSpPr>
-          <p:cNvPr id="7" name="Text 3"/>
+          <p:cNvPr id="8" name="Text 4"/>
           <p:cNvSpPr/>
           <p:nvPr/>
         </p:nvSpPr>
@@ -17426,6 +17554,1957 @@
 </p:sld>
 </file>
 
+<file path=ppt/slides/slide4.xml><?xml version="1.0" encoding="utf-8"?>
+<p:sld xmlns:a="http://schemas.openxmlformats.org/drawingml/2006/main" xmlns:r="http://schemas.openxmlformats.org/officeDocument/2006/relationships" xmlns:p="http://schemas.openxmlformats.org/presentationml/2006/main">
+  <p:cSld name="Slide 4">
+    <p:bg>
+      <p:bgPr>
+        <a:solidFill>
+          <a:srgbClr val="FFFFFF"/>
+        </a:solidFill>
+      </p:bgPr>
+    </p:bg>
+    <p:spTree>
+      <p:nvGrpSpPr>
+        <p:cNvPr id="1" name=""/>
+        <p:cNvGrpSpPr/>
+        <p:nvPr/>
+      </p:nvGrpSpPr>
+      <p:grpSpPr>
+        <a:xfrm>
+          <a:off x="0" y="0"/>
+          <a:ext cx="0" cy="0"/>
+          <a:chOff x="0" y="0"/>
+          <a:chExt cx="0" cy="0"/>
+        </a:xfrm>
+      </p:grpSpPr>
+      <p:sp>
+        <p:nvSpPr>
+          <p:cNvPr id="2" name="Text 0"/>
+          <p:cNvSpPr/>
+          <p:nvPr/>
+        </p:nvSpPr>
+        <p:spPr>
+          <a:xfrm>
+            <a:off x="502920" y="256032"/>
+            <a:ext cx="8686800" cy="256032"/>
+          </a:xfrm>
+          <a:prstGeom prst="rect">
+            <a:avLst/>
+          </a:prstGeom>
+          <a:noFill/>
+          <a:ln/>
+        </p:spPr>
+        <p:txBody>
+          <a:bodyPr wrap="square" lIns="0" tIns="0" rIns="0" bIns="0" rtlCol="0" anchor="ctr"/>
+          <a:lstStyle/>
+          <a:p>
+            <a:pPr indent="0" marL="0">
+              <a:buNone/>
+            </a:pPr>
+            <a:r>
+              <a:rPr lang="en-US" sz="1100" b="1" spc="200" kern="0" dirty="0">
+                <a:solidFill>
+                  <a:srgbClr val="0E7490"/>
+                </a:solidFill>
+                <a:latin typeface="Calibri" pitchFamily="34" charset="0"/>
+                <a:ea typeface="Calibri" pitchFamily="34" charset="-122"/>
+                <a:cs typeface="Calibri" pitchFamily="34" charset="-120"/>
+              </a:rPr>
+              <a:t>QDR  ·  FORMAT CHANGE &amp; WHAT IT SHOWS</a:t>
+            </a:r>
+            <a:endParaRPr lang="en-US" sz="1100" dirty="0"/>
+          </a:p>
+        </p:txBody>
+      </p:sp>
+      <p:sp>
+        <p:nvSpPr>
+          <p:cNvPr id="3" name="Text 1"/>
+          <p:cNvSpPr/>
+          <p:nvPr/>
+        </p:nvSpPr>
+        <p:spPr>
+          <a:xfrm>
+            <a:off x="502920" y="475488"/>
+            <a:ext cx="11155680" cy="566928"/>
+          </a:xfrm>
+          <a:prstGeom prst="rect">
+            <a:avLst/>
+          </a:prstGeom>
+          <a:noFill/>
+          <a:ln/>
+        </p:spPr>
+        <p:txBody>
+          <a:bodyPr wrap="square" lIns="0" tIns="0" rIns="0" bIns="0" rtlCol="0" anchor="ctr"/>
+          <a:lstStyle/>
+          <a:p>
+            <a:pPr indent="0" marL="0">
+              <a:buNone/>
+            </a:pPr>
+            <a:r>
+              <a:rPr lang="en-US" sz="2800" b="1" dirty="0">
+                <a:solidFill>
+                  <a:srgbClr val="1F2937"/>
+                </a:solidFill>
+                <a:latin typeface="Calibri" pitchFamily="34" charset="0"/>
+                <a:ea typeface="Calibri" pitchFamily="34" charset="-122"/>
+                <a:cs typeface="Calibri" pitchFamily="34" charset="-120"/>
+              </a:rPr>
+              <a:t>Nahunta — New Two-Stage Tally (since 8/26)</a:t>
+            </a:r>
+            <a:endParaRPr lang="en-US" sz="2800" dirty="0"/>
+          </a:p>
+        </p:txBody>
+      </p:sp>
+      <p:sp>
+        <p:nvSpPr>
+          <p:cNvPr id="4" name="Text 2"/>
+          <p:cNvSpPr/>
+          <p:nvPr/>
+        </p:nvSpPr>
+        <p:spPr>
+          <a:xfrm>
+            <a:off x="502920" y="1188720"/>
+            <a:ext cx="11183112" cy="566928"/>
+          </a:xfrm>
+          <a:prstGeom prst="rect">
+            <a:avLst/>
+          </a:prstGeom>
+          <a:noFill/>
+          <a:ln/>
+        </p:spPr>
+        <p:txBody>
+          <a:bodyPr wrap="square" lIns="0" tIns="0" rIns="0" bIns="0" rtlCol="0" anchor="ctr"/>
+          <a:lstStyle/>
+          <a:p>
+            <a:pPr indent="0" marL="0">
+              <a:buNone/>
+            </a:pPr>
+            <a:r>
+              <a:rPr lang="en-US" sz="1200" dirty="0">
+                <a:solidFill>
+                  <a:srgbClr val="1F2937"/>
+                </a:solidFill>
+                <a:latin typeface="Calibri" pitchFamily="34" charset="0"/>
+                <a:ea typeface="Calibri" pitchFamily="34" charset="-122"/>
+                <a:cs typeface="Calibri" pitchFamily="34" charset="-120"/>
+              </a:rPr>
+              <a:t>Nahunta tally sheets now carry two stages: the slaughterhouse's own tech screens every block, then our QC tech inspects the SH-passed blocks. The Inspection Log keeps recording the FINAL QC outcome, so all cross-site comparisons are unchanged — but the stage split adds two new signals.</a:t>
+            </a:r>
+            <a:endParaRPr lang="en-US" sz="1200" dirty="0"/>
+          </a:p>
+        </p:txBody>
+      </p:sp>
+      <p:graphicFrame>
+        <p:nvGraphicFramePr>
+          <p:cNvPr id="5" name="Table 0"/>
+          <p:cNvGraphicFramePr>
+            <a:graphicFrameLocks noGrp="1"/>
+          </p:cNvGraphicFramePr>
+          <p:nvPr>
+            <p:extLst>
+              <p:ext uri="{D42A27DB-BD31-4B8C-83A1-F6EECF244321}">
+                <p14:modId xmlns:p14="http://schemas.microsoft.com/office/powerpoint/2010/main" val="1579011935"/>
+              </p:ext>
+            </p:extLst>
+          </p:nvPr>
+        </p:nvGraphicFramePr>
+        <p:xfrm>
+          <a:off x="502920" y="1874520"/>
+          <a:ext cx="11183112" cy="914400"/>
+        </p:xfrm>
+        <a:graphic>
+          <a:graphicData uri="http://schemas.openxmlformats.org/drawingml/2006/table">
+            <a:tbl>
+              <a:tblPr/>
+              <a:tblGrid>
+                <a:gridCol w="1051560"/>
+                <a:gridCol w="1143000"/>
+                <a:gridCol w="960120"/>
+                <a:gridCol w="1600200"/>
+                <a:gridCol w="1691640"/>
+                <a:gridCol w="1005840"/>
+                <a:gridCol w="3730752"/>
+              </a:tblGrid>
+              <a:tr h="502920">
+                <a:tc>
+                  <a:txBody>
+                    <a:bodyPr/>
+                    <a:lstStyle/>
+                    <a:p>
+                      <a:pPr indent="0" marL="0">
+                        <a:buNone/>
+                      </a:pPr>
+                      <a:r>
+                        <a:rPr lang="en-US" sz="1000" b="1" dirty="0">
+                          <a:solidFill>
+                            <a:srgbClr val="FFFFFF"/>
+                          </a:solidFill>
+                          <a:latin typeface="Calibri" pitchFamily="34" charset="0"/>
+                          <a:ea typeface="Calibri" pitchFamily="34" charset="-122"/>
+                          <a:cs typeface="Calibri" pitchFamily="34" charset="-120"/>
+                        </a:rPr>
+                        <a:t>Harvest date</a:t>
+                      </a:r>
+                      <a:endParaRPr lang="en-US" sz="1000" dirty="0">
+                        <a:latin typeface="Calibri" charset="0"/>
+                        <a:ea typeface="Calibri" charset="0"/>
+                        <a:cs typeface="Calibri" charset="0"/>
+                      </a:endParaRPr>
+                    </a:p>
+                  </a:txBody>
+                  <a:tcPr marL="91440" marR="91440" marT="45720" marB="45720" anchor="ctr">
+                    <a:lnL w="6350" cap="flat" cmpd="sng" algn="ctr">
+                      <a:solidFill>
+                        <a:srgbClr val="E5E7EB"/>
+                      </a:solidFill>
+                      <a:prstDash val="solid"/>
+                      <a:round/>
+                      <a:headEnd type="none" w="med" len="med"/>
+                      <a:tailEnd type="none" w="med" len="med"/>
+                    </a:lnL>
+                    <a:lnR w="6350" cap="flat" cmpd="sng" algn="ctr">
+                      <a:solidFill>
+                        <a:srgbClr val="E5E7EB"/>
+                      </a:solidFill>
+                      <a:prstDash val="solid"/>
+                      <a:round/>
+                      <a:headEnd type="none" w="med" len="med"/>
+                      <a:tailEnd type="none" w="med" len="med"/>
+                    </a:lnR>
+                    <a:lnT w="6350" cap="flat" cmpd="sng" algn="ctr">
+                      <a:solidFill>
+                        <a:srgbClr val="E5E7EB"/>
+                      </a:solidFill>
+                      <a:prstDash val="solid"/>
+                      <a:round/>
+                      <a:headEnd type="none" w="med" len="med"/>
+                      <a:tailEnd type="none" w="med" len="med"/>
+                    </a:lnT>
+                    <a:lnB w="6350" cap="flat" cmpd="sng" algn="ctr">
+                      <a:solidFill>
+                        <a:srgbClr val="E5E7EB"/>
+                      </a:solidFill>
+                      <a:prstDash val="solid"/>
+                      <a:round/>
+                      <a:headEnd type="none" w="med" len="med"/>
+                      <a:tailEnd type="none" w="med" len="med"/>
+                    </a:lnB>
+                    <a:solidFill>
+                      <a:srgbClr val="1F2937"/>
+                    </a:solidFill>
+                  </a:tcPr>
+                </a:tc>
+                <a:tc>
+                  <a:txBody>
+                    <a:bodyPr/>
+                    <a:lstStyle/>
+                    <a:p>
+                      <a:pPr indent="0" marL="0">
+                        <a:buNone/>
+                      </a:pPr>
+                      <a:r>
+                        <a:rPr lang="en-US" sz="1000" b="1" dirty="0">
+                          <a:solidFill>
+                            <a:srgbClr val="FFFFFF"/>
+                          </a:solidFill>
+                          <a:latin typeface="Calibri" pitchFamily="34" charset="0"/>
+                          <a:ea typeface="Calibri" pitchFamily="34" charset="-122"/>
+                          <a:cs typeface="Calibri" pitchFamily="34" charset="-120"/>
+                        </a:rPr>
+                        <a:t>Lot</a:t>
+                      </a:r>
+                      <a:endParaRPr lang="en-US" sz="1000" dirty="0">
+                        <a:latin typeface="Calibri" charset="0"/>
+                        <a:ea typeface="Calibri" charset="0"/>
+                        <a:cs typeface="Calibri" charset="0"/>
+                      </a:endParaRPr>
+                    </a:p>
+                  </a:txBody>
+                  <a:tcPr marL="91440" marR="91440" marT="45720" marB="45720" anchor="ctr">
+                    <a:lnL w="6350" cap="flat" cmpd="sng" algn="ctr">
+                      <a:solidFill>
+                        <a:srgbClr val="E5E7EB"/>
+                      </a:solidFill>
+                      <a:prstDash val="solid"/>
+                      <a:round/>
+                      <a:headEnd type="none" w="med" len="med"/>
+                      <a:tailEnd type="none" w="med" len="med"/>
+                    </a:lnL>
+                    <a:lnR w="6350" cap="flat" cmpd="sng" algn="ctr">
+                      <a:solidFill>
+                        <a:srgbClr val="E5E7EB"/>
+                      </a:solidFill>
+                      <a:prstDash val="solid"/>
+                      <a:round/>
+                      <a:headEnd type="none" w="med" len="med"/>
+                      <a:tailEnd type="none" w="med" len="med"/>
+                    </a:lnR>
+                    <a:lnT w="6350" cap="flat" cmpd="sng" algn="ctr">
+                      <a:solidFill>
+                        <a:srgbClr val="E5E7EB"/>
+                      </a:solidFill>
+                      <a:prstDash val="solid"/>
+                      <a:round/>
+                      <a:headEnd type="none" w="med" len="med"/>
+                      <a:tailEnd type="none" w="med" len="med"/>
+                    </a:lnT>
+                    <a:lnB w="6350" cap="flat" cmpd="sng" algn="ctr">
+                      <a:solidFill>
+                        <a:srgbClr val="E5E7EB"/>
+                      </a:solidFill>
+                      <a:prstDash val="solid"/>
+                      <a:round/>
+                      <a:headEnd type="none" w="med" len="med"/>
+                      <a:tailEnd type="none" w="med" len="med"/>
+                    </a:lnB>
+                    <a:solidFill>
+                      <a:srgbClr val="1F2937"/>
+                    </a:solidFill>
+                  </a:tcPr>
+                </a:tc>
+                <a:tc>
+                  <a:txBody>
+                    <a:bodyPr/>
+                    <a:lstStyle/>
+                    <a:p>
+                      <a:pPr algn="r" indent="0" marL="0">
+                        <a:buNone/>
+                      </a:pPr>
+                      <a:r>
+                        <a:rPr lang="en-US" sz="1000" b="1" dirty="0">
+                          <a:solidFill>
+                            <a:srgbClr val="FFFFFF"/>
+                          </a:solidFill>
+                          <a:latin typeface="Calibri" pitchFamily="34" charset="0"/>
+                          <a:ea typeface="Calibri" pitchFamily="34" charset="-122"/>
+                          <a:cs typeface="Calibri" pitchFamily="34" charset="-120"/>
+                        </a:rPr>
+                        <a:t># Received</a:t>
+                      </a:r>
+                      <a:endParaRPr lang="en-US" sz="1000" dirty="0">
+                        <a:latin typeface="Calibri" charset="0"/>
+                        <a:ea typeface="Calibri" charset="0"/>
+                        <a:cs typeface="Calibri" charset="0"/>
+                      </a:endParaRPr>
+                    </a:p>
+                  </a:txBody>
+                  <a:tcPr marL="91440" marR="91440" marT="45720" marB="45720" anchor="ctr">
+                    <a:lnL w="6350" cap="flat" cmpd="sng" algn="ctr">
+                      <a:solidFill>
+                        <a:srgbClr val="E5E7EB"/>
+                      </a:solidFill>
+                      <a:prstDash val="solid"/>
+                      <a:round/>
+                      <a:headEnd type="none" w="med" len="med"/>
+                      <a:tailEnd type="none" w="med" len="med"/>
+                    </a:lnL>
+                    <a:lnR w="6350" cap="flat" cmpd="sng" algn="ctr">
+                      <a:solidFill>
+                        <a:srgbClr val="E5E7EB"/>
+                      </a:solidFill>
+                      <a:prstDash val="solid"/>
+                      <a:round/>
+                      <a:headEnd type="none" w="med" len="med"/>
+                      <a:tailEnd type="none" w="med" len="med"/>
+                    </a:lnR>
+                    <a:lnT w="6350" cap="flat" cmpd="sng" algn="ctr">
+                      <a:solidFill>
+                        <a:srgbClr val="E5E7EB"/>
+                      </a:solidFill>
+                      <a:prstDash val="solid"/>
+                      <a:round/>
+                      <a:headEnd type="none" w="med" len="med"/>
+                      <a:tailEnd type="none" w="med" len="med"/>
+                    </a:lnT>
+                    <a:lnB w="6350" cap="flat" cmpd="sng" algn="ctr">
+                      <a:solidFill>
+                        <a:srgbClr val="E5E7EB"/>
+                      </a:solidFill>
+                      <a:prstDash val="solid"/>
+                      <a:round/>
+                      <a:headEnd type="none" w="med" len="med"/>
+                      <a:tailEnd type="none" w="med" len="med"/>
+                    </a:lnB>
+                    <a:solidFill>
+                      <a:srgbClr val="1F2937"/>
+                    </a:solidFill>
+                  </a:tcPr>
+                </a:tc>
+                <a:tc>
+                  <a:txBody>
+                    <a:bodyPr/>
+                    <a:lstStyle/>
+                    <a:p>
+                      <a:pPr algn="ctr" indent="0" marL="0">
+                        <a:buNone/>
+                      </a:pPr>
+                      <a:r>
+                        <a:rPr lang="en-US" sz="1000" b="1" dirty="0">
+                          <a:solidFill>
+                            <a:srgbClr val="FFFFFF"/>
+                          </a:solidFill>
+                          <a:latin typeface="Calibri" pitchFamily="34" charset="0"/>
+                          <a:ea typeface="Calibri" pitchFamily="34" charset="-122"/>
+                          <a:cs typeface="Calibri" pitchFamily="34" charset="-120"/>
+                        </a:rPr>
+                        <a:t>SH-tech pass (yield)</a:t>
+                      </a:r>
+                      <a:endParaRPr lang="en-US" sz="1000" dirty="0">
+                        <a:latin typeface="Calibri" charset="0"/>
+                        <a:ea typeface="Calibri" charset="0"/>
+                        <a:cs typeface="Calibri" charset="0"/>
+                      </a:endParaRPr>
+                    </a:p>
+                  </a:txBody>
+                  <a:tcPr marL="91440" marR="91440" marT="45720" marB="45720" anchor="ctr">
+                    <a:lnL w="6350" cap="flat" cmpd="sng" algn="ctr">
+                      <a:solidFill>
+                        <a:srgbClr val="E5E7EB"/>
+                      </a:solidFill>
+                      <a:prstDash val="solid"/>
+                      <a:round/>
+                      <a:headEnd type="none" w="med" len="med"/>
+                      <a:tailEnd type="none" w="med" len="med"/>
+                    </a:lnL>
+                    <a:lnR w="6350" cap="flat" cmpd="sng" algn="ctr">
+                      <a:solidFill>
+                        <a:srgbClr val="E5E7EB"/>
+                      </a:solidFill>
+                      <a:prstDash val="solid"/>
+                      <a:round/>
+                      <a:headEnd type="none" w="med" len="med"/>
+                      <a:tailEnd type="none" w="med" len="med"/>
+                    </a:lnR>
+                    <a:lnT w="6350" cap="flat" cmpd="sng" algn="ctr">
+                      <a:solidFill>
+                        <a:srgbClr val="E5E7EB"/>
+                      </a:solidFill>
+                      <a:prstDash val="solid"/>
+                      <a:round/>
+                      <a:headEnd type="none" w="med" len="med"/>
+                      <a:tailEnd type="none" w="med" len="med"/>
+                    </a:lnT>
+                    <a:lnB w="6350" cap="flat" cmpd="sng" algn="ctr">
+                      <a:solidFill>
+                        <a:srgbClr val="E5E7EB"/>
+                      </a:solidFill>
+                      <a:prstDash val="solid"/>
+                      <a:round/>
+                      <a:headEnd type="none" w="med" len="med"/>
+                      <a:tailEnd type="none" w="med" len="med"/>
+                    </a:lnB>
+                    <a:solidFill>
+                      <a:srgbClr val="1F2937"/>
+                    </a:solidFill>
+                  </a:tcPr>
+                </a:tc>
+                <a:tc>
+                  <a:txBody>
+                    <a:bodyPr/>
+                    <a:lstStyle/>
+                    <a:p>
+                      <a:pPr algn="ctr" indent="0" marL="0">
+                        <a:buNone/>
+                      </a:pPr>
+                      <a:r>
+                        <a:rPr lang="en-US" sz="1000" b="1" dirty="0">
+                          <a:solidFill>
+                            <a:srgbClr val="FFFFFF"/>
+                          </a:solidFill>
+                          <a:latin typeface="Calibri" pitchFamily="34" charset="0"/>
+                          <a:ea typeface="Calibri" pitchFamily="34" charset="-122"/>
+                          <a:cs typeface="Calibri" pitchFamily="34" charset="-120"/>
+                        </a:rPr>
+                        <a:t>QC accept of SH-passed</a:t>
+                      </a:r>
+                      <a:endParaRPr lang="en-US" sz="1000" dirty="0">
+                        <a:latin typeface="Calibri" charset="0"/>
+                        <a:ea typeface="Calibri" charset="0"/>
+                        <a:cs typeface="Calibri" charset="0"/>
+                      </a:endParaRPr>
+                    </a:p>
+                  </a:txBody>
+                  <a:tcPr marL="91440" marR="91440" marT="45720" marB="45720" anchor="ctr">
+                    <a:lnL w="6350" cap="flat" cmpd="sng" algn="ctr">
+                      <a:solidFill>
+                        <a:srgbClr val="E5E7EB"/>
+                      </a:solidFill>
+                      <a:prstDash val="solid"/>
+                      <a:round/>
+                      <a:headEnd type="none" w="med" len="med"/>
+                      <a:tailEnd type="none" w="med" len="med"/>
+                    </a:lnL>
+                    <a:lnR w="6350" cap="flat" cmpd="sng" algn="ctr">
+                      <a:solidFill>
+                        <a:srgbClr val="E5E7EB"/>
+                      </a:solidFill>
+                      <a:prstDash val="solid"/>
+                      <a:round/>
+                      <a:headEnd type="none" w="med" len="med"/>
+                      <a:tailEnd type="none" w="med" len="med"/>
+                    </a:lnR>
+                    <a:lnT w="6350" cap="flat" cmpd="sng" algn="ctr">
+                      <a:solidFill>
+                        <a:srgbClr val="E5E7EB"/>
+                      </a:solidFill>
+                      <a:prstDash val="solid"/>
+                      <a:round/>
+                      <a:headEnd type="none" w="med" len="med"/>
+                      <a:tailEnd type="none" w="med" len="med"/>
+                    </a:lnT>
+                    <a:lnB w="6350" cap="flat" cmpd="sng" algn="ctr">
+                      <a:solidFill>
+                        <a:srgbClr val="E5E7EB"/>
+                      </a:solidFill>
+                      <a:prstDash val="solid"/>
+                      <a:round/>
+                      <a:headEnd type="none" w="med" len="med"/>
+                      <a:tailEnd type="none" w="med" len="med"/>
+                    </a:lnB>
+                    <a:solidFill>
+                      <a:srgbClr val="1F2937"/>
+                    </a:solidFill>
+                  </a:tcPr>
+                </a:tc>
+                <a:tc>
+                  <a:txBody>
+                    <a:bodyPr/>
+                    <a:lstStyle/>
+                    <a:p>
+                      <a:pPr algn="ctr" indent="0" marL="0">
+                        <a:buNone/>
+                      </a:pPr>
+                      <a:r>
+                        <a:rPr lang="en-US" sz="1000" b="1" dirty="0">
+                          <a:solidFill>
+                            <a:srgbClr val="FFFFFF"/>
+                          </a:solidFill>
+                          <a:latin typeface="Calibri" pitchFamily="34" charset="0"/>
+                          <a:ea typeface="Calibri" pitchFamily="34" charset="-122"/>
+                          <a:cs typeface="Calibri" pitchFamily="34" charset="-120"/>
+                        </a:rPr>
+                        <a:t>Final FPY</a:t>
+                      </a:r>
+                      <a:endParaRPr lang="en-US" sz="1000" dirty="0">
+                        <a:latin typeface="Calibri" charset="0"/>
+                        <a:ea typeface="Calibri" charset="0"/>
+                        <a:cs typeface="Calibri" charset="0"/>
+                      </a:endParaRPr>
+                    </a:p>
+                  </a:txBody>
+                  <a:tcPr marL="91440" marR="91440" marT="45720" marB="45720" anchor="ctr">
+                    <a:lnL w="6350" cap="flat" cmpd="sng" algn="ctr">
+                      <a:solidFill>
+                        <a:srgbClr val="E5E7EB"/>
+                      </a:solidFill>
+                      <a:prstDash val="solid"/>
+                      <a:round/>
+                      <a:headEnd type="none" w="med" len="med"/>
+                      <a:tailEnd type="none" w="med" len="med"/>
+                    </a:lnL>
+                    <a:lnR w="6350" cap="flat" cmpd="sng" algn="ctr">
+                      <a:solidFill>
+                        <a:srgbClr val="E5E7EB"/>
+                      </a:solidFill>
+                      <a:prstDash val="solid"/>
+                      <a:round/>
+                      <a:headEnd type="none" w="med" len="med"/>
+                      <a:tailEnd type="none" w="med" len="med"/>
+                    </a:lnR>
+                    <a:lnT w="6350" cap="flat" cmpd="sng" algn="ctr">
+                      <a:solidFill>
+                        <a:srgbClr val="E5E7EB"/>
+                      </a:solidFill>
+                      <a:prstDash val="solid"/>
+                      <a:round/>
+                      <a:headEnd type="none" w="med" len="med"/>
+                      <a:tailEnd type="none" w="med" len="med"/>
+                    </a:lnT>
+                    <a:lnB w="6350" cap="flat" cmpd="sng" algn="ctr">
+                      <a:solidFill>
+                        <a:srgbClr val="E5E7EB"/>
+                      </a:solidFill>
+                      <a:prstDash val="solid"/>
+                      <a:round/>
+                      <a:headEnd type="none" w="med" len="med"/>
+                      <a:tailEnd type="none" w="med" len="med"/>
+                    </a:lnB>
+                    <a:solidFill>
+                      <a:srgbClr val="1F2937"/>
+                    </a:solidFill>
+                  </a:tcPr>
+                </a:tc>
+                <a:tc>
+                  <a:txBody>
+                    <a:bodyPr/>
+                    <a:lstStyle/>
+                    <a:p>
+                      <a:pPr indent="0" marL="0">
+                        <a:buNone/>
+                      </a:pPr>
+                      <a:r>
+                        <a:rPr lang="en-US" sz="1000" b="1" dirty="0">
+                          <a:solidFill>
+                            <a:srgbClr val="FFFFFF"/>
+                          </a:solidFill>
+                          <a:latin typeface="Calibri" pitchFamily="34" charset="0"/>
+                          <a:ea typeface="Calibri" pitchFamily="34" charset="-122"/>
+                          <a:cs typeface="Calibri" pitchFamily="34" charset="-120"/>
+                        </a:rPr>
+                        <a:t>Stage notes</a:t>
+                      </a:r>
+                      <a:endParaRPr lang="en-US" sz="1000" dirty="0">
+                        <a:latin typeface="Calibri" charset="0"/>
+                        <a:ea typeface="Calibri" charset="0"/>
+                        <a:cs typeface="Calibri" charset="0"/>
+                      </a:endParaRPr>
+                    </a:p>
+                  </a:txBody>
+                  <a:tcPr marL="91440" marR="91440" marT="45720" marB="45720" anchor="ctr">
+                    <a:lnL w="6350" cap="flat" cmpd="sng" algn="ctr">
+                      <a:solidFill>
+                        <a:srgbClr val="E5E7EB"/>
+                      </a:solidFill>
+                      <a:prstDash val="solid"/>
+                      <a:round/>
+                      <a:headEnd type="none" w="med" len="med"/>
+                      <a:tailEnd type="none" w="med" len="med"/>
+                    </a:lnL>
+                    <a:lnR w="6350" cap="flat" cmpd="sng" algn="ctr">
+                      <a:solidFill>
+                        <a:srgbClr val="E5E7EB"/>
+                      </a:solidFill>
+                      <a:prstDash val="solid"/>
+                      <a:round/>
+                      <a:headEnd type="none" w="med" len="med"/>
+                      <a:tailEnd type="none" w="med" len="med"/>
+                    </a:lnR>
+                    <a:lnT w="6350" cap="flat" cmpd="sng" algn="ctr">
+                      <a:solidFill>
+                        <a:srgbClr val="E5E7EB"/>
+                      </a:solidFill>
+                      <a:prstDash val="solid"/>
+                      <a:round/>
+                      <a:headEnd type="none" w="med" len="med"/>
+                      <a:tailEnd type="none" w="med" len="med"/>
+                    </a:lnT>
+                    <a:lnB w="6350" cap="flat" cmpd="sng" algn="ctr">
+                      <a:solidFill>
+                        <a:srgbClr val="E5E7EB"/>
+                      </a:solidFill>
+                      <a:prstDash val="solid"/>
+                      <a:round/>
+                      <a:headEnd type="none" w="med" len="med"/>
+                      <a:tailEnd type="none" w="med" len="med"/>
+                    </a:lnB>
+                    <a:solidFill>
+                      <a:srgbClr val="1F2937"/>
+                    </a:solidFill>
+                  </a:tcPr>
+                </a:tc>
+              </a:tr>
+              <a:tr h="502920">
+                <a:tc>
+                  <a:txBody>
+                    <a:bodyPr/>
+                    <a:lstStyle/>
+                    <a:p>
+                      <a:pPr indent="0" marL="0">
+                        <a:buNone/>
+                      </a:pPr>
+                      <a:r>
+                        <a:rPr lang="en-US" sz="1000" b="1" dirty="0">
+                          <a:solidFill>
+                            <a:srgbClr val="000000"/>
+                          </a:solidFill>
+                          <a:latin typeface="Calibri" pitchFamily="34" charset="0"/>
+                          <a:ea typeface="Calibri" pitchFamily="34" charset="-122"/>
+                          <a:cs typeface="Calibri" pitchFamily="34" charset="-120"/>
+                        </a:rPr>
+                        <a:t>08-26</a:t>
+                      </a:r>
+                      <a:endParaRPr lang="en-US" sz="1000" dirty="0">
+                        <a:latin typeface="Calibri" charset="0"/>
+                        <a:ea typeface="Calibri" charset="0"/>
+                        <a:cs typeface="Calibri" charset="0"/>
+                      </a:endParaRPr>
+                    </a:p>
+                  </a:txBody>
+                  <a:tcPr marL="91440" marR="91440" marT="45720" marB="45720" anchor="ctr">
+                    <a:lnL w="6350" cap="flat" cmpd="sng" algn="ctr">
+                      <a:solidFill>
+                        <a:srgbClr val="E5E7EB"/>
+                      </a:solidFill>
+                      <a:prstDash val="solid"/>
+                      <a:round/>
+                      <a:headEnd type="none" w="med" len="med"/>
+                      <a:tailEnd type="none" w="med" len="med"/>
+                    </a:lnL>
+                    <a:lnR w="6350" cap="flat" cmpd="sng" algn="ctr">
+                      <a:solidFill>
+                        <a:srgbClr val="E5E7EB"/>
+                      </a:solidFill>
+                      <a:prstDash val="solid"/>
+                      <a:round/>
+                      <a:headEnd type="none" w="med" len="med"/>
+                      <a:tailEnd type="none" w="med" len="med"/>
+                    </a:lnR>
+                    <a:lnT w="6350" cap="flat" cmpd="sng" algn="ctr">
+                      <a:solidFill>
+                        <a:srgbClr val="E5E7EB"/>
+                      </a:solidFill>
+                      <a:prstDash val="solid"/>
+                      <a:round/>
+                      <a:headEnd type="none" w="med" len="med"/>
+                      <a:tailEnd type="none" w="med" len="med"/>
+                    </a:lnT>
+                    <a:lnB w="6350" cap="flat" cmpd="sng" algn="ctr">
+                      <a:solidFill>
+                        <a:srgbClr val="E5E7EB"/>
+                      </a:solidFill>
+                      <a:prstDash val="solid"/>
+                      <a:round/>
+                      <a:headEnd type="none" w="med" len="med"/>
+                      <a:tailEnd type="none" w="med" len="med"/>
+                    </a:lnB>
+                  </a:tcPr>
+                </a:tc>
+                <a:tc>
+                  <a:txBody>
+                    <a:bodyPr/>
+                    <a:lstStyle/>
+                    <a:p>
+                      <a:pPr indent="0" marL="0">
+                        <a:buNone/>
+                      </a:pPr>
+                      <a:r>
+                        <a:rPr lang="en-US" sz="1000" dirty="0">
+                          <a:solidFill>
+                            <a:srgbClr val="000000"/>
+                          </a:solidFill>
+                          <a:latin typeface="Calibri" pitchFamily="34" charset="0"/>
+                          <a:ea typeface="Calibri" pitchFamily="34" charset="-122"/>
+                          <a:cs typeface="Calibri" pitchFamily="34" charset="-120"/>
+                        </a:rPr>
+                        <a:t>5502539375</a:t>
+                      </a:r>
+                      <a:endParaRPr lang="en-US" sz="1000" dirty="0">
+                        <a:latin typeface="Calibri" charset="0"/>
+                        <a:ea typeface="Calibri" charset="0"/>
+                        <a:cs typeface="Calibri" charset="0"/>
+                      </a:endParaRPr>
+                    </a:p>
+                  </a:txBody>
+                  <a:tcPr marL="91440" marR="91440" marT="45720" marB="45720" anchor="ctr">
+                    <a:lnL w="6350" cap="flat" cmpd="sng" algn="ctr">
+                      <a:solidFill>
+                        <a:srgbClr val="E5E7EB"/>
+                      </a:solidFill>
+                      <a:prstDash val="solid"/>
+                      <a:round/>
+                      <a:headEnd type="none" w="med" len="med"/>
+                      <a:tailEnd type="none" w="med" len="med"/>
+                    </a:lnL>
+                    <a:lnR w="6350" cap="flat" cmpd="sng" algn="ctr">
+                      <a:solidFill>
+                        <a:srgbClr val="E5E7EB"/>
+                      </a:solidFill>
+                      <a:prstDash val="solid"/>
+                      <a:round/>
+                      <a:headEnd type="none" w="med" len="med"/>
+                      <a:tailEnd type="none" w="med" len="med"/>
+                    </a:lnR>
+                    <a:lnT w="6350" cap="flat" cmpd="sng" algn="ctr">
+                      <a:solidFill>
+                        <a:srgbClr val="E5E7EB"/>
+                      </a:solidFill>
+                      <a:prstDash val="solid"/>
+                      <a:round/>
+                      <a:headEnd type="none" w="med" len="med"/>
+                      <a:tailEnd type="none" w="med" len="med"/>
+                    </a:lnT>
+                    <a:lnB w="6350" cap="flat" cmpd="sng" algn="ctr">
+                      <a:solidFill>
+                        <a:srgbClr val="E5E7EB"/>
+                      </a:solidFill>
+                      <a:prstDash val="solid"/>
+                      <a:round/>
+                      <a:headEnd type="none" w="med" len="med"/>
+                      <a:tailEnd type="none" w="med" len="med"/>
+                    </a:lnB>
+                  </a:tcPr>
+                </a:tc>
+                <a:tc>
+                  <a:txBody>
+                    <a:bodyPr/>
+                    <a:lstStyle/>
+                    <a:p>
+                      <a:pPr algn="r" indent="0" marL="0">
+                        <a:buNone/>
+                      </a:pPr>
+                      <a:r>
+                        <a:rPr lang="en-US" sz="1000" dirty="0">
+                          <a:solidFill>
+                            <a:srgbClr val="000000"/>
+                          </a:solidFill>
+                          <a:latin typeface="Calibri" pitchFamily="34" charset="0"/>
+                          <a:ea typeface="Calibri" pitchFamily="34" charset="-122"/>
+                          <a:cs typeface="Calibri" pitchFamily="34" charset="-120"/>
+                        </a:rPr>
+                        <a:t>18</a:t>
+                      </a:r>
+                      <a:endParaRPr lang="en-US" sz="1000" dirty="0">
+                        <a:latin typeface="Calibri" charset="0"/>
+                        <a:ea typeface="Calibri" charset="0"/>
+                        <a:cs typeface="Calibri" charset="0"/>
+                      </a:endParaRPr>
+                    </a:p>
+                  </a:txBody>
+                  <a:tcPr marL="91440" marR="91440" marT="45720" marB="45720" anchor="ctr">
+                    <a:lnL w="6350" cap="flat" cmpd="sng" algn="ctr">
+                      <a:solidFill>
+                        <a:srgbClr val="E5E7EB"/>
+                      </a:solidFill>
+                      <a:prstDash val="solid"/>
+                      <a:round/>
+                      <a:headEnd type="none" w="med" len="med"/>
+                      <a:tailEnd type="none" w="med" len="med"/>
+                    </a:lnL>
+                    <a:lnR w="6350" cap="flat" cmpd="sng" algn="ctr">
+                      <a:solidFill>
+                        <a:srgbClr val="E5E7EB"/>
+                      </a:solidFill>
+                      <a:prstDash val="solid"/>
+                      <a:round/>
+                      <a:headEnd type="none" w="med" len="med"/>
+                      <a:tailEnd type="none" w="med" len="med"/>
+                    </a:lnR>
+                    <a:lnT w="6350" cap="flat" cmpd="sng" algn="ctr">
+                      <a:solidFill>
+                        <a:srgbClr val="E5E7EB"/>
+                      </a:solidFill>
+                      <a:prstDash val="solid"/>
+                      <a:round/>
+                      <a:headEnd type="none" w="med" len="med"/>
+                      <a:tailEnd type="none" w="med" len="med"/>
+                    </a:lnT>
+                    <a:lnB w="6350" cap="flat" cmpd="sng" algn="ctr">
+                      <a:solidFill>
+                        <a:srgbClr val="E5E7EB"/>
+                      </a:solidFill>
+                      <a:prstDash val="solid"/>
+                      <a:round/>
+                      <a:headEnd type="none" w="med" len="med"/>
+                      <a:tailEnd type="none" w="med" len="med"/>
+                    </a:lnB>
+                  </a:tcPr>
+                </a:tc>
+                <a:tc>
+                  <a:txBody>
+                    <a:bodyPr/>
+                    <a:lstStyle/>
+                    <a:p>
+                      <a:pPr algn="ctr" indent="0" marL="0">
+                        <a:buNone/>
+                      </a:pPr>
+                      <a:r>
+                        <a:rPr lang="en-US" sz="1000" b="1" dirty="0">
+                          <a:solidFill>
+                            <a:srgbClr val="B45309"/>
+                          </a:solidFill>
+                          <a:latin typeface="Calibri" pitchFamily="34" charset="0"/>
+                          <a:ea typeface="Calibri" pitchFamily="34" charset="-122"/>
+                          <a:cs typeface="Calibri" pitchFamily="34" charset="-120"/>
+                        </a:rPr>
+                        <a:t>9  (50.0%)</a:t>
+                      </a:r>
+                      <a:endParaRPr lang="en-US" sz="1000" dirty="0">
+                        <a:latin typeface="Calibri" charset="0"/>
+                        <a:ea typeface="Calibri" charset="0"/>
+                        <a:cs typeface="Calibri" charset="0"/>
+                      </a:endParaRPr>
+                    </a:p>
+                  </a:txBody>
+                  <a:tcPr marL="91440" marR="91440" marT="45720" marB="45720" anchor="ctr">
+                    <a:lnL w="6350" cap="flat" cmpd="sng" algn="ctr">
+                      <a:solidFill>
+                        <a:srgbClr val="E5E7EB"/>
+                      </a:solidFill>
+                      <a:prstDash val="solid"/>
+                      <a:round/>
+                      <a:headEnd type="none" w="med" len="med"/>
+                      <a:tailEnd type="none" w="med" len="med"/>
+                    </a:lnL>
+                    <a:lnR w="6350" cap="flat" cmpd="sng" algn="ctr">
+                      <a:solidFill>
+                        <a:srgbClr val="E5E7EB"/>
+                      </a:solidFill>
+                      <a:prstDash val="solid"/>
+                      <a:round/>
+                      <a:headEnd type="none" w="med" len="med"/>
+                      <a:tailEnd type="none" w="med" len="med"/>
+                    </a:lnR>
+                    <a:lnT w="6350" cap="flat" cmpd="sng" algn="ctr">
+                      <a:solidFill>
+                        <a:srgbClr val="E5E7EB"/>
+                      </a:solidFill>
+                      <a:prstDash val="solid"/>
+                      <a:round/>
+                      <a:headEnd type="none" w="med" len="med"/>
+                      <a:tailEnd type="none" w="med" len="med"/>
+                    </a:lnT>
+                    <a:lnB w="6350" cap="flat" cmpd="sng" algn="ctr">
+                      <a:solidFill>
+                        <a:srgbClr val="E5E7EB"/>
+                      </a:solidFill>
+                      <a:prstDash val="solid"/>
+                      <a:round/>
+                      <a:headEnd type="none" w="med" len="med"/>
+                      <a:tailEnd type="none" w="med" len="med"/>
+                    </a:lnB>
+                  </a:tcPr>
+                </a:tc>
+                <a:tc>
+                  <a:txBody>
+                    <a:bodyPr/>
+                    <a:lstStyle/>
+                    <a:p>
+                      <a:pPr algn="ctr" indent="0" marL="0">
+                        <a:buNone/>
+                      </a:pPr>
+                      <a:r>
+                        <a:rPr lang="en-US" sz="1000" b="1" dirty="0">
+                          <a:solidFill>
+                            <a:srgbClr val="15803D"/>
+                          </a:solidFill>
+                          <a:latin typeface="Calibri" pitchFamily="34" charset="0"/>
+                          <a:ea typeface="Calibri" pitchFamily="34" charset="-122"/>
+                          <a:cs typeface="Calibri" pitchFamily="34" charset="-120"/>
+                        </a:rPr>
+                        <a:t>8 / 9  (88.9%)</a:t>
+                      </a:r>
+                      <a:endParaRPr lang="en-US" sz="1000" dirty="0">
+                        <a:latin typeface="Calibri" charset="0"/>
+                        <a:ea typeface="Calibri" charset="0"/>
+                        <a:cs typeface="Calibri" charset="0"/>
+                      </a:endParaRPr>
+                    </a:p>
+                  </a:txBody>
+                  <a:tcPr marL="91440" marR="91440" marT="45720" marB="45720" anchor="ctr">
+                    <a:lnL w="6350" cap="flat" cmpd="sng" algn="ctr">
+                      <a:solidFill>
+                        <a:srgbClr val="E5E7EB"/>
+                      </a:solidFill>
+                      <a:prstDash val="solid"/>
+                      <a:round/>
+                      <a:headEnd type="none" w="med" len="med"/>
+                      <a:tailEnd type="none" w="med" len="med"/>
+                    </a:lnL>
+                    <a:lnR w="6350" cap="flat" cmpd="sng" algn="ctr">
+                      <a:solidFill>
+                        <a:srgbClr val="E5E7EB"/>
+                      </a:solidFill>
+                      <a:prstDash val="solid"/>
+                      <a:round/>
+                      <a:headEnd type="none" w="med" len="med"/>
+                      <a:tailEnd type="none" w="med" len="med"/>
+                    </a:lnR>
+                    <a:lnT w="6350" cap="flat" cmpd="sng" algn="ctr">
+                      <a:solidFill>
+                        <a:srgbClr val="E5E7EB"/>
+                      </a:solidFill>
+                      <a:prstDash val="solid"/>
+                      <a:round/>
+                      <a:headEnd type="none" w="med" len="med"/>
+                      <a:tailEnd type="none" w="med" len="med"/>
+                    </a:lnT>
+                    <a:lnB w="6350" cap="flat" cmpd="sng" algn="ctr">
+                      <a:solidFill>
+                        <a:srgbClr val="E5E7EB"/>
+                      </a:solidFill>
+                      <a:prstDash val="solid"/>
+                      <a:round/>
+                      <a:headEnd type="none" w="med" len="med"/>
+                      <a:tailEnd type="none" w="med" len="med"/>
+                    </a:lnB>
+                  </a:tcPr>
+                </a:tc>
+                <a:tc>
+                  <a:txBody>
+                    <a:bodyPr/>
+                    <a:lstStyle/>
+                    <a:p>
+                      <a:pPr algn="ctr" indent="0" marL="0">
+                        <a:buNone/>
+                      </a:pPr>
+                      <a:r>
+                        <a:rPr lang="en-US" sz="1000" b="1" dirty="0">
+                          <a:solidFill>
+                            <a:srgbClr val="B45309"/>
+                          </a:solidFill>
+                          <a:latin typeface="Calibri" pitchFamily="34" charset="0"/>
+                          <a:ea typeface="Calibri" pitchFamily="34" charset="-122"/>
+                          <a:cs typeface="Calibri" pitchFamily="34" charset="-120"/>
+                        </a:rPr>
+                        <a:t>44.4%</a:t>
+                      </a:r>
+                      <a:endParaRPr lang="en-US" sz="1000" dirty="0">
+                        <a:latin typeface="Calibri" charset="0"/>
+                        <a:ea typeface="Calibri" charset="0"/>
+                        <a:cs typeface="Calibri" charset="0"/>
+                      </a:endParaRPr>
+                    </a:p>
+                  </a:txBody>
+                  <a:tcPr marL="91440" marR="91440" marT="45720" marB="45720" anchor="ctr">
+                    <a:lnL w="6350" cap="flat" cmpd="sng" algn="ctr">
+                      <a:solidFill>
+                        <a:srgbClr val="E5E7EB"/>
+                      </a:solidFill>
+                      <a:prstDash val="solid"/>
+                      <a:round/>
+                      <a:headEnd type="none" w="med" len="med"/>
+                      <a:tailEnd type="none" w="med" len="med"/>
+                    </a:lnL>
+                    <a:lnR w="6350" cap="flat" cmpd="sng" algn="ctr">
+                      <a:solidFill>
+                        <a:srgbClr val="E5E7EB"/>
+                      </a:solidFill>
+                      <a:prstDash val="solid"/>
+                      <a:round/>
+                      <a:headEnd type="none" w="med" len="med"/>
+                      <a:tailEnd type="none" w="med" len="med"/>
+                    </a:lnR>
+                    <a:lnT w="6350" cap="flat" cmpd="sng" algn="ctr">
+                      <a:solidFill>
+                        <a:srgbClr val="E5E7EB"/>
+                      </a:solidFill>
+                      <a:prstDash val="solid"/>
+                      <a:round/>
+                      <a:headEnd type="none" w="med" len="med"/>
+                      <a:tailEnd type="none" w="med" len="med"/>
+                    </a:lnT>
+                    <a:lnB w="6350" cap="flat" cmpd="sng" algn="ctr">
+                      <a:solidFill>
+                        <a:srgbClr val="E5E7EB"/>
+                      </a:solidFill>
+                      <a:prstDash val="solid"/>
+                      <a:round/>
+                      <a:headEnd type="none" w="med" len="med"/>
+                      <a:tailEnd type="none" w="med" len="med"/>
+                    </a:lnB>
+                  </a:tcPr>
+                </a:tc>
+                <a:tc>
+                  <a:txBody>
+                    <a:bodyPr/>
+                    <a:lstStyle/>
+                    <a:p>
+                      <a:pPr indent="0" marL="0">
+                        <a:buNone/>
+                      </a:pPr>
+                      <a:r>
+                        <a:rPr lang="en-US" sz="860" dirty="0">
+                          <a:solidFill>
+                            <a:srgbClr val="000000"/>
+                          </a:solidFill>
+                          <a:latin typeface="Calibri" pitchFamily="34" charset="0"/>
+                          <a:ea typeface="Calibri" pitchFamily="34" charset="-122"/>
+                          <a:cs typeface="Calibri" pitchFamily="34" charset="-120"/>
+                        </a:rPr>
+                        <a:t>2 upper-vessel-damage blocks passed &amp; labeled for the usability study; rebound credited to Francisco's team.</a:t>
+                      </a:r>
+                      <a:endParaRPr lang="en-US" sz="860" dirty="0">
+                        <a:latin typeface="Calibri" charset="0"/>
+                        <a:ea typeface="Calibri" charset="0"/>
+                        <a:cs typeface="Calibri" charset="0"/>
+                      </a:endParaRPr>
+                    </a:p>
+                  </a:txBody>
+                  <a:tcPr marL="91440" marR="91440" marT="45720" marB="45720" anchor="ctr">
+                    <a:lnL w="6350" cap="flat" cmpd="sng" algn="ctr">
+                      <a:solidFill>
+                        <a:srgbClr val="E5E7EB"/>
+                      </a:solidFill>
+                      <a:prstDash val="solid"/>
+                      <a:round/>
+                      <a:headEnd type="none" w="med" len="med"/>
+                      <a:tailEnd type="none" w="med" len="med"/>
+                    </a:lnL>
+                    <a:lnR w="6350" cap="flat" cmpd="sng" algn="ctr">
+                      <a:solidFill>
+                        <a:srgbClr val="E5E7EB"/>
+                      </a:solidFill>
+                      <a:prstDash val="solid"/>
+                      <a:round/>
+                      <a:headEnd type="none" w="med" len="med"/>
+                      <a:tailEnd type="none" w="med" len="med"/>
+                    </a:lnR>
+                    <a:lnT w="6350" cap="flat" cmpd="sng" algn="ctr">
+                      <a:solidFill>
+                        <a:srgbClr val="E5E7EB"/>
+                      </a:solidFill>
+                      <a:prstDash val="solid"/>
+                      <a:round/>
+                      <a:headEnd type="none" w="med" len="med"/>
+                      <a:tailEnd type="none" w="med" len="med"/>
+                    </a:lnT>
+                    <a:lnB w="6350" cap="flat" cmpd="sng" algn="ctr">
+                      <a:solidFill>
+                        <a:srgbClr val="E5E7EB"/>
+                      </a:solidFill>
+                      <a:prstDash val="solid"/>
+                      <a:round/>
+                      <a:headEnd type="none" w="med" len="med"/>
+                      <a:tailEnd type="none" w="med" len="med"/>
+                    </a:lnB>
+                  </a:tcPr>
+                </a:tc>
+              </a:tr>
+              <a:tr h="502920">
+                <a:tc>
+                  <a:txBody>
+                    <a:bodyPr/>
+                    <a:lstStyle/>
+                    <a:p>
+                      <a:pPr indent="0" marL="0">
+                        <a:buNone/>
+                      </a:pPr>
+                      <a:r>
+                        <a:rPr lang="en-US" sz="1000" b="1" dirty="0">
+                          <a:solidFill>
+                            <a:srgbClr val="000000"/>
+                          </a:solidFill>
+                          <a:latin typeface="Calibri" pitchFamily="34" charset="0"/>
+                          <a:ea typeface="Calibri" pitchFamily="34" charset="-122"/>
+                          <a:cs typeface="Calibri" pitchFamily="34" charset="-120"/>
+                        </a:rPr>
+                        <a:t>09-09</a:t>
+                      </a:r>
+                      <a:endParaRPr lang="en-US" sz="1000" dirty="0">
+                        <a:latin typeface="Calibri" charset="0"/>
+                        <a:ea typeface="Calibri" charset="0"/>
+                        <a:cs typeface="Calibri" charset="0"/>
+                      </a:endParaRPr>
+                    </a:p>
+                  </a:txBody>
+                  <a:tcPr marL="91440" marR="91440" marT="45720" marB="45720" anchor="ctr">
+                    <a:lnL w="6350" cap="flat" cmpd="sng" algn="ctr">
+                      <a:solidFill>
+                        <a:srgbClr val="E5E7EB"/>
+                      </a:solidFill>
+                      <a:prstDash val="solid"/>
+                      <a:round/>
+                      <a:headEnd type="none" w="med" len="med"/>
+                      <a:tailEnd type="none" w="med" len="med"/>
+                    </a:lnL>
+                    <a:lnR w="6350" cap="flat" cmpd="sng" algn="ctr">
+                      <a:solidFill>
+                        <a:srgbClr val="E5E7EB"/>
+                      </a:solidFill>
+                      <a:prstDash val="solid"/>
+                      <a:round/>
+                      <a:headEnd type="none" w="med" len="med"/>
+                      <a:tailEnd type="none" w="med" len="med"/>
+                    </a:lnR>
+                    <a:lnT w="6350" cap="flat" cmpd="sng" algn="ctr">
+                      <a:solidFill>
+                        <a:srgbClr val="E5E7EB"/>
+                      </a:solidFill>
+                      <a:prstDash val="solid"/>
+                      <a:round/>
+                      <a:headEnd type="none" w="med" len="med"/>
+                      <a:tailEnd type="none" w="med" len="med"/>
+                    </a:lnT>
+                    <a:lnB w="6350" cap="flat" cmpd="sng" algn="ctr">
+                      <a:solidFill>
+                        <a:srgbClr val="E5E7EB"/>
+                      </a:solidFill>
+                      <a:prstDash val="solid"/>
+                      <a:round/>
+                      <a:headEnd type="none" w="med" len="med"/>
+                      <a:tailEnd type="none" w="med" len="med"/>
+                    </a:lnB>
+                  </a:tcPr>
+                </a:tc>
+                <a:tc>
+                  <a:txBody>
+                    <a:bodyPr/>
+                    <a:lstStyle/>
+                    <a:p>
+                      <a:pPr indent="0" marL="0">
+                        <a:buNone/>
+                      </a:pPr>
+                      <a:r>
+                        <a:rPr lang="en-US" sz="1000" dirty="0">
+                          <a:solidFill>
+                            <a:srgbClr val="000000"/>
+                          </a:solidFill>
+                          <a:latin typeface="Calibri" pitchFamily="34" charset="0"/>
+                          <a:ea typeface="Calibri" pitchFamily="34" charset="-122"/>
+                          <a:cs typeface="Calibri" pitchFamily="34" charset="-120"/>
+                        </a:rPr>
+                        <a:t>5502550281</a:t>
+                      </a:r>
+                      <a:endParaRPr lang="en-US" sz="1000" dirty="0">
+                        <a:latin typeface="Calibri" charset="0"/>
+                        <a:ea typeface="Calibri" charset="0"/>
+                        <a:cs typeface="Calibri" charset="0"/>
+                      </a:endParaRPr>
+                    </a:p>
+                  </a:txBody>
+                  <a:tcPr marL="91440" marR="91440" marT="45720" marB="45720" anchor="ctr">
+                    <a:lnL w="6350" cap="flat" cmpd="sng" algn="ctr">
+                      <a:solidFill>
+                        <a:srgbClr val="E5E7EB"/>
+                      </a:solidFill>
+                      <a:prstDash val="solid"/>
+                      <a:round/>
+                      <a:headEnd type="none" w="med" len="med"/>
+                      <a:tailEnd type="none" w="med" len="med"/>
+                    </a:lnL>
+                    <a:lnR w="6350" cap="flat" cmpd="sng" algn="ctr">
+                      <a:solidFill>
+                        <a:srgbClr val="E5E7EB"/>
+                      </a:solidFill>
+                      <a:prstDash val="solid"/>
+                      <a:round/>
+                      <a:headEnd type="none" w="med" len="med"/>
+                      <a:tailEnd type="none" w="med" len="med"/>
+                    </a:lnR>
+                    <a:lnT w="6350" cap="flat" cmpd="sng" algn="ctr">
+                      <a:solidFill>
+                        <a:srgbClr val="E5E7EB"/>
+                      </a:solidFill>
+                      <a:prstDash val="solid"/>
+                      <a:round/>
+                      <a:headEnd type="none" w="med" len="med"/>
+                      <a:tailEnd type="none" w="med" len="med"/>
+                    </a:lnT>
+                    <a:lnB w="6350" cap="flat" cmpd="sng" algn="ctr">
+                      <a:solidFill>
+                        <a:srgbClr val="E5E7EB"/>
+                      </a:solidFill>
+                      <a:prstDash val="solid"/>
+                      <a:round/>
+                      <a:headEnd type="none" w="med" len="med"/>
+                      <a:tailEnd type="none" w="med" len="med"/>
+                    </a:lnB>
+                  </a:tcPr>
+                </a:tc>
+                <a:tc>
+                  <a:txBody>
+                    <a:bodyPr/>
+                    <a:lstStyle/>
+                    <a:p>
+                      <a:pPr algn="r" indent="0" marL="0">
+                        <a:buNone/>
+                      </a:pPr>
+                      <a:r>
+                        <a:rPr lang="en-US" sz="1000" dirty="0">
+                          <a:solidFill>
+                            <a:srgbClr val="000000"/>
+                          </a:solidFill>
+                          <a:latin typeface="Calibri" pitchFamily="34" charset="0"/>
+                          <a:ea typeface="Calibri" pitchFamily="34" charset="-122"/>
+                          <a:cs typeface="Calibri" pitchFamily="34" charset="-120"/>
+                        </a:rPr>
+                        <a:t>19</a:t>
+                      </a:r>
+                      <a:endParaRPr lang="en-US" sz="1000" dirty="0">
+                        <a:latin typeface="Calibri" charset="0"/>
+                        <a:ea typeface="Calibri" charset="0"/>
+                        <a:cs typeface="Calibri" charset="0"/>
+                      </a:endParaRPr>
+                    </a:p>
+                  </a:txBody>
+                  <a:tcPr marL="91440" marR="91440" marT="45720" marB="45720" anchor="ctr">
+                    <a:lnL w="6350" cap="flat" cmpd="sng" algn="ctr">
+                      <a:solidFill>
+                        <a:srgbClr val="E5E7EB"/>
+                      </a:solidFill>
+                      <a:prstDash val="solid"/>
+                      <a:round/>
+                      <a:headEnd type="none" w="med" len="med"/>
+                      <a:tailEnd type="none" w="med" len="med"/>
+                    </a:lnL>
+                    <a:lnR w="6350" cap="flat" cmpd="sng" algn="ctr">
+                      <a:solidFill>
+                        <a:srgbClr val="E5E7EB"/>
+                      </a:solidFill>
+                      <a:prstDash val="solid"/>
+                      <a:round/>
+                      <a:headEnd type="none" w="med" len="med"/>
+                      <a:tailEnd type="none" w="med" len="med"/>
+                    </a:lnR>
+                    <a:lnT w="6350" cap="flat" cmpd="sng" algn="ctr">
+                      <a:solidFill>
+                        <a:srgbClr val="E5E7EB"/>
+                      </a:solidFill>
+                      <a:prstDash val="solid"/>
+                      <a:round/>
+                      <a:headEnd type="none" w="med" len="med"/>
+                      <a:tailEnd type="none" w="med" len="med"/>
+                    </a:lnT>
+                    <a:lnB w="6350" cap="flat" cmpd="sng" algn="ctr">
+                      <a:solidFill>
+                        <a:srgbClr val="E5E7EB"/>
+                      </a:solidFill>
+                      <a:prstDash val="solid"/>
+                      <a:round/>
+                      <a:headEnd type="none" w="med" len="med"/>
+                      <a:tailEnd type="none" w="med" len="med"/>
+                    </a:lnB>
+                  </a:tcPr>
+                </a:tc>
+                <a:tc>
+                  <a:txBody>
+                    <a:bodyPr/>
+                    <a:lstStyle/>
+                    <a:p>
+                      <a:pPr algn="ctr" indent="0" marL="0">
+                        <a:buNone/>
+                      </a:pPr>
+                      <a:r>
+                        <a:rPr lang="en-US" sz="1000" b="1" dirty="0">
+                          <a:solidFill>
+                            <a:srgbClr val="DC2626"/>
+                          </a:solidFill>
+                          <a:latin typeface="Calibri" pitchFamily="34" charset="0"/>
+                          <a:ea typeface="Calibri" pitchFamily="34" charset="-122"/>
+                          <a:cs typeface="Calibri" pitchFamily="34" charset="-120"/>
+                        </a:rPr>
+                        <a:t>2  (10.5%)</a:t>
+                      </a:r>
+                      <a:endParaRPr lang="en-US" sz="1000" dirty="0">
+                        <a:latin typeface="Calibri" charset="0"/>
+                        <a:ea typeface="Calibri" charset="0"/>
+                        <a:cs typeface="Calibri" charset="0"/>
+                      </a:endParaRPr>
+                    </a:p>
+                  </a:txBody>
+                  <a:tcPr marL="91440" marR="91440" marT="45720" marB="45720" anchor="ctr">
+                    <a:lnL w="6350" cap="flat" cmpd="sng" algn="ctr">
+                      <a:solidFill>
+                        <a:srgbClr val="E5E7EB"/>
+                      </a:solidFill>
+                      <a:prstDash val="solid"/>
+                      <a:round/>
+                      <a:headEnd type="none" w="med" len="med"/>
+                      <a:tailEnd type="none" w="med" len="med"/>
+                    </a:lnL>
+                    <a:lnR w="6350" cap="flat" cmpd="sng" algn="ctr">
+                      <a:solidFill>
+                        <a:srgbClr val="E5E7EB"/>
+                      </a:solidFill>
+                      <a:prstDash val="solid"/>
+                      <a:round/>
+                      <a:headEnd type="none" w="med" len="med"/>
+                      <a:tailEnd type="none" w="med" len="med"/>
+                    </a:lnR>
+                    <a:lnT w="6350" cap="flat" cmpd="sng" algn="ctr">
+                      <a:solidFill>
+                        <a:srgbClr val="E5E7EB"/>
+                      </a:solidFill>
+                      <a:prstDash val="solid"/>
+                      <a:round/>
+                      <a:headEnd type="none" w="med" len="med"/>
+                      <a:tailEnd type="none" w="med" len="med"/>
+                    </a:lnT>
+                    <a:lnB w="6350" cap="flat" cmpd="sng" algn="ctr">
+                      <a:solidFill>
+                        <a:srgbClr val="E5E7EB"/>
+                      </a:solidFill>
+                      <a:prstDash val="solid"/>
+                      <a:round/>
+                      <a:headEnd type="none" w="med" len="med"/>
+                      <a:tailEnd type="none" w="med" len="med"/>
+                    </a:lnB>
+                  </a:tcPr>
+                </a:tc>
+                <a:tc>
+                  <a:txBody>
+                    <a:bodyPr/>
+                    <a:lstStyle/>
+                    <a:p>
+                      <a:pPr algn="ctr" indent="0" marL="0">
+                        <a:buNone/>
+                      </a:pPr>
+                      <a:r>
+                        <a:rPr lang="en-US" sz="1000" b="1" dirty="0">
+                          <a:solidFill>
+                            <a:srgbClr val="15803D"/>
+                          </a:solidFill>
+                          <a:latin typeface="Calibri" pitchFamily="34" charset="0"/>
+                          <a:ea typeface="Calibri" pitchFamily="34" charset="-122"/>
+                          <a:cs typeface="Calibri" pitchFamily="34" charset="-120"/>
+                        </a:rPr>
+                        <a:t>2 / 2  (100%)</a:t>
+                      </a:r>
+                      <a:endParaRPr lang="en-US" sz="1000" dirty="0">
+                        <a:latin typeface="Calibri" charset="0"/>
+                        <a:ea typeface="Calibri" charset="0"/>
+                        <a:cs typeface="Calibri" charset="0"/>
+                      </a:endParaRPr>
+                    </a:p>
+                  </a:txBody>
+                  <a:tcPr marL="91440" marR="91440" marT="45720" marB="45720" anchor="ctr">
+                    <a:lnL w="6350" cap="flat" cmpd="sng" algn="ctr">
+                      <a:solidFill>
+                        <a:srgbClr val="E5E7EB"/>
+                      </a:solidFill>
+                      <a:prstDash val="solid"/>
+                      <a:round/>
+                      <a:headEnd type="none" w="med" len="med"/>
+                      <a:tailEnd type="none" w="med" len="med"/>
+                    </a:lnL>
+                    <a:lnR w="6350" cap="flat" cmpd="sng" algn="ctr">
+                      <a:solidFill>
+                        <a:srgbClr val="E5E7EB"/>
+                      </a:solidFill>
+                      <a:prstDash val="solid"/>
+                      <a:round/>
+                      <a:headEnd type="none" w="med" len="med"/>
+                      <a:tailEnd type="none" w="med" len="med"/>
+                    </a:lnR>
+                    <a:lnT w="6350" cap="flat" cmpd="sng" algn="ctr">
+                      <a:solidFill>
+                        <a:srgbClr val="E5E7EB"/>
+                      </a:solidFill>
+                      <a:prstDash val="solid"/>
+                      <a:round/>
+                      <a:headEnd type="none" w="med" len="med"/>
+                      <a:tailEnd type="none" w="med" len="med"/>
+                    </a:lnT>
+                    <a:lnB w="6350" cap="flat" cmpd="sng" algn="ctr">
+                      <a:solidFill>
+                        <a:srgbClr val="E5E7EB"/>
+                      </a:solidFill>
+                      <a:prstDash val="solid"/>
+                      <a:round/>
+                      <a:headEnd type="none" w="med" len="med"/>
+                      <a:tailEnd type="none" w="med" len="med"/>
+                    </a:lnB>
+                  </a:tcPr>
+                </a:tc>
+                <a:tc>
+                  <a:txBody>
+                    <a:bodyPr/>
+                    <a:lstStyle/>
+                    <a:p>
+                      <a:pPr algn="ctr" indent="0" marL="0">
+                        <a:buNone/>
+                      </a:pPr>
+                      <a:r>
+                        <a:rPr lang="en-US" sz="1000" b="1" dirty="0">
+                          <a:solidFill>
+                            <a:srgbClr val="DC2626"/>
+                          </a:solidFill>
+                          <a:latin typeface="Calibri" pitchFamily="34" charset="0"/>
+                          <a:ea typeface="Calibri" pitchFamily="34" charset="-122"/>
+                          <a:cs typeface="Calibri" pitchFamily="34" charset="-120"/>
+                        </a:rPr>
+                        <a:t>10.5%</a:t>
+                      </a:r>
+                      <a:endParaRPr lang="en-US" sz="1000" dirty="0">
+                        <a:latin typeface="Calibri" charset="0"/>
+                        <a:ea typeface="Calibri" charset="0"/>
+                        <a:cs typeface="Calibri" charset="0"/>
+                      </a:endParaRPr>
+                    </a:p>
+                  </a:txBody>
+                  <a:tcPr marL="91440" marR="91440" marT="45720" marB="45720" anchor="ctr">
+                    <a:lnL w="6350" cap="flat" cmpd="sng" algn="ctr">
+                      <a:solidFill>
+                        <a:srgbClr val="E5E7EB"/>
+                      </a:solidFill>
+                      <a:prstDash val="solid"/>
+                      <a:round/>
+                      <a:headEnd type="none" w="med" len="med"/>
+                      <a:tailEnd type="none" w="med" len="med"/>
+                    </a:lnL>
+                    <a:lnR w="6350" cap="flat" cmpd="sng" algn="ctr">
+                      <a:solidFill>
+                        <a:srgbClr val="E5E7EB"/>
+                      </a:solidFill>
+                      <a:prstDash val="solid"/>
+                      <a:round/>
+                      <a:headEnd type="none" w="med" len="med"/>
+                      <a:tailEnd type="none" w="med" len="med"/>
+                    </a:lnR>
+                    <a:lnT w="6350" cap="flat" cmpd="sng" algn="ctr">
+                      <a:solidFill>
+                        <a:srgbClr val="E5E7EB"/>
+                      </a:solidFill>
+                      <a:prstDash val="solid"/>
+                      <a:round/>
+                      <a:headEnd type="none" w="med" len="med"/>
+                      <a:tailEnd type="none" w="med" len="med"/>
+                    </a:lnT>
+                    <a:lnB w="6350" cap="flat" cmpd="sng" algn="ctr">
+                      <a:solidFill>
+                        <a:srgbClr val="E5E7EB"/>
+                      </a:solidFill>
+                      <a:prstDash val="solid"/>
+                      <a:round/>
+                      <a:headEnd type="none" w="med" len="med"/>
+                      <a:tailEnd type="none" w="med" len="med"/>
+                    </a:lnB>
+                  </a:tcPr>
+                </a:tc>
+                <a:tc>
+                  <a:txBody>
+                    <a:bodyPr/>
+                    <a:lstStyle/>
+                    <a:p>
+                      <a:pPr indent="0" marL="0">
+                        <a:buNone/>
+                      </a:pPr>
+                      <a:r>
+                        <a:rPr lang="en-US" sz="860" dirty="0">
+                          <a:solidFill>
+                            <a:srgbClr val="000000"/>
+                          </a:solidFill>
+                          <a:latin typeface="Calibri" pitchFamily="34" charset="0"/>
+                          <a:ea typeface="Calibri" pitchFamily="34" charset="-122"/>
+                          <a:cs typeface="Calibri" pitchFamily="34" charset="-120"/>
+                        </a:rPr>
+                        <a:t>Fails: 8 left-lung lacerations + 9 missing trachea (SH harvesting tracheas for another buyer); one passed unit labeled for a high head-vessel laceration.</a:t>
+                      </a:r>
+                      <a:endParaRPr lang="en-US" sz="860" dirty="0">
+                        <a:latin typeface="Calibri" charset="0"/>
+                        <a:ea typeface="Calibri" charset="0"/>
+                        <a:cs typeface="Calibri" charset="0"/>
+                      </a:endParaRPr>
+                    </a:p>
+                  </a:txBody>
+                  <a:tcPr marL="91440" marR="91440" marT="45720" marB="45720" anchor="ctr">
+                    <a:lnL w="6350" cap="flat" cmpd="sng" algn="ctr">
+                      <a:solidFill>
+                        <a:srgbClr val="E5E7EB"/>
+                      </a:solidFill>
+                      <a:prstDash val="solid"/>
+                      <a:round/>
+                      <a:headEnd type="none" w="med" len="med"/>
+                      <a:tailEnd type="none" w="med" len="med"/>
+                    </a:lnL>
+                    <a:lnR w="6350" cap="flat" cmpd="sng" algn="ctr">
+                      <a:solidFill>
+                        <a:srgbClr val="E5E7EB"/>
+                      </a:solidFill>
+                      <a:prstDash val="solid"/>
+                      <a:round/>
+                      <a:headEnd type="none" w="med" len="med"/>
+                      <a:tailEnd type="none" w="med" len="med"/>
+                    </a:lnR>
+                    <a:lnT w="6350" cap="flat" cmpd="sng" algn="ctr">
+                      <a:solidFill>
+                        <a:srgbClr val="E5E7EB"/>
+                      </a:solidFill>
+                      <a:prstDash val="solid"/>
+                      <a:round/>
+                      <a:headEnd type="none" w="med" len="med"/>
+                      <a:tailEnd type="none" w="med" len="med"/>
+                    </a:lnT>
+                    <a:lnB w="6350" cap="flat" cmpd="sng" algn="ctr">
+                      <a:solidFill>
+                        <a:srgbClr val="E5E7EB"/>
+                      </a:solidFill>
+                      <a:prstDash val="solid"/>
+                      <a:round/>
+                      <a:headEnd type="none" w="med" len="med"/>
+                      <a:tailEnd type="none" w="med" len="med"/>
+                    </a:lnB>
+                  </a:tcPr>
+                </a:tc>
+              </a:tr>
+            </a:tbl>
+          </a:graphicData>
+        </a:graphic>
+      </p:graphicFrame>
+      <p:sp>
+        <p:nvSpPr>
+          <p:cNvPr id="6" name="Shape 3"/>
+          <p:cNvSpPr/>
+          <p:nvPr/>
+        </p:nvSpPr>
+        <p:spPr>
+          <a:xfrm>
+            <a:off x="502920" y="3749040"/>
+            <a:ext cx="5486400" cy="2148840"/>
+          </a:xfrm>
+          <a:prstGeom prst="roundRect">
+            <a:avLst>
+              <a:gd name="adj" fmla="val 2553"/>
+            </a:avLst>
+          </a:prstGeom>
+          <a:solidFill>
+            <a:srgbClr val="F3F4F6"/>
+          </a:solidFill>
+          <a:ln w="9525">
+            <a:solidFill>
+              <a:srgbClr val="E5E7EB"/>
+            </a:solidFill>
+            <a:prstDash val="solid"/>
+          </a:ln>
+        </p:spPr>
+      </p:sp>
+      <p:sp>
+        <p:nvSpPr>
+          <p:cNvPr id="7" name="Text 4"/>
+          <p:cNvSpPr/>
+          <p:nvPr/>
+        </p:nvSpPr>
+        <p:spPr>
+          <a:xfrm>
+            <a:off x="667512" y="3840480"/>
+            <a:ext cx="5120640" cy="237744"/>
+          </a:xfrm>
+          <a:prstGeom prst="rect">
+            <a:avLst/>
+          </a:prstGeom>
+          <a:noFill/>
+          <a:ln/>
+        </p:spPr>
+        <p:txBody>
+          <a:bodyPr wrap="square" lIns="0" tIns="0" rIns="0" bIns="0" rtlCol="0" anchor="ctr"/>
+          <a:lstStyle/>
+          <a:p>
+            <a:pPr indent="0" marL="0">
+              <a:buNone/>
+            </a:pPr>
+            <a:r>
+              <a:rPr lang="en-US" sz="1100" b="1" dirty="0">
+                <a:solidFill>
+                  <a:srgbClr val="1F2937"/>
+                </a:solidFill>
+                <a:latin typeface="Calibri" pitchFamily="34" charset="0"/>
+                <a:ea typeface="Calibri" pitchFamily="34" charset="-122"/>
+                <a:cs typeface="Calibri" pitchFamily="34" charset="-120"/>
+              </a:rPr>
+              <a:t>Definitions</a:t>
+            </a:r>
+            <a:endParaRPr lang="en-US" sz="1100" dirty="0"/>
+          </a:p>
+        </p:txBody>
+      </p:sp>
+      <p:sp>
+        <p:nvSpPr>
+          <p:cNvPr id="8" name="Text 5"/>
+          <p:cNvSpPr/>
+          <p:nvPr/>
+        </p:nvSpPr>
+        <p:spPr>
+          <a:xfrm>
+            <a:off x="694944" y="4114800"/>
+            <a:ext cx="5120640" cy="1691640"/>
+          </a:xfrm>
+          <a:prstGeom prst="rect">
+            <a:avLst/>
+          </a:prstGeom>
+          <a:noFill/>
+          <a:ln/>
+        </p:spPr>
+        <p:txBody>
+          <a:bodyPr wrap="square" lIns="0" tIns="0" rIns="0" bIns="0" rtlCol="0" anchor="ctr"/>
+          <a:lstStyle/>
+          <a:p>
+            <a:pPr marL="342900" indent="-342900">
+              <a:spcAft>
+                <a:spcPts val="400"/>
+              </a:spcAft>
+              <a:buSzPct val="100000"/>
+              <a:buChar char="➢"/>
+            </a:pPr>
+            <a:r>
+              <a:rPr lang="en-US" sz="950" dirty="0">
+                <a:solidFill>
+                  <a:srgbClr val="1F2937"/>
+                </a:solidFill>
+                <a:latin typeface="Calibri" pitchFamily="34" charset="0"/>
+                <a:ea typeface="Calibri" pitchFamily="34" charset="-122"/>
+                <a:cs typeface="Calibri" pitchFamily="34" charset="-120"/>
+              </a:rPr>
+              <a:t>SH-tech yield — blocks the slaughterhouse's own tech passed ÷ received (the sheet's "FPY for SH").</a:t>
+            </a:r>
+            <a:endParaRPr lang="en-US" sz="950" dirty="0"/>
+          </a:p>
+          <a:p>
+            <a:pPr marL="342900" indent="-342900">
+              <a:spcAft>
+                <a:spcPts val="400"/>
+              </a:spcAft>
+              <a:buSzPct val="100000"/>
+              <a:buChar char="➢"/>
+            </a:pPr>
+            <a:r>
+              <a:rPr lang="en-US" sz="950" dirty="0">
+                <a:solidFill>
+                  <a:srgbClr val="1F2937"/>
+                </a:solidFill>
+                <a:latin typeface="Calibri" pitchFamily="34" charset="0"/>
+                <a:ea typeface="Calibri" pitchFamily="34" charset="-122"/>
+                <a:cs typeface="Calibri" pitchFamily="34" charset="-120"/>
+              </a:rPr>
+              <a:t>QC accept of SH-passed — of the SH-tech-passed blocks, how many our QC tech confirmed (the sheet's "FPY for SH Tech").</a:t>
+            </a:r>
+            <a:endParaRPr lang="en-US" sz="950" dirty="0"/>
+          </a:p>
+          <a:p>
+            <a:pPr marL="342900" indent="-342900">
+              <a:spcAft>
+                <a:spcPts val="400"/>
+              </a:spcAft>
+              <a:buSzPct val="100000"/>
+              <a:buChar char="➢"/>
+            </a:pPr>
+            <a:r>
+              <a:rPr lang="en-US" sz="950" dirty="0">
+                <a:solidFill>
+                  <a:srgbClr val="1F2937"/>
+                </a:solidFill>
+                <a:latin typeface="Calibri" pitchFamily="34" charset="0"/>
+                <a:ea typeface="Calibri" pitchFamily="34" charset="-122"/>
+                <a:cs typeface="Calibri" pitchFamily="34" charset="-120"/>
+              </a:rPr>
+              <a:t>Final FPY — QC final pass ÷ received; this is the number in the log, dashboards and monthly tabs. Visits before 08/26 used the standard single-stage tally.</a:t>
+            </a:r>
+            <a:endParaRPr lang="en-US" sz="950" dirty="0"/>
+          </a:p>
+        </p:txBody>
+      </p:sp>
+      <p:sp>
+        <p:nvSpPr>
+          <p:cNvPr id="9" name="Shape 6"/>
+          <p:cNvSpPr/>
+          <p:nvPr/>
+        </p:nvSpPr>
+        <p:spPr>
+          <a:xfrm>
+            <a:off x="6199632" y="3749040"/>
+            <a:ext cx="5486400" cy="2148840"/>
+          </a:xfrm>
+          <a:prstGeom prst="roundRect">
+            <a:avLst>
+              <a:gd name="adj" fmla="val 2553"/>
+            </a:avLst>
+          </a:prstGeom>
+          <a:solidFill>
+            <a:srgbClr val="E0F2F7"/>
+          </a:solidFill>
+          <a:ln/>
+        </p:spPr>
+      </p:sp>
+      <p:sp>
+        <p:nvSpPr>
+          <p:cNvPr id="10" name="Text 7"/>
+          <p:cNvSpPr/>
+          <p:nvPr/>
+        </p:nvSpPr>
+        <p:spPr>
+          <a:xfrm>
+            <a:off x="6364224" y="3840480"/>
+            <a:ext cx="5120640" cy="237744"/>
+          </a:xfrm>
+          <a:prstGeom prst="rect">
+            <a:avLst/>
+          </a:prstGeom>
+          <a:noFill/>
+          <a:ln/>
+        </p:spPr>
+        <p:txBody>
+          <a:bodyPr wrap="square" lIns="0" tIns="0" rIns="0" bIns="0" rtlCol="0" anchor="ctr"/>
+          <a:lstStyle/>
+          <a:p>
+            <a:pPr indent="0" marL="0">
+              <a:buNone/>
+            </a:pPr>
+            <a:r>
+              <a:rPr lang="en-US" sz="1100" b="1" dirty="0">
+                <a:solidFill>
+                  <a:srgbClr val="0E7490"/>
+                </a:solidFill>
+                <a:latin typeface="Calibri" pitchFamily="34" charset="0"/>
+                <a:ea typeface="Calibri" pitchFamily="34" charset="-122"/>
+                <a:cs typeface="Calibri" pitchFamily="34" charset="-120"/>
+              </a:rPr>
+              <a:t>What the stage split shows</a:t>
+            </a:r>
+            <a:endParaRPr lang="en-US" sz="1100" dirty="0"/>
+          </a:p>
+        </p:txBody>
+      </p:sp>
+      <p:sp>
+        <p:nvSpPr>
+          <p:cNvPr id="11" name="Text 8"/>
+          <p:cNvSpPr/>
+          <p:nvPr/>
+        </p:nvSpPr>
+        <p:spPr>
+          <a:xfrm>
+            <a:off x="6391656" y="4114800"/>
+            <a:ext cx="5120640" cy="1691640"/>
+          </a:xfrm>
+          <a:prstGeom prst="rect">
+            <a:avLst/>
+          </a:prstGeom>
+          <a:noFill/>
+          <a:ln/>
+        </p:spPr>
+        <p:txBody>
+          <a:bodyPr wrap="square" lIns="0" tIns="0" rIns="0" bIns="0" rtlCol="0" anchor="ctr"/>
+          <a:lstStyle/>
+          <a:p>
+            <a:pPr marL="342900" indent="-342900">
+              <a:spcAft>
+                <a:spcPts val="400"/>
+              </a:spcAft>
+              <a:buSzPct val="100000"/>
+              <a:buChar char="➢"/>
+            </a:pPr>
+            <a:r>
+              <a:rPr lang="en-US" sz="950" dirty="0">
+                <a:solidFill>
+                  <a:srgbClr val="1F2937"/>
+                </a:solidFill>
+                <a:latin typeface="Calibri" pitchFamily="34" charset="0"/>
+                <a:ea typeface="Calibri" pitchFamily="34" charset="-122"/>
+                <a:cs typeface="Calibri" pitchFamily="34" charset="-120"/>
+              </a:rPr>
+              <a:t>The SH's own screen now quantifies harvesting quality: 50% (8/26) → 10.5% (9/9) — their numbers, not just ours, make the harvesting-side case.</a:t>
+            </a:r>
+            <a:endParaRPr lang="en-US" sz="950" dirty="0"/>
+          </a:p>
+          <a:p>
+            <a:pPr marL="342900" indent="-342900">
+              <a:spcAft>
+                <a:spcPts val="400"/>
+              </a:spcAft>
+              <a:buSzPct val="100000"/>
+              <a:buChar char="➢"/>
+            </a:pPr>
+            <a:r>
+              <a:rPr lang="en-US" sz="950" dirty="0">
+                <a:solidFill>
+                  <a:srgbClr val="1F2937"/>
+                </a:solidFill>
+                <a:latin typeface="Calibri" pitchFamily="34" charset="0"/>
+                <a:ea typeface="Calibri" pitchFamily="34" charset="-122"/>
+                <a:cs typeface="Calibri" pitchFamily="34" charset="-120"/>
+              </a:rPr>
+              <a:t>QC accepted 88.9–100% of SH-tech-passed blocks — Jordan's judgement aligns with our spec. The losses happen at harvest, not in the screening.</a:t>
+            </a:r>
+            <a:endParaRPr lang="en-US" sz="950" dirty="0"/>
+          </a:p>
+          <a:p>
+            <a:pPr marL="342900" indent="-342900">
+              <a:spcAft>
+                <a:spcPts val="400"/>
+              </a:spcAft>
+              <a:buSzPct val="100000"/>
+              <a:buChar char="➢"/>
+            </a:pPr>
+            <a:r>
+              <a:rPr lang="en-US" sz="950" dirty="0">
+                <a:solidFill>
+                  <a:srgbClr val="1F2937"/>
+                </a:solidFill>
+                <a:latin typeface="Calibri" pitchFamily="34" charset="0"/>
+                <a:ea typeface="Calibri" pitchFamily="34" charset="-122"/>
+                <a:cs typeface="Calibri" pitchFamily="34" charset="-120"/>
+              </a:rPr>
+              <a:t>Watch: SH-tech yield as a leading indicator, and the missing-trachea conflict (tracheas sold to another buyer) as the newest driver.</a:t>
+            </a:r>
+            <a:endParaRPr lang="en-US" sz="950" dirty="0"/>
+          </a:p>
+        </p:txBody>
+      </p:sp>
+      <p:sp>
+        <p:nvSpPr>
+          <p:cNvPr id="12" name="Text 9"/>
+          <p:cNvSpPr/>
+          <p:nvPr/>
+        </p:nvSpPr>
+        <p:spPr>
+          <a:xfrm>
+            <a:off x="502920" y="6510528"/>
+            <a:ext cx="8686800" cy="228600"/>
+          </a:xfrm>
+          <a:prstGeom prst="rect">
+            <a:avLst/>
+          </a:prstGeom>
+          <a:noFill/>
+          <a:ln/>
+        </p:spPr>
+        <p:txBody>
+          <a:bodyPr wrap="square" lIns="0" tIns="0" rIns="0" bIns="0" rtlCol="0" anchor="ctr"/>
+          <a:lstStyle/>
+          <a:p>
+            <a:pPr indent="0" marL="0">
+              <a:buNone/>
+            </a:pPr>
+            <a:r>
+              <a:rPr lang="en-US" sz="850" i="1" dirty="0">
+                <a:solidFill>
+                  <a:srgbClr val="6B7280"/>
+                </a:solidFill>
+                <a:latin typeface="Calibri" pitchFamily="34" charset="0"/>
+                <a:ea typeface="Calibri" pitchFamily="34" charset="-122"/>
+                <a:cs typeface="Calibri" pitchFamily="34" charset="-120"/>
+              </a:rPr>
+              <a:t>Source: SH_IQC_Inspections.xlsx — SH-floor IQC &amp; ATM (SAP) receipt data, extract 09/16/2026</a:t>
+            </a:r>
+            <a:endParaRPr lang="en-US" sz="850" dirty="0"/>
+          </a:p>
+        </p:txBody>
+      </p:sp>
+      <p:sp>
+        <p:nvSpPr>
+          <p:cNvPr id="13" name="Text 10"/>
+          <p:cNvSpPr/>
+          <p:nvPr/>
+        </p:nvSpPr>
+        <p:spPr>
+          <a:xfrm>
+            <a:off x="11430000" y="6510528"/>
+            <a:ext cx="365760" cy="228600"/>
+          </a:xfrm>
+          <a:prstGeom prst="rect">
+            <a:avLst/>
+          </a:prstGeom>
+          <a:noFill/>
+          <a:ln/>
+        </p:spPr>
+        <p:txBody>
+          <a:bodyPr wrap="square" lIns="0" tIns="0" rIns="0" bIns="0" rtlCol="0" anchor="ctr"/>
+          <a:lstStyle/>
+          <a:p>
+            <a:pPr algn="r" indent="0" marL="0">
+              <a:buNone/>
+            </a:pPr>
+            <a:r>
+              <a:rPr lang="en-US" sz="900" dirty="0">
+                <a:solidFill>
+                  <a:srgbClr val="6B7280"/>
+                </a:solidFill>
+                <a:latin typeface="Calibri" pitchFamily="34" charset="0"/>
+                <a:ea typeface="Calibri" pitchFamily="34" charset="-122"/>
+                <a:cs typeface="Calibri" pitchFamily="34" charset="-120"/>
+              </a:rPr>
+              <a:t>4</a:t>
+            </a:r>
+            <a:endParaRPr lang="en-US" sz="900" dirty="0"/>
+          </a:p>
+        </p:txBody>
+      </p:sp>
+    </p:spTree>
+  </p:cSld>
+  <p:clrMapOvr>
+    <a:masterClrMapping/>
+  </p:clrMapOvr>
+</p:sld>
+</file>
+
 <file path=ppt/theme/theme1.xml><?xml version="1.0" encoding="utf-8"?>
 <a:theme xmlns:a="http://schemas.openxmlformats.org/drawingml/2006/main" name="Office Theme">
   <a:themeElements>

</xml_diff>

<commit_message>
QDR deck: corrected Nahunta QC-stage numbers, named categories, matched-batch ATM scope
- Slide 1: Aug thoracic now 66/16/50 (24.2% QC FPY); Nahunta 8/12 pelvic line
  labeled UNVERIFIED and excluded from defect cards; Sept two-inspection bullet.
- Slide 2: two-stage lots show QC-stage I/P/F (9/8/1 and 2/2/0) with harvest
  rejects excluded and footnoted.
- Slide 3: ATM side restricted to SH-inspected (matched) batches, 08/01-09/16
  window; no unspecified buckets — exclusions called out explicitly on-slide.
- Slide 4: reframed as Nahunta's two-inspections-per-visit process (before/after
  harvest) with the log convention spelled out.

Co-Authored-By: Claude Fable 5 <noreply@anthropic.com>
Claude-Session: https://claude.ai/code/session_014UGcEfvuC9NvQ5rauRTTbR
</commit_message>
<xml_diff>
--- a/QC inspections suppliers/QDR_Slides_AugSep2026.pptx
+++ b/QC inspections suppliers/QDR_Slides_AugSep2026.pptx
@@ -274,10 +274,10 @@
                   <c:v>0.8095</c:v>
                 </c:pt>
                 <c:pt idx="14">
-                  <c:v>0.5556</c:v>
+                  <c:v>0.1111</c:v>
                 </c:pt>
                 <c:pt idx="15">
-                  <c:v>0.8947</c:v>
+                  <c:v>0</c:v>
                 </c:pt>
               </c:numCache>
             </c:numRef>
@@ -631,7 +631,7 @@
               <c:strCache>
                 <c:ptCount val="1"/>
                 <c:pt idx="0">
-                  <c:v>SH issues — 22 total</c:v>
+                  <c:v>SH issues — 10 verified</c:v>
                 </c:pt>
               </c:strCache>
             </c:strRef>
@@ -669,30 +669,21 @@
           </c:dLbls>
           <c:cat>
             <c:multiLvlStrRef>
-              <c:f>Sheet1!$A$2:$A$8</c:f>
+              <c:f>Sheet1!$A$2:$A$5</c:f>
               <c:multiLvlStrCache>
-                <c:ptCount val="7"/>
+                <c:ptCount val="4"/>
                 <c:lvl>
                   <c:pt idx="0">
-                    <c:v>Ureter damage</c:v>
+                    <c:v>Critical-area laceration</c:v>
                   </c:pt>
                   <c:pt idx="1">
-                    <c:v>Short block / mesentery length</c:v>
+                    <c:v>Bowel damage / separation</c:v>
                   </c:pt>
                   <c:pt idx="2">
-                    <c:v>Critical-area laceration</c:v>
+                    <c:v>Membrane damage</c:v>
                   </c:pt>
                   <c:pt idx="3">
-                    <c:v>Bowel damage / separation</c:v>
-                  </c:pt>
-                  <c:pt idx="4">
-                    <c:v>Membrane damage</c:v>
-                  </c:pt>
-                  <c:pt idx="5">
                     <c:v>Urethra / bladder damage</c:v>
-                  </c:pt>
-                  <c:pt idx="6">
-                    <c:v>Other / unspecified (8/12 provisional)</c:v>
                   </c:pt>
                 </c:lvl>
               </c:multiLvlStrCache>
@@ -700,30 +691,21 @@
           </c:cat>
           <c:val>
             <c:numRef>
-              <c:f>Sheet1!$B$2:$B$8</c:f>
+              <c:f>Sheet1!$B$2:$B$5</c:f>
               <c:numCache>
                 <c:formatCode>General</c:formatCode>
-                <c:ptCount val="7"/>
+                <c:ptCount val="4"/>
                 <c:pt idx="0">
-                  <c:v>0</c:v>
+                  <c:v>1</c:v>
                 </c:pt>
                 <c:pt idx="1">
-                  <c:v>0</c:v>
+                  <c:v>3</c:v>
                 </c:pt>
                 <c:pt idx="2">
-                  <c:v>1</c:v>
+                  <c:v>3</c:v>
                 </c:pt>
                 <c:pt idx="3">
                   <c:v>3</c:v>
-                </c:pt>
-                <c:pt idx="4">
-                  <c:v>3</c:v>
-                </c:pt>
-                <c:pt idx="5">
-                  <c:v>3</c:v>
-                </c:pt>
-                <c:pt idx="6">
-                  <c:v>12</c:v>
                 </c:pt>
               </c:numCache>
             </c:numRef>
@@ -884,7 +866,7 @@
               <c:strCache>
                 <c:ptCount val="1"/>
                 <c:pt idx="0">
-                  <c:v>ATM scrap — 63 total · 57 quality-only</c:v>
+                  <c:v>ATM scrap — 40 units · matched batches, all quality</c:v>
                 </c:pt>
               </c:strCache>
             </c:strRef>
@@ -922,35 +904,23 @@
           </c:dLbls>
           <c:cat>
             <c:multiLvlStrRef>
-              <c:f>Sheet1!$A$2:$A$10</c:f>
+              <c:f>Sheet1!$A$2:$A$6</c:f>
               <c:multiLvlStrCache>
-                <c:ptCount val="9"/>
+                <c:ptCount val="5"/>
                 <c:lvl>
                   <c:pt idx="0">
-                    <c:v>1220 · Destructive Testing (eng/R&amp;D)*</c:v>
+                    <c:v>9978 · Damage to Suspensory</c:v>
                   </c:pt>
                   <c:pt idx="1">
-                    <c:v>9983 · Incorrect Dimensions</c:v>
+                    <c:v>9988 · Exposed Urethra</c:v>
                   </c:pt>
                   <c:pt idx="2">
-                    <c:v>9973 · Out of Spec</c:v>
+                    <c:v>9987 · Blood Clots</c:v>
                   </c:pt>
                   <c:pt idx="3">
-                    <c:v>9978 · Damage to Suspensory</c:v>
+                    <c:v>9986 · Bladder Length</c:v>
                   </c:pt>
                   <c:pt idx="4">
-                    <c:v>9988 · Exposed Urethra</c:v>
-                  </c:pt>
-                  <c:pt idx="5">
-                    <c:v>9994 · Line Clearance*</c:v>
-                  </c:pt>
-                  <c:pt idx="6">
-                    <c:v>9987 · Blood Clots</c:v>
-                  </c:pt>
-                  <c:pt idx="7">
-                    <c:v>9986 · Bladder Length</c:v>
-                  </c:pt>
-                  <c:pt idx="8">
                     <c:v>9972 · Laceration/Cut</c:v>
                   </c:pt>
                 </c:lvl>
@@ -959,36 +929,24 @@
           </c:cat>
           <c:val>
             <c:numRef>
-              <c:f>Sheet1!$B$2:$B$10</c:f>
+              <c:f>Sheet1!$B$2:$B$6</c:f>
               <c:numCache>
                 <c:formatCode>General</c:formatCode>
-                <c:ptCount val="9"/>
+                <c:ptCount val="5"/>
                 <c:pt idx="0">
-                  <c:v>0</c:v>
+                  <c:v>1</c:v>
                 </c:pt>
                 <c:pt idx="1">
-                  <c:v>0</c:v>
+                  <c:v>3</c:v>
                 </c:pt>
                 <c:pt idx="2">
-                  <c:v>0</c:v>
+                  <c:v>4</c:v>
                 </c:pt>
                 <c:pt idx="3">
-                  <c:v>1</c:v>
+                  <c:v>11</c:v>
                 </c:pt>
                 <c:pt idx="4">
-                  <c:v>5</c:v>
-                </c:pt>
-                <c:pt idx="5">
-                  <c:v>6</c:v>
-                </c:pt>
-                <c:pt idx="6">
-                  <c:v>9</c:v>
-                </c:pt>
-                <c:pt idx="7">
-                  <c:v>12</c:v>
-                </c:pt>
-                <c:pt idx="8">
-                  <c:v>30</c:v>
+                  <c:v>21</c:v>
                 </c:pt>
               </c:numCache>
             </c:numRef>
@@ -1149,7 +1107,7 @@
               <c:strCache>
                 <c:ptCount val="1"/>
                 <c:pt idx="0">
-                  <c:v>SH issues — 77 total</c:v>
+                  <c:v>SH issues — 51 tags on 50 QC fails</c:v>
                 </c:pt>
               </c:strCache>
             </c:strRef>
@@ -1187,20 +1145,17 @@
           </c:dLbls>
           <c:cat>
             <c:multiLvlStrRef>
-              <c:f>Sheet1!$A$2:$A$5</c:f>
+              <c:f>Sheet1!$A$2:$A$4</c:f>
               <c:multiLvlStrCache>
-                <c:ptCount val="4"/>
+                <c:ptCount val="3"/>
                 <c:lvl>
                   <c:pt idx="0">
-                    <c:v>Other / unspecified</c:v>
+                    <c:v>Undocumented / not itemized</c:v>
                   </c:pt>
                   <c:pt idx="1">
-                    <c:v>Missing anatomy (trachea)</c:v>
+                    <c:v>Heart damage</c:v>
                   </c:pt>
                   <c:pt idx="2">
-                    <c:v>Heart damage</c:v>
-                  </c:pt>
-                  <c:pt idx="3">
                     <c:v>Lung laceration</c:v>
                   </c:pt>
                 </c:lvl>
@@ -1209,21 +1164,18 @@
           </c:cat>
           <c:val>
             <c:numRef>
-              <c:f>Sheet1!$B$2:$B$5</c:f>
+              <c:f>Sheet1!$B$2:$B$4</c:f>
               <c:numCache>
                 <c:formatCode>General</c:formatCode>
-                <c:ptCount val="4"/>
+                <c:ptCount val="3"/>
                 <c:pt idx="0">
-                  <c:v>0</c:v>
+                  <c:v>1</c:v>
                 </c:pt>
                 <c:pt idx="1">
-                  <c:v>9</c:v>
+                  <c:v>19</c:v>
                 </c:pt>
                 <c:pt idx="2">
-                  <c:v>21</c:v>
-                </c:pt>
-                <c:pt idx="3">
-                  <c:v>47</c:v>
+                  <c:v>31</c:v>
                 </c:pt>
               </c:numCache>
             </c:numRef>
@@ -1384,7 +1336,7 @@
               <c:strCache>
                 <c:ptCount val="1"/>
                 <c:pt idx="0">
-                  <c:v>ATM scrap — 153 total · 153 quality-only</c:v>
+                  <c:v>ATM scrap — 24 units · matched batches, all quality</c:v>
                 </c:pt>
               </c:strCache>
             </c:strRef>
@@ -1422,26 +1374,11 @@
           </c:dLbls>
           <c:cat>
             <c:multiLvlStrRef>
-              <c:f>Sheet1!$A$2:$A$7</c:f>
+              <c:f>Sheet1!$A$2:$A$2</c:f>
               <c:multiLvlStrCache>
-                <c:ptCount val="6"/>
+                <c:ptCount val="1"/>
                 <c:lvl>
                   <c:pt idx="0">
-                    <c:v>1201 · Tech Performance</c:v>
-                  </c:pt>
-                  <c:pt idx="1">
-                    <c:v>9973 · Out of Spec</c:v>
-                  </c:pt>
-                  <c:pt idx="2">
-                    <c:v>7 · Others</c:v>
-                  </c:pt>
-                  <c:pt idx="3">
-                    <c:v>9985 · Tech Damaged</c:v>
-                  </c:pt>
-                  <c:pt idx="4">
-                    <c:v>1220 · Destructive Testing (eng/R&amp;D)*</c:v>
-                  </c:pt>
-                  <c:pt idx="5">
                     <c:v>9972 · Laceration/Cut</c:v>
                   </c:pt>
                 </c:lvl>
@@ -1450,27 +1387,12 @@
           </c:cat>
           <c:val>
             <c:numRef>
-              <c:f>Sheet1!$B$2:$B$7</c:f>
+              <c:f>Sheet1!$B$2:$B$2</c:f>
               <c:numCache>
                 <c:formatCode>General</c:formatCode>
-                <c:ptCount val="6"/>
+                <c:ptCount val="1"/>
                 <c:pt idx="0">
-                  <c:v>0</c:v>
-                </c:pt>
-                <c:pt idx="1">
-                  <c:v>0</c:v>
-                </c:pt>
-                <c:pt idx="2">
-                  <c:v>0</c:v>
-                </c:pt>
-                <c:pt idx="3">
-                  <c:v>0</c:v>
-                </c:pt>
-                <c:pt idx="4">
-                  <c:v>0</c:v>
-                </c:pt>
-                <c:pt idx="5">
-                  <c:v>153</c:v>
+                  <c:v>24</c:v>
                 </c:pt>
               </c:numCache>
             </c:numRef>
@@ -2651,7 +2573,7 @@
         <p:spPr>
           <a:xfrm>
             <a:off x="502920" y="256032"/>
-            <a:ext cx="8686800" cy="256032"/>
+            <a:ext cx="10515600" cy="256032"/>
           </a:xfrm>
           <a:prstGeom prst="rect">
             <a:avLst/>
@@ -3632,7 +3554,7 @@
                         <a:buNone/>
                       </a:pPr>
                       <a:r>
-                        <a:rPr lang="en-US" sz="1100" dirty="0">
+                        <a:rPr lang="en-US" sz="950" dirty="0">
                           <a:solidFill>
                             <a:srgbClr val="000000"/>
                           </a:solidFill>
@@ -3642,7 +3564,7 @@
                         </a:rPr>
                         <a:t>Urethra / bladder damage (3)</a:t>
                       </a:r>
-                      <a:endParaRPr lang="en-US" sz="1100" dirty="0">
+                      <a:endParaRPr lang="en-US" sz="950" dirty="0">
                         <a:latin typeface="Calibri" charset="0"/>
                         <a:ea typeface="Calibri" charset="0"/>
                         <a:cs typeface="Calibri" charset="0"/>
@@ -4092,7 +4014,7 @@
                         <a:buNone/>
                       </a:pPr>
                       <a:r>
-                        <a:rPr lang="en-US" sz="1100" dirty="0">
+                        <a:rPr lang="en-US" sz="950" dirty="0">
                           <a:solidFill>
                             <a:srgbClr val="000000"/>
                           </a:solidFill>
@@ -4102,7 +4024,7 @@
                         </a:rPr>
                         <a:t>—</a:t>
                       </a:r>
-                      <a:endParaRPr lang="en-US" sz="1100" dirty="0">
+                      <a:endParaRPr lang="en-US" sz="950" dirty="0">
                         <a:latin typeface="Calibri" charset="0"/>
                         <a:ea typeface="Calibri" charset="0"/>
                         <a:cs typeface="Calibri" charset="0"/>
@@ -4552,7 +4474,7 @@
                         <a:buNone/>
                       </a:pPr>
                       <a:r>
-                        <a:rPr lang="en-US" sz="1100" dirty="0">
+                        <a:rPr lang="en-US" sz="950" dirty="0">
                           <a:solidFill>
                             <a:srgbClr val="000000"/>
                           </a:solidFill>
@@ -4562,7 +4484,7 @@
                         </a:rPr>
                         <a:t>Bowel damage / separation (1)</a:t>
                       </a:r>
-                      <a:endParaRPr lang="en-US" sz="1100" dirty="0">
+                      <a:endParaRPr lang="en-US" sz="950" dirty="0">
                         <a:latin typeface="Calibri" charset="0"/>
                         <a:ea typeface="Calibri" charset="0"/>
                         <a:cs typeface="Calibri" charset="0"/>
@@ -5012,7 +4934,7 @@
                         <a:buNone/>
                       </a:pPr>
                       <a:r>
-                        <a:rPr lang="en-US" sz="1100" dirty="0">
+                        <a:rPr lang="en-US" sz="950" dirty="0">
                           <a:solidFill>
                             <a:srgbClr val="000000"/>
                           </a:solidFill>
@@ -5020,9 +4942,9 @@
                           <a:ea typeface="Calibri" pitchFamily="34" charset="-122"/>
                           <a:cs typeface="Calibri" pitchFamily="34" charset="-120"/>
                         </a:rPr>
-                        <a:t>Other / unspecified (12, provisional)</a:t>
-                      </a:r>
-                      <a:endParaRPr lang="en-US" sz="1100" dirty="0">
+                        <a:t>UNVERIFIED — no reasons recorded; excluded from charts</a:t>
+                      </a:r>
+                      <a:endParaRPr lang="en-US" sz="950" dirty="0">
                         <a:latin typeface="Calibri" charset="0"/>
                         <a:ea typeface="Calibri" charset="0"/>
                         <a:cs typeface="Calibri" charset="0"/>
@@ -5217,7 +5139,7 @@
                           <a:ea typeface="Calibri" pitchFamily="34" charset="-122"/>
                           <a:cs typeface="Calibri" pitchFamily="34" charset="-120"/>
                         </a:rPr>
-                        <a:t>75</a:t>
+                        <a:t>66</a:t>
                       </a:r>
                       <a:endParaRPr lang="en-US" sz="1100" dirty="0">
                         <a:latin typeface="Calibri" charset="0"/>
@@ -5347,7 +5269,7 @@
                           <a:ea typeface="Calibri" pitchFamily="34" charset="-122"/>
                           <a:cs typeface="Calibri" pitchFamily="34" charset="-120"/>
                         </a:rPr>
-                        <a:t>59</a:t>
+                        <a:t>50</a:t>
                       </a:r>
                       <a:endParaRPr lang="en-US" sz="1100" dirty="0">
                         <a:latin typeface="Calibri" charset="0"/>
@@ -5412,7 +5334,7 @@
                           <a:ea typeface="Calibri" pitchFamily="34" charset="-122"/>
                           <a:cs typeface="Calibri" pitchFamily="34" charset="-120"/>
                         </a:rPr>
-                        <a:t>21.33%</a:t>
+                        <a:t>24.24%</a:t>
                       </a:r>
                       <a:endParaRPr lang="en-US" sz="1100" dirty="0">
                         <a:latin typeface="Calibri" charset="0"/>
@@ -5472,7 +5394,7 @@
                         <a:buNone/>
                       </a:pPr>
                       <a:r>
-                        <a:rPr lang="en-US" sz="1100" dirty="0">
+                        <a:rPr lang="en-US" sz="950" dirty="0">
                           <a:solidFill>
                             <a:srgbClr val="000000"/>
                           </a:solidFill>
@@ -5480,9 +5402,9 @@
                           <a:ea typeface="Calibri" pitchFamily="34" charset="-122"/>
                           <a:cs typeface="Calibri" pitchFamily="34" charset="-120"/>
                         </a:rPr>
-                        <a:t>Lung laceration (39)</a:t>
-                      </a:r>
-                      <a:endParaRPr lang="en-US" sz="1100" dirty="0">
+                        <a:t>Lung laceration (31)</a:t>
+                      </a:r>
+                      <a:endParaRPr lang="en-US" sz="950" dirty="0">
                         <a:latin typeface="Calibri" charset="0"/>
                         <a:ea typeface="Calibri" charset="0"/>
                         <a:cs typeface="Calibri" charset="0"/>
@@ -5535,7 +5457,46 @@
       </p:graphicFrame>
       <p:sp>
         <p:nvSpPr>
-          <p:cNvPr id="5" name="Shape 2"/>
+          <p:cNvPr id="5" name="Text 2"/>
+          <p:cNvSpPr/>
+          <p:nvPr/>
+        </p:nvSpPr>
+        <p:spPr>
+          <a:xfrm>
+            <a:off x="502920" y="3017520"/>
+            <a:ext cx="11155680" cy="201168"/>
+          </a:xfrm>
+          <a:prstGeom prst="rect">
+            <a:avLst/>
+          </a:prstGeom>
+          <a:noFill/>
+          <a:ln/>
+        </p:spPr>
+        <p:txBody>
+          <a:bodyPr wrap="square" lIns="0" tIns="0" rIns="0" bIns="0" rtlCol="0" anchor="ctr"/>
+          <a:lstStyle/>
+          <a:p>
+            <a:pPr indent="0" marL="0">
+              <a:buNone/>
+            </a:pPr>
+            <a:r>
+              <a:rPr lang="en-US" sz="820" i="1" dirty="0">
+                <a:solidFill>
+                  <a:srgbClr val="6B7280"/>
+                </a:solidFill>
+                <a:latin typeface="Calibri" pitchFamily="34" charset="0"/>
+                <a:ea typeface="Calibri" pitchFamily="34" charset="-122"/>
+                <a:cs typeface="Calibri" pitchFamily="34" charset="-120"/>
+              </a:rPr>
+              <a:t>Thoracic # columns for the 8/26 two-inspection visit are our QC inspection of harvest-passed blocks (9 received at QC); harvest-tech rejects tracked separately.</a:t>
+            </a:r>
+            <a:endParaRPr lang="en-US" sz="820" dirty="0"/>
+          </a:p>
+        </p:txBody>
+      </p:sp>
+      <p:sp>
+        <p:nvSpPr>
+          <p:cNvPr id="6" name="Shape 3"/>
           <p:cNvSpPr/>
           <p:nvPr/>
         </p:nvSpPr>
@@ -5562,7 +5523,7 @@
       </p:sp>
       <p:sp>
         <p:nvSpPr>
-          <p:cNvPr id="6" name="Text 3"/>
+          <p:cNvPr id="7" name="Text 4"/>
           <p:cNvSpPr/>
           <p:nvPr/>
         </p:nvSpPr>
@@ -5601,14 +5562,14 @@
       </p:sp>
       <p:sp>
         <p:nvSpPr>
-          <p:cNvPr id="7" name="Shape 4"/>
+          <p:cNvPr id="8" name="Shape 5"/>
           <p:cNvSpPr/>
           <p:nvPr/>
         </p:nvSpPr>
         <p:spPr>
           <a:xfrm>
             <a:off x="640080" y="3790188"/>
-            <a:ext cx="73855" cy="118872"/>
+            <a:ext cx="92915" cy="118872"/>
           </a:xfrm>
           <a:prstGeom prst="rect">
             <a:avLst/>
@@ -5621,7 +5582,7 @@
       </p:sp>
       <p:sp>
         <p:nvSpPr>
-          <p:cNvPr id="8" name="Text 5"/>
+          <p:cNvPr id="9" name="Text 6"/>
           <p:cNvSpPr/>
           <p:nvPr/>
         </p:nvSpPr>
@@ -5688,14 +5649,14 @@
       </p:sp>
       <p:sp>
         <p:nvSpPr>
-          <p:cNvPr id="9" name="Shape 6"/>
+          <p:cNvPr id="10" name="Shape 7"/>
           <p:cNvSpPr/>
           <p:nvPr/>
         </p:nvSpPr>
         <p:spPr>
           <a:xfrm>
             <a:off x="640080" y="4119372"/>
-            <a:ext cx="73855" cy="118872"/>
+            <a:ext cx="92915" cy="118872"/>
           </a:xfrm>
           <a:prstGeom prst="rect">
             <a:avLst/>
@@ -5708,7 +5669,7 @@
       </p:sp>
       <p:sp>
         <p:nvSpPr>
-          <p:cNvPr id="10" name="Text 7"/>
+          <p:cNvPr id="11" name="Text 8"/>
           <p:cNvSpPr/>
           <p:nvPr/>
         </p:nvSpPr>
@@ -5775,14 +5736,14 @@
       </p:sp>
       <p:sp>
         <p:nvSpPr>
-          <p:cNvPr id="11" name="Shape 8"/>
+          <p:cNvPr id="12" name="Shape 9"/>
           <p:cNvSpPr/>
           <p:nvPr/>
         </p:nvSpPr>
         <p:spPr>
           <a:xfrm>
             <a:off x="640080" y="4448556"/>
-            <a:ext cx="54864" cy="118872"/>
+            <a:ext cx="61943" cy="118872"/>
           </a:xfrm>
           <a:prstGeom prst="rect">
             <a:avLst/>
@@ -5795,7 +5756,7 @@
       </p:sp>
       <p:sp>
         <p:nvSpPr>
-          <p:cNvPr id="12" name="Text 9"/>
+          <p:cNvPr id="13" name="Text 10"/>
           <p:cNvSpPr/>
           <p:nvPr/>
         </p:nvSpPr>
@@ -5862,7 +5823,7 @@
       </p:sp>
       <p:sp>
         <p:nvSpPr>
-          <p:cNvPr id="13" name="Shape 10"/>
+          <p:cNvPr id="14" name="Shape 11"/>
           <p:cNvSpPr/>
           <p:nvPr/>
         </p:nvSpPr>
@@ -5889,7 +5850,7 @@
       </p:sp>
       <p:sp>
         <p:nvSpPr>
-          <p:cNvPr id="14" name="Text 11"/>
+          <p:cNvPr id="15" name="Text 12"/>
           <p:cNvSpPr/>
           <p:nvPr/>
         </p:nvSpPr>
@@ -5928,7 +5889,7 @@
       </p:sp>
       <p:sp>
         <p:nvSpPr>
-          <p:cNvPr id="15" name="Shape 12"/>
+          <p:cNvPr id="16" name="Shape 13"/>
           <p:cNvSpPr/>
           <p:nvPr/>
         </p:nvSpPr>
@@ -5948,7 +5909,7 @@
       </p:sp>
       <p:sp>
         <p:nvSpPr>
-          <p:cNvPr id="16" name="Text 13"/>
+          <p:cNvPr id="17" name="Text 14"/>
           <p:cNvSpPr/>
           <p:nvPr/>
         </p:nvSpPr>
@@ -6015,7 +5976,7 @@
       </p:sp>
       <p:sp>
         <p:nvSpPr>
-          <p:cNvPr id="17" name="Shape 14"/>
+          <p:cNvPr id="18" name="Shape 15"/>
           <p:cNvSpPr/>
           <p:nvPr/>
         </p:nvSpPr>
@@ -6035,7 +5996,7 @@
       </p:sp>
       <p:sp>
         <p:nvSpPr>
-          <p:cNvPr id="18" name="Text 15"/>
+          <p:cNvPr id="19" name="Text 16"/>
           <p:cNvSpPr/>
           <p:nvPr/>
         </p:nvSpPr>
@@ -6102,7 +6063,7 @@
       </p:sp>
       <p:sp>
         <p:nvSpPr>
-          <p:cNvPr id="19" name="Shape 16"/>
+          <p:cNvPr id="20" name="Shape 17"/>
           <p:cNvSpPr/>
           <p:nvPr/>
         </p:nvSpPr>
@@ -6129,7 +6090,7 @@
       </p:sp>
       <p:sp>
         <p:nvSpPr>
-          <p:cNvPr id="20" name="Text 17"/>
+          <p:cNvPr id="21" name="Text 18"/>
           <p:cNvSpPr/>
           <p:nvPr/>
         </p:nvSpPr>
@@ -6160,7 +6121,7 @@
                 <a:ea typeface="Calibri" pitchFamily="34" charset="-122"/>
                 <a:cs typeface="Calibri" pitchFamily="34" charset="-120"/>
               </a:rPr>
-              <a:t>Thoracic @ Nahunta · 666521 — 59 fails of 75</a:t>
+              <a:t>Thoracic @ Nahunta · 666521 — 50 fails of 66</a:t>
             </a:r>
             <a:endParaRPr lang="en-US" sz="1050" dirty="0"/>
           </a:p>
@@ -6168,7 +6129,7 @@
       </p:sp>
       <p:sp>
         <p:nvSpPr>
-          <p:cNvPr id="21" name="Shape 18"/>
+          <p:cNvPr id="22" name="Shape 19"/>
           <p:cNvSpPr/>
           <p:nvPr/>
         </p:nvSpPr>
@@ -6188,7 +6149,7 @@
       </p:sp>
       <p:sp>
         <p:nvSpPr>
-          <p:cNvPr id="22" name="Text 19"/>
+          <p:cNvPr id="23" name="Text 20"/>
           <p:cNvSpPr/>
           <p:nvPr/>
         </p:nvSpPr>
@@ -6233,7 +6194,7 @@
                 <a:ea typeface="Calibri" pitchFamily="34" charset="-122"/>
                 <a:cs typeface="Calibri" pitchFamily="34" charset="-120"/>
               </a:rPr>
-              <a:t>39</a:t>
+              <a:t>31</a:t>
             </a:r>
             <a:pPr indent="0" marL="0">
               <a:buNone/>
@@ -6247,7 +6208,7 @@
                 <a:ea typeface="Calibri" pitchFamily="34" charset="-122"/>
                 <a:cs typeface="Calibri" pitchFamily="34" charset="-120"/>
               </a:rPr>
-              <a:t>  ·  66.10%</a:t>
+              <a:t>  ·  62.00%</a:t>
             </a:r>
             <a:endParaRPr lang="en-US" sz="950" dirty="0"/>
           </a:p>
@@ -6255,14 +6216,14 @@
       </p:sp>
       <p:sp>
         <p:nvSpPr>
-          <p:cNvPr id="23" name="Shape 20"/>
+          <p:cNvPr id="24" name="Shape 21"/>
           <p:cNvSpPr/>
           <p:nvPr/>
         </p:nvSpPr>
         <p:spPr>
           <a:xfrm>
             <a:off x="8211312" y="4119372"/>
-            <a:ext cx="516988" cy="118872"/>
+            <a:ext cx="588461" cy="118872"/>
           </a:xfrm>
           <a:prstGeom prst="rect">
             <a:avLst/>
@@ -6275,7 +6236,7 @@
       </p:sp>
       <p:sp>
         <p:nvSpPr>
-          <p:cNvPr id="24" name="Text 21"/>
+          <p:cNvPr id="25" name="Text 22"/>
           <p:cNvSpPr/>
           <p:nvPr/>
         </p:nvSpPr>
@@ -6320,7 +6281,7 @@
                 <a:ea typeface="Calibri" pitchFamily="34" charset="-122"/>
                 <a:cs typeface="Calibri" pitchFamily="34" charset="-120"/>
               </a:rPr>
-              <a:t>21</a:t>
+              <a:t>19</a:t>
             </a:r>
             <a:pPr indent="0" marL="0">
               <a:buNone/>
@@ -6334,7 +6295,7 @@
                 <a:ea typeface="Calibri" pitchFamily="34" charset="-122"/>
                 <a:cs typeface="Calibri" pitchFamily="34" charset="-120"/>
               </a:rPr>
-              <a:t>  ·  35.59%</a:t>
+              <a:t>  ·  38.00%</a:t>
             </a:r>
             <a:endParaRPr lang="en-US" sz="950" dirty="0"/>
           </a:p>
@@ -6342,7 +6303,94 @@
       </p:sp>
       <p:sp>
         <p:nvSpPr>
-          <p:cNvPr id="25" name="Shape 22"/>
+          <p:cNvPr id="26" name="Shape 23"/>
+          <p:cNvSpPr/>
+          <p:nvPr/>
+        </p:nvSpPr>
+        <p:spPr>
+          <a:xfrm>
+            <a:off x="8211312" y="4448556"/>
+            <a:ext cx="54864" cy="118872"/>
+          </a:xfrm>
+          <a:prstGeom prst="rect">
+            <a:avLst/>
+          </a:prstGeom>
+          <a:solidFill>
+            <a:srgbClr val="0E7490"/>
+          </a:solidFill>
+          <a:ln/>
+        </p:spPr>
+      </p:sp>
+      <p:sp>
+        <p:nvSpPr>
+          <p:cNvPr id="27" name="Text 24"/>
+          <p:cNvSpPr/>
+          <p:nvPr/>
+        </p:nvSpPr>
+        <p:spPr>
+          <a:xfrm>
+            <a:off x="9262872" y="4398264"/>
+            <a:ext cx="2286000" cy="237744"/>
+          </a:xfrm>
+          <a:prstGeom prst="rect">
+            <a:avLst/>
+          </a:prstGeom>
+          <a:noFill/>
+          <a:ln/>
+        </p:spPr>
+        <p:txBody>
+          <a:bodyPr wrap="square" lIns="0" tIns="0" rIns="0" bIns="0" rtlCol="0" anchor="ctr"/>
+          <a:lstStyle/>
+          <a:p>
+            <a:pPr indent="0" marL="0">
+              <a:buNone/>
+            </a:pPr>
+            <a:r>
+              <a:rPr lang="en-US" sz="950" dirty="0">
+                <a:solidFill>
+                  <a:srgbClr val="1F2937"/>
+                </a:solidFill>
+                <a:latin typeface="Calibri" pitchFamily="34" charset="0"/>
+                <a:ea typeface="Calibri" pitchFamily="34" charset="-122"/>
+                <a:cs typeface="Calibri" pitchFamily="34" charset="-120"/>
+              </a:rPr>
+              <a:t>3. Undocumented / not itemized  </a:t>
+            </a:r>
+            <a:pPr indent="0" marL="0">
+              <a:buNone/>
+            </a:pPr>
+            <a:r>
+              <a:rPr lang="en-US" sz="950" b="1" dirty="0">
+                <a:solidFill>
+                  <a:srgbClr val="000000"/>
+                </a:solidFill>
+                <a:latin typeface="Calibri" pitchFamily="34" charset="0"/>
+                <a:ea typeface="Calibri" pitchFamily="34" charset="-122"/>
+                <a:cs typeface="Calibri" pitchFamily="34" charset="-120"/>
+              </a:rPr>
+              <a:t>1</a:t>
+            </a:r>
+            <a:pPr indent="0" marL="0">
+              <a:buNone/>
+            </a:pPr>
+            <a:r>
+              <a:rPr lang="en-US" sz="950" dirty="0">
+                <a:solidFill>
+                  <a:srgbClr val="6B7280"/>
+                </a:solidFill>
+                <a:latin typeface="Calibri" pitchFamily="34" charset="0"/>
+                <a:ea typeface="Calibri" pitchFamily="34" charset="-122"/>
+                <a:cs typeface="Calibri" pitchFamily="34" charset="-120"/>
+              </a:rPr>
+              <a:t>  ·  2.00%</a:t>
+            </a:r>
+            <a:endParaRPr lang="en-US" sz="950" dirty="0"/>
+          </a:p>
+        </p:txBody>
+      </p:sp>
+      <p:sp>
+        <p:nvSpPr>
+          <p:cNvPr id="28" name="Shape 25"/>
           <p:cNvSpPr/>
           <p:nvPr/>
         </p:nvSpPr>
@@ -6364,7 +6412,7 @@
       </p:sp>
       <p:sp>
         <p:nvSpPr>
-          <p:cNvPr id="26" name="Text 23"/>
+          <p:cNvPr id="29" name="Text 26"/>
           <p:cNvSpPr/>
           <p:nvPr/>
         </p:nvSpPr>
@@ -6403,7 +6451,7 @@
       </p:sp>
       <p:sp>
         <p:nvSpPr>
-          <p:cNvPr id="27" name="Text 24"/>
+          <p:cNvPr id="30" name="Text 27"/>
           <p:cNvSpPr/>
           <p:nvPr/>
         </p:nvSpPr>
@@ -6430,7 +6478,7 @@
               <a:buChar char="➢"/>
             </a:pPr>
             <a:r>
-              <a:rPr lang="en-US" sz="840" dirty="0">
+              <a:rPr lang="en-US" sz="820" dirty="0">
                 <a:solidFill>
                   <a:srgbClr val="1F2937"/>
                 </a:solidFill>
@@ -6440,7 +6488,7 @@
               </a:rPr>
               <a:t>666541 (Pelvic @ Martins): 96.0% FPY on 198 — clean month; scattered singles (bowel, urethra, membrane).</a:t>
             </a:r>
-            <a:endParaRPr lang="en-US" sz="840" dirty="0"/>
+            <a:endParaRPr lang="en-US" sz="820" dirty="0"/>
           </a:p>
           <a:p>
             <a:pPr marL="342900" indent="-342900">
@@ -6451,7 +6499,7 @@
               <a:buChar char="➢"/>
             </a:pPr>
             <a:r>
-              <a:rPr lang="en-US" sz="840" dirty="0">
+              <a:rPr lang="en-US" sz="820" dirty="0">
                 <a:solidFill>
                   <a:srgbClr val="1F2937"/>
                 </a:solidFill>
@@ -6461,7 +6509,7 @@
               </a:rPr>
               <a:t>666506 (Pelvic @ Martins): 100% FPY on 20 — no failures.</a:t>
             </a:r>
-            <a:endParaRPr lang="en-US" sz="840" dirty="0"/>
+            <a:endParaRPr lang="en-US" sz="820" dirty="0"/>
           </a:p>
           <a:p>
             <a:pPr marL="342900" indent="-342900">
@@ -6472,7 +6520,7 @@
               <a:buChar char="➢"/>
             </a:pPr>
             <a:r>
-              <a:rPr lang="en-US" sz="840" dirty="0">
+              <a:rPr lang="en-US" sz="820" dirty="0">
                 <a:solidFill>
                   <a:srgbClr val="1F2937"/>
                 </a:solidFill>
@@ -6482,7 +6530,7 @@
               </a:rPr>
               <a:t>666541 (Pelvic @ Parks): 95.7% FPY on 46 — strong start on the new spec after the 518 → 541 transition (8/10).</a:t>
             </a:r>
-            <a:endParaRPr lang="en-US" sz="840" dirty="0"/>
+            <a:endParaRPr lang="en-US" sz="820" dirty="0"/>
           </a:p>
           <a:p>
             <a:pPr marL="342900" indent="-342900">
@@ -6493,7 +6541,7 @@
               <a:buChar char="➢"/>
             </a:pPr>
             <a:r>
-              <a:rPr lang="en-US" sz="840" dirty="0">
+              <a:rPr lang="en-US" sz="820" dirty="0">
                 <a:solidFill>
                   <a:srgbClr val="1F2937"/>
                 </a:solidFill>
@@ -6501,9 +6549,9 @@
                 <a:ea typeface="Calibri" pitchFamily="34" charset="-122"/>
                 <a:cs typeface="Calibri" pitchFamily="34" charset="-120"/>
               </a:rPr>
-              <a:t>666521 (Thoracic @ Nahunta): 21.3% FPY on 75 across 4 visits — lung lacerations (39) and heart damage (21) persist; 8/26 rebounded to 44% (two-stage tally: SH tech passed 9/18, QC confirmed 8) after Francisco's team engagement.</a:t>
+              <a:t>666521 (Thoracic @ Nahunta): 24.2% QC FPY on 66 across 4 visits — lung lacerations (31) + heart damage (19). 8/26 was the first two-inspection visit: Jordan rejected 9 of 18 at harvest, our QC then passed 8 of 9 (88.9%) — rebound credited to Francisco's team.</a:t>
             </a:r>
-            <a:endParaRPr lang="en-US" sz="840" dirty="0"/>
+            <a:endParaRPr lang="en-US" sz="820" dirty="0"/>
           </a:p>
           <a:p>
             <a:pPr marL="342900" indent="-342900">
@@ -6514,7 +6562,7 @@
               <a:buChar char="➢"/>
             </a:pPr>
             <a:r>
-              <a:rPr lang="en-US" sz="840" dirty="0">
+              <a:rPr lang="en-US" sz="820" dirty="0">
                 <a:solidFill>
                   <a:srgbClr val="1F2937"/>
                 </a:solidFill>
@@ -6522,9 +6570,9 @@
                 <a:ea typeface="Calibri" pitchFamily="34" charset="-122"/>
                 <a:cs typeface="Calibri" pitchFamily="34" charset="-120"/>
               </a:rPr>
-              <a:t>666541 (Pelvic @ Nahunta): 8/12 line (13/1/12) is provisional — no defect breakdown recorded; confirm.</a:t>
+              <a:t>666541 (Pelvic @ Nahunta): 8/12 line (13/1/12) is UNVERIFIED — no scrap reasons on the source sheet; excluded from defect charts pending confirmation with Kris.</a:t>
             </a:r>
-            <a:endParaRPr lang="en-US" sz="840" dirty="0"/>
+            <a:endParaRPr lang="en-US" sz="820" dirty="0"/>
           </a:p>
           <a:p>
             <a:pPr marL="342900" indent="-342900">
@@ -6535,7 +6583,7 @@
               <a:buChar char="➢"/>
             </a:pPr>
             <a:r>
-              <a:rPr lang="en-US" sz="840" dirty="0">
+              <a:rPr lang="en-US" sz="820" dirty="0">
                 <a:solidFill>
                   <a:srgbClr val="1F2937"/>
                 </a:solidFill>
@@ -6543,15 +6591,15 @@
                 <a:ea typeface="Calibri" pitchFamily="34" charset="-122"/>
                 <a:cs typeface="Calibri" pitchFamily="34" charset="-120"/>
               </a:rPr>
-              <a:t>September to date (9/9, two-stage): SH tech passed only 2/19 and QC confirmed both — NEW failure mode: 9 missing trachea (SH harvesting tracheas for another buyer).</a:t>
+              <a:t>September to date (9/9, two-inspection visit): our QC passed both blocks Jordan passed (2/2); he rejected 17 of 19 at harvest — incl. 9 MISSING TRACHEA (tracheas harvested for another buyer).</a:t>
             </a:r>
-            <a:endParaRPr lang="en-US" sz="840" dirty="0"/>
+            <a:endParaRPr lang="en-US" sz="820" dirty="0"/>
           </a:p>
         </p:txBody>
       </p:sp>
       <p:sp>
         <p:nvSpPr>
-          <p:cNvPr id="28" name="Text 25"/>
+          <p:cNvPr id="31" name="Text 28"/>
           <p:cNvSpPr/>
           <p:nvPr/>
         </p:nvSpPr>
@@ -6590,7 +6638,7 @@
       </p:sp>
       <p:sp>
         <p:nvSpPr>
-          <p:cNvPr id="29" name="Text 26"/>
+          <p:cNvPr id="32" name="Text 29"/>
           <p:cNvSpPr/>
           <p:nvPr/>
         </p:nvSpPr>
@@ -6668,7 +6716,7 @@
         <p:spPr>
           <a:xfrm>
             <a:off x="502920" y="256032"/>
-            <a:ext cx="8686800" cy="256032"/>
+            <a:ext cx="10515600" cy="256032"/>
           </a:xfrm>
           <a:prstGeom prst="rect">
             <a:avLst/>
@@ -7678,7 +7726,7 @@
                           <a:ea typeface="Calibri" pitchFamily="34" charset="-122"/>
                           <a:cs typeface="Calibri" pitchFamily="34" charset="-120"/>
                         </a:rPr>
-                        <a:t>Urethra (2), Other (2), Bowel damage (1)</a:t>
+                        <a:t>Urethra (2), Blood clots (2), Bowel (1)</a:t>
                       </a:r>
                       <a:endParaRPr lang="en-US" sz="720" dirty="0">
                         <a:latin typeface="Calibri" charset="0"/>
@@ -11787,7 +11835,7 @@
                           <a:ea typeface="Calibri" pitchFamily="34" charset="-122"/>
                           <a:cs typeface="Calibri" pitchFamily="34" charset="-120"/>
                         </a:rPr>
-                        <a:t>Urethra (2), Membrane (1), Other (1)</a:t>
+                        <a:t>Urethra (2), Membrane (1), Undocumented (1)</a:t>
                       </a:r>
                       <a:endParaRPr lang="en-US" sz="720" dirty="0">
                         <a:latin typeface="Calibri" charset="0"/>
@@ -15894,7 +15942,7 @@
                           <a:ea typeface="Calibri" pitchFamily="34" charset="-122"/>
                           <a:cs typeface="Calibri" pitchFamily="34" charset="-120"/>
                         </a:rPr>
-                        <a:t>18 / 8 / 10</a:t>
+                        <a:t>9 / 8 / 1</a:t>
                       </a:r>
                       <a:endParaRPr lang="en-US" sz="760" dirty="0">
                         <a:latin typeface="Calibri" charset="0"/>
@@ -15962,7 +16010,7 @@
                           <a:ea typeface="Calibri" pitchFamily="34" charset="-122"/>
                           <a:cs typeface="Calibri" pitchFamily="34" charset="-120"/>
                         </a:rPr>
-                        <a:t>Lung laceration (8), Heart damage (2)</a:t>
+                        <a:t>Undocumented (1) — QC stage</a:t>
                       </a:r>
                       <a:endParaRPr lang="en-US" sz="720" dirty="0">
                         <a:latin typeface="Calibri" charset="0"/>
@@ -16508,7 +16556,7 @@
                           <a:ea typeface="Calibri" pitchFamily="34" charset="-122"/>
                           <a:cs typeface="Calibri" pitchFamily="34" charset="-120"/>
                         </a:rPr>
-                        <a:t>19 / 2 / 17</a:t>
+                        <a:t>2 / 2 / 0</a:t>
                       </a:r>
                       <a:endParaRPr lang="en-US" sz="760" dirty="0">
                         <a:latin typeface="Calibri" charset="0"/>
@@ -16576,7 +16624,7 @@
                           <a:ea typeface="Calibri" pitchFamily="34" charset="-122"/>
                           <a:cs typeface="Calibri" pitchFamily="34" charset="-120"/>
                         </a:rPr>
-                        <a:t>Missing anatomy (9), Lung laceration (8)</a:t>
+                        <a:t>clean at QC — harvest rejects excl.</a:t>
                       </a:r>
                       <a:endParaRPr lang="en-US" sz="720" dirty="0">
                         <a:latin typeface="Calibri" charset="0"/>
@@ -16937,7 +16985,7 @@
                 <a:ea typeface="Calibri" pitchFamily="34" charset="-122"/>
                 <a:cs typeface="Calibri" pitchFamily="34" charset="-120"/>
               </a:rPr>
-              <a:t>† Inspected under Nahunta's new two-stage tally (SH tech screens, then QC inspects) — SH I/P/F shown is the final QC outcome; stage detail on the two-stage slide.</a:t>
+              <a:t>† Nahunta two-inspection visits (unique to Nahunta, from 08/26): the harvest tech inspects BEFORE we receive the tissue — SH I/P/F shown is OUR QC inspection of harvest-passed blocks (8/26: 9 of 18 passed to QC; 9/9: 2 of 19). Stage detail on the final slide.</a:t>
             </a:r>
             <a:endParaRPr lang="en-US" sz="780" dirty="0"/>
           </a:p>
@@ -17062,7 +17110,7 @@
         <p:spPr>
           <a:xfrm>
             <a:off x="502920" y="256032"/>
-            <a:ext cx="8686800" cy="256032"/>
+            <a:ext cx="10515600" cy="256032"/>
           </a:xfrm>
           <a:prstGeom prst="rect">
             <a:avLst/>
@@ -17086,7 +17134,7 @@
                 <a:ea typeface="Calibri" pitchFamily="34" charset="-122"/>
                 <a:cs typeface="Calibri" pitchFamily="34" charset="-120"/>
               </a:rPr>
-              <a:t>QDR  ·  WINDOW 08/01 – 09/16/2026</a:t>
+              <a:t>QDR  ·  WINDOW 08/01 – 09/16/2026  ·  ATM = SH-INSPECTED BATCHES ONLY</a:t>
             </a:r>
             <a:endParaRPr lang="en-US" sz="1100" dirty="0"/>
           </a:p>
@@ -17203,7 +17251,7 @@
                 <a:ea typeface="Calibri" pitchFamily="34" charset="-122"/>
                 <a:cs typeface="Calibri" pitchFamily="34" charset="-120"/>
               </a:rPr>
-              <a:t>SH issues — 22 total</a:t>
+              <a:t>SH issues — 10 verified</a:t>
             </a:r>
             <a:endParaRPr lang="en-US" sz="1000" dirty="0"/>
           </a:p>
@@ -17217,7 +17265,7 @@
         </p:nvGraphicFramePr>
         <p:xfrm>
           <a:off x="502920" y="1645920"/>
-          <a:ext cx="5394960" cy="1828800"/>
+          <a:ext cx="5394960" cy="1691640"/>
         </p:xfrm>
         <a:graphic xmlns:a="http://schemas.openxmlformats.org/drawingml/2006/main">
           <a:graphicData uri="http://schemas.openxmlformats.org/drawingml/2006/chart">
@@ -17258,7 +17306,7 @@
                 <a:ea typeface="Calibri" pitchFamily="34" charset="-122"/>
                 <a:cs typeface="Calibri" pitchFamily="34" charset="-120"/>
               </a:rPr>
-              <a:t>ATM scrap — 63 total · 57 quality-only</a:t>
+              <a:t>ATM scrap — 40 units · matched batches, all quality</a:t>
             </a:r>
             <a:endParaRPr lang="en-US" sz="1000" dirty="0"/>
           </a:p>
@@ -17272,7 +17320,7 @@
         </p:nvGraphicFramePr>
         <p:xfrm>
           <a:off x="6263640" y="1645920"/>
-          <a:ext cx="5394960" cy="1828800"/>
+          <a:ext cx="5394960" cy="1691640"/>
         </p:xfrm>
         <a:graphic xmlns:a="http://schemas.openxmlformats.org/drawingml/2006/main">
           <a:graphicData uri="http://schemas.openxmlformats.org/drawingml/2006/chart">
@@ -17288,7 +17336,46 @@
         </p:nvSpPr>
         <p:spPr>
           <a:xfrm>
-            <a:off x="502920" y="3657600"/>
+            <a:off x="502920" y="3310128"/>
+            <a:ext cx="11155680" cy="201168"/>
+          </a:xfrm>
+          <a:prstGeom prst="rect">
+            <a:avLst/>
+          </a:prstGeom>
+          <a:noFill/>
+          <a:ln/>
+        </p:spPr>
+        <p:txBody>
+          <a:bodyPr wrap="square" lIns="0" tIns="0" rIns="0" bIns="0" rtlCol="0" anchor="ctr"/>
+          <a:lstStyle/>
+          <a:p>
+            <a:pPr indent="0" marL="0">
+              <a:buNone/>
+            </a:pPr>
+            <a:r>
+              <a:rPr lang="en-US" sz="820" i="1" dirty="0">
+                <a:solidFill>
+                  <a:srgbClr val="B45309"/>
+                </a:solidFill>
+                <a:latin typeface="Calibri" pitchFamily="34" charset="0"/>
+                <a:ea typeface="Calibri" pitchFamily="34" charset="-122"/>
+                <a:cs typeface="Calibri" pitchFamily="34" charset="-120"/>
+              </a:rPr>
+              <a:t>Excluded from the SH chart: the Nahunta 8/12 line (12 fails) — no scrap reasons recorded on the source sheet; pending confirmation with Kris.</a:t>
+            </a:r>
+            <a:endParaRPr lang="en-US" sz="820" dirty="0"/>
+          </a:p>
+        </p:txBody>
+      </p:sp>
+      <p:sp>
+        <p:nvSpPr>
+          <p:cNvPr id="10" name="Text 6"/>
+          <p:cNvSpPr/>
+          <p:nvPr/>
+        </p:nvSpPr>
+        <p:spPr>
+          <a:xfrm>
+            <a:off x="502920" y="3639312"/>
             <a:ext cx="3657600" cy="237744"/>
           </a:xfrm>
           <a:prstGeom prst="rect">
@@ -17321,13 +17408,13 @@
       </p:sp>
       <p:sp>
         <p:nvSpPr>
-          <p:cNvPr id="10" name="Text 6"/>
+          <p:cNvPr id="11" name="Text 7"/>
           <p:cNvSpPr/>
           <p:nvPr/>
         </p:nvSpPr>
         <p:spPr>
           <a:xfrm>
-            <a:off x="502920" y="3931920"/>
+            <a:off x="502920" y="3913632"/>
             <a:ext cx="5394960" cy="219456"/>
           </a:xfrm>
           <a:prstGeom prst="rect">
@@ -17352,7 +17439,7 @@
                 <a:ea typeface="Calibri" pitchFamily="34" charset="-122"/>
                 <a:cs typeface="Calibri" pitchFamily="34" charset="-120"/>
               </a:rPr>
-              <a:t>SH issues — 77 total</a:t>
+              <a:t>SH issues — 51 tags on 50 QC fails</a:t>
             </a:r>
             <a:endParaRPr lang="en-US" sz="1000" dirty="0"/>
           </a:p>
@@ -17360,13 +17447,13 @@
       </p:sp>
       <p:graphicFrame>
         <p:nvGraphicFramePr>
-          <p:cNvPr id="11" name="Chart 2" descr=""/>
+          <p:cNvPr id="12" name="Chart 2" descr=""/>
           <p:cNvGraphicFramePr/>
           <p:nvPr/>
         </p:nvGraphicFramePr>
         <p:xfrm>
-          <a:off x="502920" y="4151376"/>
-          <a:ext cx="5394960" cy="1554480"/>
+          <a:off x="502920" y="4133088"/>
+          <a:ext cx="5394960" cy="1417320"/>
         </p:xfrm>
         <a:graphic xmlns:a="http://schemas.openxmlformats.org/drawingml/2006/main">
           <a:graphicData uri="http://schemas.openxmlformats.org/drawingml/2006/chart">
@@ -17376,13 +17463,13 @@
       </p:graphicFrame>
       <p:sp>
         <p:nvSpPr>
-          <p:cNvPr id="12" name="Text 7"/>
+          <p:cNvPr id="13" name="Text 8"/>
           <p:cNvSpPr/>
           <p:nvPr/>
         </p:nvSpPr>
         <p:spPr>
           <a:xfrm>
-            <a:off x="6263640" y="3931920"/>
+            <a:off x="6263640" y="3913632"/>
             <a:ext cx="5394960" cy="219456"/>
           </a:xfrm>
           <a:prstGeom prst="rect">
@@ -17407,7 +17494,7 @@
                 <a:ea typeface="Calibri" pitchFamily="34" charset="-122"/>
                 <a:cs typeface="Calibri" pitchFamily="34" charset="-120"/>
               </a:rPr>
-              <a:t>ATM scrap — 153 total · 153 quality-only</a:t>
+              <a:t>ATM scrap — 24 units · matched batches, all quality</a:t>
             </a:r>
             <a:endParaRPr lang="en-US" sz="1000" dirty="0"/>
           </a:p>
@@ -17415,13 +17502,13 @@
       </p:sp>
       <p:graphicFrame>
         <p:nvGraphicFramePr>
-          <p:cNvPr id="13" name="Chart 3" descr=""/>
+          <p:cNvPr id="14" name="Chart 3" descr=""/>
           <p:cNvGraphicFramePr/>
           <p:nvPr/>
         </p:nvGraphicFramePr>
         <p:xfrm>
-          <a:off x="6263640" y="4151376"/>
-          <a:ext cx="5394960" cy="1554480"/>
+          <a:off x="6263640" y="4133088"/>
+          <a:ext cx="5394960" cy="1417320"/>
         </p:xfrm>
         <a:graphic xmlns:a="http://schemas.openxmlformats.org/drawingml/2006/main">
           <a:graphicData uri="http://schemas.openxmlformats.org/drawingml/2006/chart">
@@ -17431,13 +17518,52 @@
       </p:graphicFrame>
       <p:sp>
         <p:nvSpPr>
-          <p:cNvPr id="14" name="Text 8"/>
+          <p:cNvPr id="15" name="Text 9"/>
           <p:cNvSpPr/>
           <p:nvPr/>
         </p:nvSpPr>
         <p:spPr>
           <a:xfrm>
-            <a:off x="502920" y="5989320"/>
+            <a:off x="502920" y="5541264"/>
+            <a:ext cx="11155680" cy="201168"/>
+          </a:xfrm>
+          <a:prstGeom prst="rect">
+            <a:avLst/>
+          </a:prstGeom>
+          <a:noFill/>
+          <a:ln/>
+        </p:spPr>
+        <p:txBody>
+          <a:bodyPr wrap="square" lIns="0" tIns="0" rIns="0" bIns="0" rtlCol="0" anchor="ctr"/>
+          <a:lstStyle/>
+          <a:p>
+            <a:pPr indent="0" marL="0">
+              <a:buNone/>
+            </a:pPr>
+            <a:r>
+              <a:rPr lang="en-US" sz="820" i="1" dirty="0">
+                <a:solidFill>
+                  <a:srgbClr val="B45309"/>
+                </a:solidFill>
+                <a:latin typeface="Calibri" pitchFamily="34" charset="0"/>
+                <a:ea typeface="Calibri" pitchFamily="34" charset="-122"/>
+                <a:cs typeface="Calibri" pitchFamily="34" charset="-120"/>
+              </a:rPr>
+              <a:t>Not in the SH chart: harvest-stage rejects at Nahunta's two-inspection visits — Jordan rejected 9 of 18 (8/26) and 17 of 19 (9/9, incl. 9 MISSING TRACHEA: tracheas harvested for another buyer).</a:t>
+            </a:r>
+            <a:endParaRPr lang="en-US" sz="820" dirty="0"/>
+          </a:p>
+        </p:txBody>
+      </p:sp>
+      <p:sp>
+        <p:nvSpPr>
+          <p:cNvPr id="16" name="Text 10"/>
+          <p:cNvSpPr/>
+          <p:nvPr/>
+        </p:nvSpPr>
+        <p:spPr>
+          <a:xfrm>
+            <a:off x="502920" y="5943600"/>
             <a:ext cx="11155680" cy="365760"/>
           </a:xfrm>
           <a:prstGeom prst="rect">
@@ -17462,7 +17588,7 @@
                 <a:ea typeface="Calibri" pitchFamily="34" charset="-122"/>
                 <a:cs typeface="Calibri" pitchFamily="34" charset="-120"/>
               </a:rPr>
-              <a:t>* planned/process withdrawal — not a harvest-quality defect.   ATM Aug–Sep scrap reflects batches harvested ~1–1.5 months earlier; thoracic ATM units are the survivors of already-failing SH lots.</a:t>
+              <a:t>ATM side counts only batches that were inspected at the slaughterhouses (matched lots), postings 08/01–09/16 net of reversals. ATM scrap in this window reflects batches harvested ~1–1.5 months earlier; thoracic ATM units are the survivors of already-failing SH lots.</a:t>
             </a:r>
             <a:endParaRPr lang="en-US" sz="850" dirty="0"/>
           </a:p>
@@ -17470,7 +17596,7 @@
       </p:sp>
       <p:sp>
         <p:nvSpPr>
-          <p:cNvPr id="15" name="Text 9"/>
+          <p:cNvPr id="17" name="Text 11"/>
           <p:cNvSpPr/>
           <p:nvPr/>
         </p:nvSpPr>
@@ -17509,7 +17635,7 @@
       </p:sp>
       <p:sp>
         <p:nvSpPr>
-          <p:cNvPr id="16" name="Text 10"/>
+          <p:cNvPr id="18" name="Text 12"/>
           <p:cNvSpPr/>
           <p:nvPr/>
         </p:nvSpPr>
@@ -17587,7 +17713,7 @@
         <p:spPr>
           <a:xfrm>
             <a:off x="502920" y="256032"/>
-            <a:ext cx="8686800" cy="256032"/>
+            <a:ext cx="10515600" cy="256032"/>
           </a:xfrm>
           <a:prstGeom prst="rect">
             <a:avLst/>
@@ -17611,7 +17737,7 @@
                 <a:ea typeface="Calibri" pitchFamily="34" charset="-122"/>
                 <a:cs typeface="Calibri" pitchFamily="34" charset="-120"/>
               </a:rPr>
-              <a:t>QDR  ·  FORMAT CHANGE &amp; WHAT IT SHOWS</a:t>
+              <a:t>QDR  ·  UNIQUE TO NAHUNTA  ·  FORMAT &amp; LOG CONVENTION</a:t>
             </a:r>
             <a:endParaRPr lang="en-US" sz="1100" dirty="0"/>
           </a:p>
@@ -17650,7 +17776,7 @@
                 <a:ea typeface="Calibri" pitchFamily="34" charset="-122"/>
                 <a:cs typeface="Calibri" pitchFamily="34" charset="-120"/>
               </a:rPr>
-              <a:t>Nahunta — New Two-Stage Tally (since 8/26)</a:t>
+              <a:t>Nahunta — Two Inspections per Visit (since 8/26)</a:t>
             </a:r>
             <a:endParaRPr lang="en-US" sz="2800" dirty="0"/>
           </a:p>
@@ -17689,7 +17815,7 @@
                 <a:ea typeface="Calibri" pitchFamily="34" charset="-122"/>
                 <a:cs typeface="Calibri" pitchFamily="34" charset="-120"/>
               </a:rPr>
-              <a:t>Nahunta tally sheets now carry two stages: the slaughterhouse's own tech screens every block, then our QC tech inspects the SH-passed blocks. The Inspection Log keeps recording the FINAL QC outcome, so all cross-site comparisons are unchanged — but the stage split adds two new signals.</a:t>
+              <a:t>Nahunta is the only slaughterhouse running two inspections per visit: one BEFORE we receive the tissue — the harvesting tech (Jordan) inspects and rejects blocks as he harvests — and one AFTER, when our QC tech inspects what was passed to us. The Inspection Log records our QC stage; the harvest stage is tracked as a leading indicator.</a:t>
             </a:r>
             <a:endParaRPr lang="en-US" sz="1200" dirty="0"/>
           </a:p>
@@ -17718,13 +17844,13 @@
             <a:tbl>
               <a:tblPr/>
               <a:tblGrid>
-                <a:gridCol w="1051560"/>
+                <a:gridCol w="1005840"/>
                 <a:gridCol w="1143000"/>
-                <a:gridCol w="960120"/>
-                <a:gridCol w="1600200"/>
-                <a:gridCol w="1691640"/>
-                <a:gridCol w="1005840"/>
-                <a:gridCol w="3730752"/>
+                <a:gridCol w="1371600"/>
+                <a:gridCol w="1554480"/>
+                <a:gridCol w="1234440"/>
+                <a:gridCol w="1417320"/>
+                <a:gridCol w="3456432"/>
               </a:tblGrid>
               <a:tr h="502920">
                 <a:tc>
@@ -17880,7 +18006,7 @@
                           <a:ea typeface="Calibri" pitchFamily="34" charset="-122"/>
                           <a:cs typeface="Calibri" pitchFamily="34" charset="-120"/>
                         </a:rPr>
-                        <a:t># Received</a:t>
+                        <a:t># Received at harvest</a:t>
                       </a:r>
                       <a:endParaRPr lang="en-US" sz="1000" dirty="0">
                         <a:latin typeface="Calibri" charset="0"/>
@@ -17948,7 +18074,7 @@
                           <a:ea typeface="Calibri" pitchFamily="34" charset="-122"/>
                           <a:cs typeface="Calibri" pitchFamily="34" charset="-120"/>
                         </a:rPr>
-                        <a:t>SH-tech pass (yield)</a:t>
+                        <a:t>Rejected by harvest tech</a:t>
                       </a:r>
                       <a:endParaRPr lang="en-US" sz="1000" dirty="0">
                         <a:latin typeface="Calibri" charset="0"/>
@@ -18016,7 +18142,7 @@
                           <a:ea typeface="Calibri" pitchFamily="34" charset="-122"/>
                           <a:cs typeface="Calibri" pitchFamily="34" charset="-120"/>
                         </a:rPr>
-                        <a:t>QC accept of SH-passed</a:t>
+                        <a:t>Passed to our QC</a:t>
                       </a:r>
                       <a:endParaRPr lang="en-US" sz="1000" dirty="0">
                         <a:latin typeface="Calibri" charset="0"/>
@@ -18084,7 +18210,7 @@
                           <a:ea typeface="Calibri" pitchFamily="34" charset="-122"/>
                           <a:cs typeface="Calibri" pitchFamily="34" charset="-120"/>
                         </a:rPr>
-                        <a:t>Final FPY</a:t>
+                        <a:t>QC accept (log basis)</a:t>
                       </a:r>
                       <a:endParaRPr lang="en-US" sz="1000" dirty="0">
                         <a:latin typeface="Calibri" charset="0"/>
@@ -18474,6 +18600,71 @@
                         <a:buNone/>
                       </a:pPr>
                       <a:r>
+                        <a:rPr lang="en-US" sz="1000" dirty="0">
+                          <a:solidFill>
+                            <a:srgbClr val="000000"/>
+                          </a:solidFill>
+                          <a:latin typeface="Calibri" pitchFamily="34" charset="0"/>
+                          <a:ea typeface="Calibri" pitchFamily="34" charset="-122"/>
+                          <a:cs typeface="Calibri" pitchFamily="34" charset="-120"/>
+                        </a:rPr>
+                        <a:t>9</a:t>
+                      </a:r>
+                      <a:endParaRPr lang="en-US" sz="1000" dirty="0">
+                        <a:latin typeface="Calibri" charset="0"/>
+                        <a:ea typeface="Calibri" charset="0"/>
+                        <a:cs typeface="Calibri" charset="0"/>
+                      </a:endParaRPr>
+                    </a:p>
+                  </a:txBody>
+                  <a:tcPr marL="91440" marR="91440" marT="45720" marB="45720" anchor="ctr">
+                    <a:lnL w="6350" cap="flat" cmpd="sng" algn="ctr">
+                      <a:solidFill>
+                        <a:srgbClr val="E5E7EB"/>
+                      </a:solidFill>
+                      <a:prstDash val="solid"/>
+                      <a:round/>
+                      <a:headEnd type="none" w="med" len="med"/>
+                      <a:tailEnd type="none" w="med" len="med"/>
+                    </a:lnL>
+                    <a:lnR w="6350" cap="flat" cmpd="sng" algn="ctr">
+                      <a:solidFill>
+                        <a:srgbClr val="E5E7EB"/>
+                      </a:solidFill>
+                      <a:prstDash val="solid"/>
+                      <a:round/>
+                      <a:headEnd type="none" w="med" len="med"/>
+                      <a:tailEnd type="none" w="med" len="med"/>
+                    </a:lnR>
+                    <a:lnT w="6350" cap="flat" cmpd="sng" algn="ctr">
+                      <a:solidFill>
+                        <a:srgbClr val="E5E7EB"/>
+                      </a:solidFill>
+                      <a:prstDash val="solid"/>
+                      <a:round/>
+                      <a:headEnd type="none" w="med" len="med"/>
+                      <a:tailEnd type="none" w="med" len="med"/>
+                    </a:lnT>
+                    <a:lnB w="6350" cap="flat" cmpd="sng" algn="ctr">
+                      <a:solidFill>
+                        <a:srgbClr val="E5E7EB"/>
+                      </a:solidFill>
+                      <a:prstDash val="solid"/>
+                      <a:round/>
+                      <a:headEnd type="none" w="med" len="med"/>
+                      <a:tailEnd type="none" w="med" len="med"/>
+                    </a:lnB>
+                  </a:tcPr>
+                </a:tc>
+                <a:tc>
+                  <a:txBody>
+                    <a:bodyPr/>
+                    <a:lstStyle/>
+                    <a:p>
+                      <a:pPr algn="ctr" indent="0" marL="0">
+                        <a:buNone/>
+                      </a:pPr>
+                      <a:r>
                         <a:rPr lang="en-US" sz="1000" b="1" dirty="0">
                           <a:solidFill>
                             <a:srgbClr val="15803D"/>
@@ -18483,71 +18674,6 @@
                           <a:cs typeface="Calibri" pitchFamily="34" charset="-120"/>
                         </a:rPr>
                         <a:t>8 / 9  (88.9%)</a:t>
-                      </a:r>
-                      <a:endParaRPr lang="en-US" sz="1000" dirty="0">
-                        <a:latin typeface="Calibri" charset="0"/>
-                        <a:ea typeface="Calibri" charset="0"/>
-                        <a:cs typeface="Calibri" charset="0"/>
-                      </a:endParaRPr>
-                    </a:p>
-                  </a:txBody>
-                  <a:tcPr marL="91440" marR="91440" marT="45720" marB="45720" anchor="ctr">
-                    <a:lnL w="6350" cap="flat" cmpd="sng" algn="ctr">
-                      <a:solidFill>
-                        <a:srgbClr val="E5E7EB"/>
-                      </a:solidFill>
-                      <a:prstDash val="solid"/>
-                      <a:round/>
-                      <a:headEnd type="none" w="med" len="med"/>
-                      <a:tailEnd type="none" w="med" len="med"/>
-                    </a:lnL>
-                    <a:lnR w="6350" cap="flat" cmpd="sng" algn="ctr">
-                      <a:solidFill>
-                        <a:srgbClr val="E5E7EB"/>
-                      </a:solidFill>
-                      <a:prstDash val="solid"/>
-                      <a:round/>
-                      <a:headEnd type="none" w="med" len="med"/>
-                      <a:tailEnd type="none" w="med" len="med"/>
-                    </a:lnR>
-                    <a:lnT w="6350" cap="flat" cmpd="sng" algn="ctr">
-                      <a:solidFill>
-                        <a:srgbClr val="E5E7EB"/>
-                      </a:solidFill>
-                      <a:prstDash val="solid"/>
-                      <a:round/>
-                      <a:headEnd type="none" w="med" len="med"/>
-                      <a:tailEnd type="none" w="med" len="med"/>
-                    </a:lnT>
-                    <a:lnB w="6350" cap="flat" cmpd="sng" algn="ctr">
-                      <a:solidFill>
-                        <a:srgbClr val="E5E7EB"/>
-                      </a:solidFill>
-                      <a:prstDash val="solid"/>
-                      <a:round/>
-                      <a:headEnd type="none" w="med" len="med"/>
-                      <a:tailEnd type="none" w="med" len="med"/>
-                    </a:lnB>
-                  </a:tcPr>
-                </a:tc>
-                <a:tc>
-                  <a:txBody>
-                    <a:bodyPr/>
-                    <a:lstStyle/>
-                    <a:p>
-                      <a:pPr algn="ctr" indent="0" marL="0">
-                        <a:buNone/>
-                      </a:pPr>
-                      <a:r>
-                        <a:rPr lang="en-US" sz="1000" b="1" dirty="0">
-                          <a:solidFill>
-                            <a:srgbClr val="B45309"/>
-                          </a:solidFill>
-                          <a:latin typeface="Calibri" pitchFamily="34" charset="0"/>
-                          <a:ea typeface="Calibri" pitchFamily="34" charset="-122"/>
-                          <a:cs typeface="Calibri" pitchFamily="34" charset="-120"/>
-                        </a:rPr>
-                        <a:t>44.4%</a:t>
                       </a:r>
                       <a:endParaRPr lang="en-US" sz="1000" dirty="0">
                         <a:latin typeface="Calibri" charset="0"/>
@@ -18874,7 +19000,7 @@
                           <a:ea typeface="Calibri" pitchFamily="34" charset="-122"/>
                           <a:cs typeface="Calibri" pitchFamily="34" charset="-120"/>
                         </a:rPr>
-                        <a:t>2  (10.5%)</a:t>
+                        <a:t>17  (89.5%)</a:t>
                       </a:r>
                       <a:endParaRPr lang="en-US" sz="1000" dirty="0">
                         <a:latin typeface="Calibri" charset="0"/>
@@ -18931,6 +19057,71 @@
                         <a:buNone/>
                       </a:pPr>
                       <a:r>
+                        <a:rPr lang="en-US" sz="1000" dirty="0">
+                          <a:solidFill>
+                            <a:srgbClr val="000000"/>
+                          </a:solidFill>
+                          <a:latin typeface="Calibri" pitchFamily="34" charset="0"/>
+                          <a:ea typeface="Calibri" pitchFamily="34" charset="-122"/>
+                          <a:cs typeface="Calibri" pitchFamily="34" charset="-120"/>
+                        </a:rPr>
+                        <a:t>2</a:t>
+                      </a:r>
+                      <a:endParaRPr lang="en-US" sz="1000" dirty="0">
+                        <a:latin typeface="Calibri" charset="0"/>
+                        <a:ea typeface="Calibri" charset="0"/>
+                        <a:cs typeface="Calibri" charset="0"/>
+                      </a:endParaRPr>
+                    </a:p>
+                  </a:txBody>
+                  <a:tcPr marL="91440" marR="91440" marT="45720" marB="45720" anchor="ctr">
+                    <a:lnL w="6350" cap="flat" cmpd="sng" algn="ctr">
+                      <a:solidFill>
+                        <a:srgbClr val="E5E7EB"/>
+                      </a:solidFill>
+                      <a:prstDash val="solid"/>
+                      <a:round/>
+                      <a:headEnd type="none" w="med" len="med"/>
+                      <a:tailEnd type="none" w="med" len="med"/>
+                    </a:lnL>
+                    <a:lnR w="6350" cap="flat" cmpd="sng" algn="ctr">
+                      <a:solidFill>
+                        <a:srgbClr val="E5E7EB"/>
+                      </a:solidFill>
+                      <a:prstDash val="solid"/>
+                      <a:round/>
+                      <a:headEnd type="none" w="med" len="med"/>
+                      <a:tailEnd type="none" w="med" len="med"/>
+                    </a:lnR>
+                    <a:lnT w="6350" cap="flat" cmpd="sng" algn="ctr">
+                      <a:solidFill>
+                        <a:srgbClr val="E5E7EB"/>
+                      </a:solidFill>
+                      <a:prstDash val="solid"/>
+                      <a:round/>
+                      <a:headEnd type="none" w="med" len="med"/>
+                      <a:tailEnd type="none" w="med" len="med"/>
+                    </a:lnT>
+                    <a:lnB w="6350" cap="flat" cmpd="sng" algn="ctr">
+                      <a:solidFill>
+                        <a:srgbClr val="E5E7EB"/>
+                      </a:solidFill>
+                      <a:prstDash val="solid"/>
+                      <a:round/>
+                      <a:headEnd type="none" w="med" len="med"/>
+                      <a:tailEnd type="none" w="med" len="med"/>
+                    </a:lnB>
+                  </a:tcPr>
+                </a:tc>
+                <a:tc>
+                  <a:txBody>
+                    <a:bodyPr/>
+                    <a:lstStyle/>
+                    <a:p>
+                      <a:pPr algn="ctr" indent="0" marL="0">
+                        <a:buNone/>
+                      </a:pPr>
+                      <a:r>
                         <a:rPr lang="en-US" sz="1000" b="1" dirty="0">
                           <a:solidFill>
                             <a:srgbClr val="15803D"/>
@@ -18992,71 +19183,6 @@
                     <a:bodyPr/>
                     <a:lstStyle/>
                     <a:p>
-                      <a:pPr algn="ctr" indent="0" marL="0">
-                        <a:buNone/>
-                      </a:pPr>
-                      <a:r>
-                        <a:rPr lang="en-US" sz="1000" b="1" dirty="0">
-                          <a:solidFill>
-                            <a:srgbClr val="DC2626"/>
-                          </a:solidFill>
-                          <a:latin typeface="Calibri" pitchFamily="34" charset="0"/>
-                          <a:ea typeface="Calibri" pitchFamily="34" charset="-122"/>
-                          <a:cs typeface="Calibri" pitchFamily="34" charset="-120"/>
-                        </a:rPr>
-                        <a:t>10.5%</a:t>
-                      </a:r>
-                      <a:endParaRPr lang="en-US" sz="1000" dirty="0">
-                        <a:latin typeface="Calibri" charset="0"/>
-                        <a:ea typeface="Calibri" charset="0"/>
-                        <a:cs typeface="Calibri" charset="0"/>
-                      </a:endParaRPr>
-                    </a:p>
-                  </a:txBody>
-                  <a:tcPr marL="91440" marR="91440" marT="45720" marB="45720" anchor="ctr">
-                    <a:lnL w="6350" cap="flat" cmpd="sng" algn="ctr">
-                      <a:solidFill>
-                        <a:srgbClr val="E5E7EB"/>
-                      </a:solidFill>
-                      <a:prstDash val="solid"/>
-                      <a:round/>
-                      <a:headEnd type="none" w="med" len="med"/>
-                      <a:tailEnd type="none" w="med" len="med"/>
-                    </a:lnL>
-                    <a:lnR w="6350" cap="flat" cmpd="sng" algn="ctr">
-                      <a:solidFill>
-                        <a:srgbClr val="E5E7EB"/>
-                      </a:solidFill>
-                      <a:prstDash val="solid"/>
-                      <a:round/>
-                      <a:headEnd type="none" w="med" len="med"/>
-                      <a:tailEnd type="none" w="med" len="med"/>
-                    </a:lnR>
-                    <a:lnT w="6350" cap="flat" cmpd="sng" algn="ctr">
-                      <a:solidFill>
-                        <a:srgbClr val="E5E7EB"/>
-                      </a:solidFill>
-                      <a:prstDash val="solid"/>
-                      <a:round/>
-                      <a:headEnd type="none" w="med" len="med"/>
-                      <a:tailEnd type="none" w="med" len="med"/>
-                    </a:lnT>
-                    <a:lnB w="6350" cap="flat" cmpd="sng" algn="ctr">
-                      <a:solidFill>
-                        <a:srgbClr val="E5E7EB"/>
-                      </a:solidFill>
-                      <a:prstDash val="solid"/>
-                      <a:round/>
-                      <a:headEnd type="none" w="med" len="med"/>
-                      <a:tailEnd type="none" w="med" len="med"/>
-                    </a:lnB>
-                  </a:tcPr>
-                </a:tc>
-                <a:tc>
-                  <a:txBody>
-                    <a:bodyPr/>
-                    <a:lstStyle/>
-                    <a:p>
                       <a:pPr indent="0" marL="0">
                         <a:buNone/>
                       </a:pPr>
@@ -19069,7 +19195,7 @@
                           <a:ea typeface="Calibri" pitchFamily="34" charset="-122"/>
                           <a:cs typeface="Calibri" pitchFamily="34" charset="-120"/>
                         </a:rPr>
-                        <a:t>Fails: 8 left-lung lacerations + 9 missing trachea (SH harvesting tracheas for another buyer); one passed unit labeled for a high head-vessel laceration.</a:t>
+                        <a:t>Harvest rejects: 8 left-lung lacerations + 9 missing trachea (SH harvesting tracheas for another buyer); one passed unit labeled for a high head-vessel laceration.</a:t>
                       </a:r>
                       <a:endParaRPr lang="en-US" sz="860" dirty="0">
                         <a:latin typeface="Calibri" charset="0"/>
@@ -19182,7 +19308,7 @@
                 <a:ea typeface="Calibri" pitchFamily="34" charset="-122"/>
                 <a:cs typeface="Calibri" pitchFamily="34" charset="-120"/>
               </a:rPr>
-              <a:t>Definitions</a:t>
+              <a:t>Log convention</a:t>
             </a:r>
             <a:endParaRPr lang="en-US" sz="1100" dirty="0"/>
           </a:p>
@@ -19225,7 +19351,7 @@
                 <a:ea typeface="Calibri" pitchFamily="34" charset="-122"/>
                 <a:cs typeface="Calibri" pitchFamily="34" charset="-120"/>
               </a:rPr>
-              <a:t>SH-tech yield — blocks the slaughterhouse's own tech passed ÷ received (the sheet's "FPY for SH").</a:t>
+              <a:t>Inspection 1 (before we receive): the harvest tech inspects and rejects as he harvests — those rejections never reach us.</a:t>
             </a:r>
             <a:endParaRPr lang="en-US" sz="950" dirty="0"/>
           </a:p>
@@ -19246,7 +19372,7 @@
                 <a:ea typeface="Calibri" pitchFamily="34" charset="-122"/>
                 <a:cs typeface="Calibri" pitchFamily="34" charset="-120"/>
               </a:rPr>
-              <a:t>QC accept of SH-passed — of the SH-tech-passed blocks, how many our QC tech confirmed (the sheet's "FPY for SH Tech").</a:t>
+              <a:t>Inspection 2 (after): our QC tech inspects the harvest-passed blocks. The log's # Inspected / Pass / Fail for these visits is THIS stage — harvest-stage rejects live in the notes and the stage-detail section.</a:t>
             </a:r>
             <a:endParaRPr lang="en-US" sz="950" dirty="0"/>
           </a:p>
@@ -19267,7 +19393,7 @@
                 <a:ea typeface="Calibri" pitchFamily="34" charset="-122"/>
                 <a:cs typeface="Calibri" pitchFamily="34" charset="-120"/>
               </a:rPr>
-              <a:t>Final FPY — QC final pass ÷ received; this is the number in the log, dashboards and monthly tabs. Visits before 08/26 used the standard single-stage tally.</a:t>
+              <a:t>Visits before 08/26 used the standard single-stage tally, directly comparable to Martins and Parks.</a:t>
             </a:r>
             <a:endParaRPr lang="en-US" sz="950" dirty="0"/>
           </a:p>
@@ -19371,7 +19497,7 @@
                 <a:ea typeface="Calibri" pitchFamily="34" charset="-122"/>
                 <a:cs typeface="Calibri" pitchFamily="34" charset="-120"/>
               </a:rPr>
-              <a:t>The SH's own screen now quantifies harvesting quality: 50% (8/26) → 10.5% (9/9) — their numbers, not just ours, make the harvesting-side case.</a:t>
+              <a:t>The harvest tech's reject rate quantifies harvesting quality at the source: 9 of 18 (8/26) → 17 of 19 (9/9). Their numbers, not just ours, make the harvesting-side case.</a:t>
             </a:r>
             <a:endParaRPr lang="en-US" sz="950" dirty="0"/>
           </a:p>
@@ -19392,7 +19518,7 @@
                 <a:ea typeface="Calibri" pitchFamily="34" charset="-122"/>
                 <a:cs typeface="Calibri" pitchFamily="34" charset="-120"/>
               </a:rPr>
-              <a:t>QC accepted 88.9–100% of SH-tech-passed blocks — Jordan's judgement aligns with our spec. The losses happen at harvest, not in the screening.</a:t>
+              <a:t>Our QC accepted 88.9–100% of what Jordan passed — his judgement aligns with our spec. The losses happen at harvest, not in the screening.</a:t>
             </a:r>
             <a:endParaRPr lang="en-US" sz="950" dirty="0"/>
           </a:p>
@@ -19413,7 +19539,7 @@
                 <a:ea typeface="Calibri" pitchFamily="34" charset="-122"/>
                 <a:cs typeface="Calibri" pitchFamily="34" charset="-120"/>
               </a:rPr>
-              <a:t>Watch: SH-tech yield as a leading indicator, and the missing-trachea conflict (tracheas sold to another buyer) as the newest driver.</a:t>
+              <a:t>Watch: harvest reject rate as the leading indicator, and the missing-trachea conflict (9 units on 9/9 — tracheas sold to another buyer) as the newest driver.</a:t>
             </a:r>
             <a:endParaRPr lang="en-US" sz="950" dirty="0"/>
           </a:p>

</xml_diff>

<commit_message>
QDR deck: remove Nahunta pelvic and thoracic content and related notes
Slides now cover Martins/Parks pelvic only: August summary with defect cards
and takeaways, and the pelvic SH-vs-ATM reasons slide (matched batches).
All Nahunta rows, the thoracic section, and their notes removed per request.
Workbook data untouched.

Co-Authored-By: Claude Fable 5 <noreply@anthropic.com>
Claude-Session: https://claude.ai/code/session_014UGcEfvuC9NvQ5rauRTTbR
</commit_message>
<xml_diff>
--- a/QC inspections suppliers/QDR_Slides_AugSep2026.pptx
+++ b/QC inspections suppliers/QDR_Slides_AugSep2026.pptx
@@ -129,7 +129,7 @@
               <c:strCache>
                 <c:ptCount val="1"/>
                 <c:pt idx="0">
-                  <c:v>SH issues — 10 (August)</c:v>
+                  <c:v>SH floor — 10 rejects (August)</c:v>
                 </c:pt>
               </c:strCache>
             </c:strRef>
@@ -148,7 +148,7 @@
               <a:lstStyle/>
               <a:p>
                 <a:pPr>
-                  <a:defRPr b="0" i="0" strike="noStrike" sz="800" u="none">
+                  <a:defRPr b="0" i="0" strike="noStrike" sz="1000" u="none">
                     <a:solidFill>
                       <a:srgbClr val="1F2937"/>
                     </a:solidFill>
@@ -216,7 +216,7 @@
             <a:lstStyle/>
             <a:p>
               <a:pPr>
-                <a:defRPr b="0" i="0" strike="noStrike" sz="800" u="none">
+                <a:defRPr b="0" i="0" strike="noStrike" sz="1000" u="none">
                   <a:solidFill>
                     <a:srgbClr val="1F2937"/>
                   </a:solidFill>
@@ -264,7 +264,7 @@
           <a:lstStyle/>
           <a:p>
             <a:pPr>
-              <a:defRPr sz="740" b="0" i="0" u="none" strike="noStrike">
+              <a:defRPr sz="950" b="0" i="0" u="none" strike="noStrike">
                 <a:solidFill>
                   <a:srgbClr val="1F2937"/>
                 </a:solidFill>
@@ -364,7 +364,7 @@
               <c:strCache>
                 <c:ptCount val="1"/>
                 <c:pt idx="0">
-                  <c:v>ATM scrap — 40 units · matched batches, all quality</c:v>
+                  <c:v>ATM receipt — 40 units scrapped (all quality codes)</c:v>
                 </c:pt>
               </c:strCache>
             </c:strRef>
@@ -383,7 +383,7 @@
               <a:lstStyle/>
               <a:p>
                 <a:pPr>
-                  <a:defRPr b="0" i="0" strike="noStrike" sz="800" u="none">
+                  <a:defRPr b="0" i="0" strike="noStrike" sz="1000" u="none">
                     <a:solidFill>
                       <a:srgbClr val="1F2937"/>
                     </a:solidFill>
@@ -457,7 +457,7 @@
             <a:lstStyle/>
             <a:p>
               <a:pPr>
-                <a:defRPr b="0" i="0" strike="noStrike" sz="800" u="none">
+                <a:defRPr b="0" i="0" strike="noStrike" sz="1000" u="none">
                   <a:solidFill>
                     <a:srgbClr val="1F2937"/>
                   </a:solidFill>
@@ -505,453 +505,7 @@
           <a:lstStyle/>
           <a:p>
             <a:pPr>
-              <a:defRPr sz="740" b="0" i="0" u="none" strike="noStrike">
-                <a:solidFill>
-                  <a:srgbClr val="1F2937"/>
-                </a:solidFill>
-                <a:latin typeface="Calibri"/>
-              </a:defRPr>
-            </a:pPr>
-            <a:endParaRPr lang="en-US"/>
-          </a:p>
-        </c:txPr>
-        <c:crossAx val="2094734552"/>
-        <c:crosses val="autoZero"/>
-        <c:auto val="1"/>
-        <c:lblAlgn val="ctr"/>
-        <c:noMultiLvlLbl val="1"/>
-      </c:catAx>
-      <c:valAx>
-        <c:axId val="2094734552"/>
-        <c:scaling>
-          <c:orientation val="minMax"/>
-        </c:scaling>
-        <c:delete val="1"/>
-        <c:axPos val="b"/>
-        <c:numFmt formatCode="General" sourceLinked="0"/>
-        <c:majorTickMark val="out"/>
-        <c:minorTickMark val="none"/>
-        <c:tickLblPos val="low"/>
-        <c:spPr>
-          <a:ln w="12700" cap="flat">
-            <a:solidFill>
-              <a:srgbClr val="888888"/>
-            </a:solidFill>
-            <a:prstDash val="solid"/>
-            <a:round/>
-          </a:ln>
-        </c:spPr>
-        <c:txPr>
-          <a:bodyPr/>
-          <a:lstStyle/>
-          <a:p>
-            <a:pPr>
-              <a:defRPr sz="1200" b="0" i="0" u="none" strike="noStrike">
-                <a:solidFill>
-                  <a:srgbClr val="000000"/>
-                </a:solidFill>
-                <a:latin typeface="Arial"/>
-              </a:defRPr>
-            </a:pPr>
-            <a:endParaRPr lang="en-US"/>
-          </a:p>
-        </c:txPr>
-        <c:crossAx val="2094734554"/>
-        <c:crosses val="autoZero"/>
-        <c:crossBetween val="between"/>
-      </c:valAx>
-      <c:spPr>
-        <a:noFill/>
-        <a:ln>
-          <a:noFill/>
-        </a:ln>
-        <a:effectLst/>
-      </c:spPr>
-    </c:plotArea>
-    <c:plotVisOnly val="1"/>
-    <c:dispBlanksAs val="span"/>
-  </c:chart>
-  <c:spPr>
-    <a:noFill/>
-    <a:ln>
-      <a:noFill/>
-    </a:ln>
-    <a:effectLst/>
-  </c:spPr>
-  <c:externalData r:id="rId1">
-    <c:autoUpdate val="0"/>
-  </c:externalData>
-</c:chartSpace>
-</file>
-
-<file path=ppt/charts/chart3.xml><?xml version="1.0" encoding="utf-8"?>
-<c:chartSpace xmlns:c="http://schemas.openxmlformats.org/drawingml/2006/chart" xmlns:a="http://schemas.openxmlformats.org/drawingml/2006/main" xmlns:r="http://schemas.openxmlformats.org/officeDocument/2006/relationships">
-  <c:date1904 val="0"/>
-  <c:roundedCorners val="1"/>
-  <c:chart>
-    <c:autoTitleDeleted val="1"/>
-    <c:plotArea>
-      <c:layout/>
-      <c:barChart>
-        <c:barDir val="bar"/>
-        <c:grouping val="clustered"/>
-        <c:varyColors val="0"/>
-        <c:ser>
-          <c:idx val="0"/>
-          <c:order val="0"/>
-          <c:tx>
-            <c:strRef>
-              <c:f>Sheet1!$B$1</c:f>
-              <c:strCache>
-                <c:ptCount val="1"/>
-                <c:pt idx="0">
-                  <c:v>SH issues — 51 tags on 50 QC fails (August)</c:v>
-                </c:pt>
-              </c:strCache>
-            </c:strRef>
-          </c:tx>
-          <c:spPr>
-            <a:solidFill>
-              <a:srgbClr val="1F2937"/>
-            </a:solidFill>
-            <a:effectLst/>
-          </c:spPr>
-          <c:invertIfNegative val="0"/>
-          <c:dLbls>
-            <c:numFmt formatCode="0" sourceLinked="0"/>
-            <c:txPr>
-              <a:bodyPr/>
-              <a:lstStyle/>
-              <a:p>
-                <a:pPr>
-                  <a:defRPr b="0" i="0" strike="noStrike" sz="800" u="none">
-                    <a:solidFill>
-                      <a:srgbClr val="1F2937"/>
-                    </a:solidFill>
-                    <a:latin typeface="Calibri"/>
-                  </a:defRPr>
-                </a:pPr>
-              </a:p>
-            </c:txPr>
-            <c:showLegendKey val="0"/>
-            <c:showVal val="1"/>
-            <c:showCatName val="0"/>
-            <c:showSerName val="0"/>
-            <c:showPercent val="0"/>
-            <c:showBubbleSize val="0"/>
-            <c:showLeaderLines val="0"/>
-          </c:dLbls>
-          <c:cat>
-            <c:multiLvlStrRef>
-              <c:f>Sheet1!$A$2:$A$4</c:f>
-              <c:multiLvlStrCache>
-                <c:ptCount val="3"/>
-                <c:lvl>
-                  <c:pt idx="0">
-                    <c:v>Undocumented / not itemized</c:v>
-                  </c:pt>
-                  <c:pt idx="1">
-                    <c:v>Heart damage</c:v>
-                  </c:pt>
-                  <c:pt idx="2">
-                    <c:v>Lung laceration</c:v>
-                  </c:pt>
-                </c:lvl>
-              </c:multiLvlStrCache>
-            </c:multiLvlStrRef>
-          </c:cat>
-          <c:val>
-            <c:numRef>
-              <c:f>Sheet1!$B$2:$B$4</c:f>
-              <c:numCache>
-                <c:formatCode>General</c:formatCode>
-                <c:ptCount val="3"/>
-                <c:pt idx="0">
-                  <c:v>1</c:v>
-                </c:pt>
-                <c:pt idx="1">
-                  <c:v>19</c:v>
-                </c:pt>
-                <c:pt idx="2">
-                  <c:v>31</c:v>
-                </c:pt>
-              </c:numCache>
-            </c:numRef>
-          </c:val>
-        </c:ser>
-        <c:dLbls>
-          <c:numFmt formatCode="0" sourceLinked="0"/>
-          <c:txPr>
-            <a:bodyPr/>
-            <a:lstStyle/>
-            <a:p>
-              <a:pPr>
-                <a:defRPr b="0" i="0" strike="noStrike" sz="800" u="none">
-                  <a:solidFill>
-                    <a:srgbClr val="1F2937"/>
-                  </a:solidFill>
-                  <a:latin typeface="Calibri"/>
-                </a:defRPr>
-              </a:pPr>
-            </a:p>
-          </c:txPr>
-          <c:showLegendKey val="0"/>
-          <c:showVal val="1"/>
-          <c:showCatName val="0"/>
-          <c:showSerName val="0"/>
-          <c:showPercent val="0"/>
-          <c:showBubbleSize val="0"/>
-          <c:showLeaderLines val="0"/>
-        </c:dLbls>
-        <c:gapWidth val="150"/>
-        <c:overlap val="0"/>
-        <c:axId val="2094734554"/>
-        <c:axId val="2094734552"/>
-        <c:axId val="2094734556"/>
-      </c:barChart>
-      <c:catAx>
-        <c:axId val="2094734554"/>
-        <c:scaling>
-          <c:orientation val="minMax"/>
-        </c:scaling>
-        <c:delete val="0"/>
-        <c:axPos val="l"/>
-        <c:numFmt formatCode="General" sourceLinked="1"/>
-        <c:majorTickMark val="out"/>
-        <c:minorTickMark val="none"/>
-        <c:tickLblPos val="nextTo"/>
-        <c:spPr>
-          <a:ln w="12700" cap="flat">
-            <a:solidFill>
-              <a:srgbClr val="888888"/>
-            </a:solidFill>
-            <a:prstDash val="solid"/>
-            <a:round/>
-          </a:ln>
-        </c:spPr>
-        <c:txPr>
-          <a:bodyPr/>
-          <a:lstStyle/>
-          <a:p>
-            <a:pPr>
-              <a:defRPr sz="740" b="0" i="0" u="none" strike="noStrike">
-                <a:solidFill>
-                  <a:srgbClr val="1F2937"/>
-                </a:solidFill>
-                <a:latin typeface="Calibri"/>
-              </a:defRPr>
-            </a:pPr>
-            <a:endParaRPr lang="en-US"/>
-          </a:p>
-        </c:txPr>
-        <c:crossAx val="2094734552"/>
-        <c:crosses val="autoZero"/>
-        <c:auto val="1"/>
-        <c:lblAlgn val="ctr"/>
-        <c:noMultiLvlLbl val="1"/>
-      </c:catAx>
-      <c:valAx>
-        <c:axId val="2094734552"/>
-        <c:scaling>
-          <c:orientation val="minMax"/>
-        </c:scaling>
-        <c:delete val="1"/>
-        <c:axPos val="b"/>
-        <c:numFmt formatCode="General" sourceLinked="0"/>
-        <c:majorTickMark val="out"/>
-        <c:minorTickMark val="none"/>
-        <c:tickLblPos val="low"/>
-        <c:spPr>
-          <a:ln w="12700" cap="flat">
-            <a:solidFill>
-              <a:srgbClr val="888888"/>
-            </a:solidFill>
-            <a:prstDash val="solid"/>
-            <a:round/>
-          </a:ln>
-        </c:spPr>
-        <c:txPr>
-          <a:bodyPr/>
-          <a:lstStyle/>
-          <a:p>
-            <a:pPr>
-              <a:defRPr sz="1200" b="0" i="0" u="none" strike="noStrike">
-                <a:solidFill>
-                  <a:srgbClr val="000000"/>
-                </a:solidFill>
-                <a:latin typeface="Arial"/>
-              </a:defRPr>
-            </a:pPr>
-            <a:endParaRPr lang="en-US"/>
-          </a:p>
-        </c:txPr>
-        <c:crossAx val="2094734554"/>
-        <c:crosses val="autoZero"/>
-        <c:crossBetween val="between"/>
-      </c:valAx>
-      <c:spPr>
-        <a:noFill/>
-        <a:ln>
-          <a:noFill/>
-        </a:ln>
-        <a:effectLst/>
-      </c:spPr>
-    </c:plotArea>
-    <c:plotVisOnly val="1"/>
-    <c:dispBlanksAs val="span"/>
-  </c:chart>
-  <c:spPr>
-    <a:noFill/>
-    <a:ln>
-      <a:noFill/>
-    </a:ln>
-    <a:effectLst/>
-  </c:spPr>
-  <c:externalData r:id="rId1">
-    <c:autoUpdate val="0"/>
-  </c:externalData>
-</c:chartSpace>
-</file>
-
-<file path=ppt/charts/chart4.xml><?xml version="1.0" encoding="utf-8"?>
-<c:chartSpace xmlns:c="http://schemas.openxmlformats.org/drawingml/2006/chart" xmlns:a="http://schemas.openxmlformats.org/drawingml/2006/main" xmlns:r="http://schemas.openxmlformats.org/officeDocument/2006/relationships">
-  <c:date1904 val="0"/>
-  <c:roundedCorners val="1"/>
-  <c:chart>
-    <c:autoTitleDeleted val="1"/>
-    <c:plotArea>
-      <c:layout/>
-      <c:barChart>
-        <c:barDir val="bar"/>
-        <c:grouping val="clustered"/>
-        <c:varyColors val="0"/>
-        <c:ser>
-          <c:idx val="0"/>
-          <c:order val="0"/>
-          <c:tx>
-            <c:strRef>
-              <c:f>Sheet1!$B$1</c:f>
-              <c:strCache>
-                <c:ptCount val="1"/>
-                <c:pt idx="0">
-                  <c:v>ATM scrap — 24 units · matched batches, all quality</c:v>
-                </c:pt>
-              </c:strCache>
-            </c:strRef>
-          </c:tx>
-          <c:spPr>
-            <a:solidFill>
-              <a:srgbClr val="0E7490"/>
-            </a:solidFill>
-            <a:effectLst/>
-          </c:spPr>
-          <c:invertIfNegative val="0"/>
-          <c:dLbls>
-            <c:numFmt formatCode="0" sourceLinked="0"/>
-            <c:txPr>
-              <a:bodyPr/>
-              <a:lstStyle/>
-              <a:p>
-                <a:pPr>
-                  <a:defRPr b="0" i="0" strike="noStrike" sz="800" u="none">
-                    <a:solidFill>
-                      <a:srgbClr val="1F2937"/>
-                    </a:solidFill>
-                    <a:latin typeface="Calibri"/>
-                  </a:defRPr>
-                </a:pPr>
-              </a:p>
-            </c:txPr>
-            <c:showLegendKey val="0"/>
-            <c:showVal val="1"/>
-            <c:showCatName val="0"/>
-            <c:showSerName val="0"/>
-            <c:showPercent val="0"/>
-            <c:showBubbleSize val="0"/>
-            <c:showLeaderLines val="0"/>
-          </c:dLbls>
-          <c:cat>
-            <c:multiLvlStrRef>
-              <c:f>Sheet1!$A$2:$A$2</c:f>
-              <c:multiLvlStrCache>
-                <c:ptCount val="1"/>
-                <c:lvl>
-                  <c:pt idx="0">
-                    <c:v>9972 · Laceration/Cut</c:v>
-                  </c:pt>
-                </c:lvl>
-              </c:multiLvlStrCache>
-            </c:multiLvlStrRef>
-          </c:cat>
-          <c:val>
-            <c:numRef>
-              <c:f>Sheet1!$B$2:$B$2</c:f>
-              <c:numCache>
-                <c:formatCode>General</c:formatCode>
-                <c:ptCount val="1"/>
-                <c:pt idx="0">
-                  <c:v>24</c:v>
-                </c:pt>
-              </c:numCache>
-            </c:numRef>
-          </c:val>
-        </c:ser>
-        <c:dLbls>
-          <c:numFmt formatCode="0" sourceLinked="0"/>
-          <c:txPr>
-            <a:bodyPr/>
-            <a:lstStyle/>
-            <a:p>
-              <a:pPr>
-                <a:defRPr b="0" i="0" strike="noStrike" sz="800" u="none">
-                  <a:solidFill>
-                    <a:srgbClr val="1F2937"/>
-                  </a:solidFill>
-                  <a:latin typeface="Calibri"/>
-                </a:defRPr>
-              </a:pPr>
-            </a:p>
-          </c:txPr>
-          <c:showLegendKey val="0"/>
-          <c:showVal val="1"/>
-          <c:showCatName val="0"/>
-          <c:showSerName val="0"/>
-          <c:showPercent val="0"/>
-          <c:showBubbleSize val="0"/>
-          <c:showLeaderLines val="0"/>
-        </c:dLbls>
-        <c:gapWidth val="150"/>
-        <c:overlap val="0"/>
-        <c:axId val="2094734554"/>
-        <c:axId val="2094734552"/>
-        <c:axId val="2094734556"/>
-      </c:barChart>
-      <c:catAx>
-        <c:axId val="2094734554"/>
-        <c:scaling>
-          <c:orientation val="minMax"/>
-        </c:scaling>
-        <c:delete val="0"/>
-        <c:axPos val="l"/>
-        <c:numFmt formatCode="General" sourceLinked="1"/>
-        <c:majorTickMark val="out"/>
-        <c:minorTickMark val="none"/>
-        <c:tickLblPos val="nextTo"/>
-        <c:spPr>
-          <a:ln w="12700" cap="flat">
-            <a:solidFill>
-              <a:srgbClr val="888888"/>
-            </a:solidFill>
-            <a:prstDash val="solid"/>
-            <a:round/>
-          </a:ln>
-        </c:spPr>
-        <c:txPr>
-          <a:bodyPr/>
-          <a:lstStyle/>
-          <a:p>
-            <a:pPr>
-              <a:defRPr sz="740" b="0" i="0" u="none" strike="noStrike">
+              <a:defRPr sz="950" b="0" i="0" u="none" strike="noStrike">
                 <a:solidFill>
                   <a:srgbClr val="1F2937"/>
                 </a:solidFill>
@@ -1919,7 +1473,7 @@
                 <a:ea typeface="Calibri" pitchFamily="34" charset="-122"/>
                 <a:cs typeface="Calibri" pitchFamily="34" charset="-120"/>
               </a:rPr>
-              <a:t>QDR  ·  AUGUST 2026  (+ SEPTEMBER TO DATE)</a:t>
+              <a:t>QDR  ·  AUGUST 2026</a:t>
             </a:r>
             <a:endParaRPr lang="en-US" sz="1100" dirty="0"/>
           </a:p>
@@ -1979,7 +1533,7 @@
           </p:nvPr>
         </p:nvGraphicFramePr>
         <p:xfrm>
-          <a:off x="502920" y="1207008"/>
+          <a:off x="502920" y="1234440"/>
           <a:ext cx="11183112" cy="914400"/>
         </p:xfrm>
         <a:graphic>
@@ -1995,7 +1549,7 @@
                 <a:gridCol w="1371600"/>
                 <a:gridCol w="4233672"/>
               </a:tblGrid>
-              <a:tr h="310896">
+              <a:tr h="384048">
                 <a:tc>
                   <a:txBody>
                     <a:bodyPr/>
@@ -2005,7 +1559,7 @@
                         <a:buNone/>
                       </a:pPr>
                       <a:r>
-                        <a:rPr lang="en-US" sz="1100" b="1" dirty="0">
+                        <a:rPr lang="en-US" sz="1150" b="1" dirty="0">
                           <a:solidFill>
                             <a:srgbClr val="FFFFFF"/>
                           </a:solidFill>
@@ -2015,7 +1569,7 @@
                         </a:rPr>
                         <a:t>Tissue @ SH</a:t>
                       </a:r>
-                      <a:endParaRPr lang="en-US" sz="1100" dirty="0">
+                      <a:endParaRPr lang="en-US" sz="1150" dirty="0">
                         <a:latin typeface="Calibri" charset="0"/>
                         <a:ea typeface="Calibri" charset="0"/>
                         <a:cs typeface="Calibri" charset="0"/>
@@ -2073,7 +1627,7 @@
                         <a:buNone/>
                       </a:pPr>
                       <a:r>
-                        <a:rPr lang="en-US" sz="1100" b="1" dirty="0">
+                        <a:rPr lang="en-US" sz="1150" b="1" dirty="0">
                           <a:solidFill>
                             <a:srgbClr val="FFFFFF"/>
                           </a:solidFill>
@@ -2083,7 +1637,7 @@
                         </a:rPr>
                         <a:t>Part #</a:t>
                       </a:r>
-                      <a:endParaRPr lang="en-US" sz="1100" dirty="0">
+                      <a:endParaRPr lang="en-US" sz="1150" dirty="0">
                         <a:latin typeface="Calibri" charset="0"/>
                         <a:ea typeface="Calibri" charset="0"/>
                         <a:cs typeface="Calibri" charset="0"/>
@@ -2141,7 +1695,7 @@
                         <a:buNone/>
                       </a:pPr>
                       <a:r>
-                        <a:rPr lang="en-US" sz="1100" b="1" dirty="0">
+                        <a:rPr lang="en-US" sz="1150" b="1" dirty="0">
                           <a:solidFill>
                             <a:srgbClr val="FFFFFF"/>
                           </a:solidFill>
@@ -2151,7 +1705,7 @@
                         </a:rPr>
                         <a:t># Inspected</a:t>
                       </a:r>
-                      <a:endParaRPr lang="en-US" sz="1100" dirty="0">
+                      <a:endParaRPr lang="en-US" sz="1150" dirty="0">
                         <a:latin typeface="Calibri" charset="0"/>
                         <a:ea typeface="Calibri" charset="0"/>
                         <a:cs typeface="Calibri" charset="0"/>
@@ -2209,7 +1763,7 @@
                         <a:buNone/>
                       </a:pPr>
                       <a:r>
-                        <a:rPr lang="en-US" sz="1100" b="1" dirty="0">
+                        <a:rPr lang="en-US" sz="1150" b="1" dirty="0">
                           <a:solidFill>
                             <a:srgbClr val="FFFFFF"/>
                           </a:solidFill>
@@ -2219,7 +1773,7 @@
                         </a:rPr>
                         <a:t># Pass</a:t>
                       </a:r>
-                      <a:endParaRPr lang="en-US" sz="1100" dirty="0">
+                      <a:endParaRPr lang="en-US" sz="1150" dirty="0">
                         <a:latin typeface="Calibri" charset="0"/>
                         <a:ea typeface="Calibri" charset="0"/>
                         <a:cs typeface="Calibri" charset="0"/>
@@ -2277,7 +1831,7 @@
                         <a:buNone/>
                       </a:pPr>
                       <a:r>
-                        <a:rPr lang="en-US" sz="1100" b="1" dirty="0">
+                        <a:rPr lang="en-US" sz="1150" b="1" dirty="0">
                           <a:solidFill>
                             <a:srgbClr val="FFFFFF"/>
                           </a:solidFill>
@@ -2287,7 +1841,7 @@
                         </a:rPr>
                         <a:t># Fail</a:t>
                       </a:r>
-                      <a:endParaRPr lang="en-US" sz="1100" dirty="0">
+                      <a:endParaRPr lang="en-US" sz="1150" dirty="0">
                         <a:latin typeface="Calibri" charset="0"/>
                         <a:ea typeface="Calibri" charset="0"/>
                         <a:cs typeface="Calibri" charset="0"/>
@@ -2345,7 +1899,7 @@
                         <a:buNone/>
                       </a:pPr>
                       <a:r>
-                        <a:rPr lang="en-US" sz="1100" b="1" dirty="0">
+                        <a:rPr lang="en-US" sz="1150" b="1" dirty="0">
                           <a:solidFill>
                             <a:srgbClr val="FFFFFF"/>
                           </a:solidFill>
@@ -2355,7 +1909,7 @@
                         </a:rPr>
                         <a:t>First-Pass Yield</a:t>
                       </a:r>
-                      <a:endParaRPr lang="en-US" sz="1100" dirty="0">
+                      <a:endParaRPr lang="en-US" sz="1150" dirty="0">
                         <a:latin typeface="Calibri" charset="0"/>
                         <a:ea typeface="Calibri" charset="0"/>
                         <a:cs typeface="Calibri" charset="0"/>
@@ -2413,7 +1967,7 @@
                         <a:buNone/>
                       </a:pPr>
                       <a:r>
-                        <a:rPr lang="en-US" sz="1100" b="1" dirty="0">
+                        <a:rPr lang="en-US" sz="1150" b="1" dirty="0">
                           <a:solidFill>
                             <a:srgbClr val="FFFFFF"/>
                           </a:solidFill>
@@ -2423,7 +1977,7 @@
                         </a:rPr>
                         <a:t>Top defect this month</a:t>
                       </a:r>
-                      <a:endParaRPr lang="en-US" sz="1100" dirty="0">
+                      <a:endParaRPr lang="en-US" sz="1150" dirty="0">
                         <a:latin typeface="Calibri" charset="0"/>
                         <a:ea typeface="Calibri" charset="0"/>
                         <a:cs typeface="Calibri" charset="0"/>
@@ -2473,7 +2027,7 @@
                   </a:tcPr>
                 </a:tc>
               </a:tr>
-              <a:tr h="310896">
+              <a:tr h="384048">
                 <a:tc>
                   <a:txBody>
                     <a:bodyPr/>
@@ -2483,7 +2037,7 @@
                         <a:buNone/>
                       </a:pPr>
                       <a:r>
-                        <a:rPr lang="en-US" sz="1100" b="1" dirty="0">
+                        <a:rPr lang="en-US" sz="1150" b="1" dirty="0">
                           <a:solidFill>
                             <a:srgbClr val="000000"/>
                           </a:solidFill>
@@ -2493,7 +2047,7 @@
                         </a:rPr>
                         <a:t>Pelvic @ Martins</a:t>
                       </a:r>
-                      <a:endParaRPr lang="en-US" sz="1100" dirty="0">
+                      <a:endParaRPr lang="en-US" sz="1150" dirty="0">
                         <a:latin typeface="Calibri" charset="0"/>
                         <a:ea typeface="Calibri" charset="0"/>
                         <a:cs typeface="Calibri" charset="0"/>
@@ -2548,7 +2102,7 @@
                         <a:buNone/>
                       </a:pPr>
                       <a:r>
-                        <a:rPr lang="en-US" sz="1100" dirty="0">
+                        <a:rPr lang="en-US" sz="1150" dirty="0">
                           <a:solidFill>
                             <a:srgbClr val="6B7280"/>
                           </a:solidFill>
@@ -2558,7 +2112,7 @@
                         </a:rPr>
                         <a:t>666541</a:t>
                       </a:r>
-                      <a:endParaRPr lang="en-US" sz="1100" dirty="0">
+                      <a:endParaRPr lang="en-US" sz="1150" dirty="0">
                         <a:latin typeface="Calibri" charset="0"/>
                         <a:ea typeface="Calibri" charset="0"/>
                         <a:cs typeface="Calibri" charset="0"/>
@@ -2613,7 +2167,7 @@
                         <a:buNone/>
                       </a:pPr>
                       <a:r>
-                        <a:rPr lang="en-US" sz="1100" dirty="0">
+                        <a:rPr lang="en-US" sz="1150" dirty="0">
                           <a:solidFill>
                             <a:srgbClr val="000000"/>
                           </a:solidFill>
@@ -2623,7 +2177,7 @@
                         </a:rPr>
                         <a:t>198</a:t>
                       </a:r>
-                      <a:endParaRPr lang="en-US" sz="1100" dirty="0">
+                      <a:endParaRPr lang="en-US" sz="1150" dirty="0">
                         <a:latin typeface="Calibri" charset="0"/>
                         <a:ea typeface="Calibri" charset="0"/>
                         <a:cs typeface="Calibri" charset="0"/>
@@ -2678,7 +2232,7 @@
                         <a:buNone/>
                       </a:pPr>
                       <a:r>
-                        <a:rPr lang="en-US" sz="1100" dirty="0">
+                        <a:rPr lang="en-US" sz="1150" dirty="0">
                           <a:solidFill>
                             <a:srgbClr val="000000"/>
                           </a:solidFill>
@@ -2688,7 +2242,7 @@
                         </a:rPr>
                         <a:t>190</a:t>
                       </a:r>
-                      <a:endParaRPr lang="en-US" sz="1100" dirty="0">
+                      <a:endParaRPr lang="en-US" sz="1150" dirty="0">
                         <a:latin typeface="Calibri" charset="0"/>
                         <a:ea typeface="Calibri" charset="0"/>
                         <a:cs typeface="Calibri" charset="0"/>
@@ -2743,7 +2297,7 @@
                         <a:buNone/>
                       </a:pPr>
                       <a:r>
-                        <a:rPr lang="en-US" sz="1100" dirty="0">
+                        <a:rPr lang="en-US" sz="1150" dirty="0">
                           <a:solidFill>
                             <a:srgbClr val="000000"/>
                           </a:solidFill>
@@ -2753,7 +2307,7 @@
                         </a:rPr>
                         <a:t>8</a:t>
                       </a:r>
-                      <a:endParaRPr lang="en-US" sz="1100" dirty="0">
+                      <a:endParaRPr lang="en-US" sz="1150" dirty="0">
                         <a:latin typeface="Calibri" charset="0"/>
                         <a:ea typeface="Calibri" charset="0"/>
                         <a:cs typeface="Calibri" charset="0"/>
@@ -2808,7 +2362,7 @@
                         <a:buNone/>
                       </a:pPr>
                       <a:r>
-                        <a:rPr lang="en-US" sz="1100" b="1" dirty="0">
+                        <a:rPr lang="en-US" sz="1150" b="1" dirty="0">
                           <a:solidFill>
                             <a:srgbClr val="15803D"/>
                           </a:solidFill>
@@ -2818,7 +2372,7 @@
                         </a:rPr>
                         <a:t>95.96%</a:t>
                       </a:r>
-                      <a:endParaRPr lang="en-US" sz="1100" dirty="0">
+                      <a:endParaRPr lang="en-US" sz="1150" dirty="0">
                         <a:latin typeface="Calibri" charset="0"/>
                         <a:ea typeface="Calibri" charset="0"/>
                         <a:cs typeface="Calibri" charset="0"/>
@@ -2876,7 +2430,7 @@
                         <a:buNone/>
                       </a:pPr>
                       <a:r>
-                        <a:rPr lang="en-US" sz="950" dirty="0">
+                        <a:rPr lang="en-US" sz="1150" dirty="0">
                           <a:solidFill>
                             <a:srgbClr val="000000"/>
                           </a:solidFill>
@@ -2886,7 +2440,7 @@
                         </a:rPr>
                         <a:t>Urethra / bladder damage (3)</a:t>
                       </a:r>
-                      <a:endParaRPr lang="en-US" sz="950" dirty="0">
+                      <a:endParaRPr lang="en-US" sz="1150" dirty="0">
                         <a:latin typeface="Calibri" charset="0"/>
                         <a:ea typeface="Calibri" charset="0"/>
                         <a:cs typeface="Calibri" charset="0"/>
@@ -2933,7 +2487,7 @@
                   </a:tcPr>
                 </a:tc>
               </a:tr>
-              <a:tr h="310896">
+              <a:tr h="384048">
                 <a:tc>
                   <a:txBody>
                     <a:bodyPr/>
@@ -2943,7 +2497,7 @@
                         <a:buNone/>
                       </a:pPr>
                       <a:r>
-                        <a:rPr lang="en-US" sz="1100" b="1" dirty="0">
+                        <a:rPr lang="en-US" sz="1150" b="1" dirty="0">
                           <a:solidFill>
                             <a:srgbClr val="000000"/>
                           </a:solidFill>
@@ -2953,7 +2507,7 @@
                         </a:rPr>
                         <a:t>Pelvic @ Martins</a:t>
                       </a:r>
-                      <a:endParaRPr lang="en-US" sz="1100" dirty="0">
+                      <a:endParaRPr lang="en-US" sz="1150" dirty="0">
                         <a:latin typeface="Calibri" charset="0"/>
                         <a:ea typeface="Calibri" charset="0"/>
                         <a:cs typeface="Calibri" charset="0"/>
@@ -3008,7 +2562,7 @@
                         <a:buNone/>
                       </a:pPr>
                       <a:r>
-                        <a:rPr lang="en-US" sz="1100" dirty="0">
+                        <a:rPr lang="en-US" sz="1150" dirty="0">
                           <a:solidFill>
                             <a:srgbClr val="6B7280"/>
                           </a:solidFill>
@@ -3018,7 +2572,7 @@
                         </a:rPr>
                         <a:t>666506</a:t>
                       </a:r>
-                      <a:endParaRPr lang="en-US" sz="1100" dirty="0">
+                      <a:endParaRPr lang="en-US" sz="1150" dirty="0">
                         <a:latin typeface="Calibri" charset="0"/>
                         <a:ea typeface="Calibri" charset="0"/>
                         <a:cs typeface="Calibri" charset="0"/>
@@ -3073,7 +2627,7 @@
                         <a:buNone/>
                       </a:pPr>
                       <a:r>
-                        <a:rPr lang="en-US" sz="1100" dirty="0">
+                        <a:rPr lang="en-US" sz="1150" dirty="0">
                           <a:solidFill>
                             <a:srgbClr val="000000"/>
                           </a:solidFill>
@@ -3083,7 +2637,7 @@
                         </a:rPr>
                         <a:t>20</a:t>
                       </a:r>
-                      <a:endParaRPr lang="en-US" sz="1100" dirty="0">
+                      <a:endParaRPr lang="en-US" sz="1150" dirty="0">
                         <a:latin typeface="Calibri" charset="0"/>
                         <a:ea typeface="Calibri" charset="0"/>
                         <a:cs typeface="Calibri" charset="0"/>
@@ -3138,7 +2692,7 @@
                         <a:buNone/>
                       </a:pPr>
                       <a:r>
-                        <a:rPr lang="en-US" sz="1100" dirty="0">
+                        <a:rPr lang="en-US" sz="1150" dirty="0">
                           <a:solidFill>
                             <a:srgbClr val="000000"/>
                           </a:solidFill>
@@ -3148,7 +2702,7 @@
                         </a:rPr>
                         <a:t>20</a:t>
                       </a:r>
-                      <a:endParaRPr lang="en-US" sz="1100" dirty="0">
+                      <a:endParaRPr lang="en-US" sz="1150" dirty="0">
                         <a:latin typeface="Calibri" charset="0"/>
                         <a:ea typeface="Calibri" charset="0"/>
                         <a:cs typeface="Calibri" charset="0"/>
@@ -3203,7 +2757,7 @@
                         <a:buNone/>
                       </a:pPr>
                       <a:r>
-                        <a:rPr lang="en-US" sz="1100" dirty="0">
+                        <a:rPr lang="en-US" sz="1150" dirty="0">
                           <a:solidFill>
                             <a:srgbClr val="000000"/>
                           </a:solidFill>
@@ -3213,7 +2767,7 @@
                         </a:rPr>
                         <a:t>0</a:t>
                       </a:r>
-                      <a:endParaRPr lang="en-US" sz="1100" dirty="0">
+                      <a:endParaRPr lang="en-US" sz="1150" dirty="0">
                         <a:latin typeface="Calibri" charset="0"/>
                         <a:ea typeface="Calibri" charset="0"/>
                         <a:cs typeface="Calibri" charset="0"/>
@@ -3268,7 +2822,7 @@
                         <a:buNone/>
                       </a:pPr>
                       <a:r>
-                        <a:rPr lang="en-US" sz="1100" b="1" dirty="0">
+                        <a:rPr lang="en-US" sz="1150" b="1" dirty="0">
                           <a:solidFill>
                             <a:srgbClr val="15803D"/>
                           </a:solidFill>
@@ -3278,7 +2832,7 @@
                         </a:rPr>
                         <a:t>100.00%</a:t>
                       </a:r>
-                      <a:endParaRPr lang="en-US" sz="1100" dirty="0">
+                      <a:endParaRPr lang="en-US" sz="1150" dirty="0">
                         <a:latin typeface="Calibri" charset="0"/>
                         <a:ea typeface="Calibri" charset="0"/>
                         <a:cs typeface="Calibri" charset="0"/>
@@ -3336,7 +2890,7 @@
                         <a:buNone/>
                       </a:pPr>
                       <a:r>
-                        <a:rPr lang="en-US" sz="950" dirty="0">
+                        <a:rPr lang="en-US" sz="1150" dirty="0">
                           <a:solidFill>
                             <a:srgbClr val="000000"/>
                           </a:solidFill>
@@ -3346,7 +2900,7 @@
                         </a:rPr>
                         <a:t>—</a:t>
                       </a:r>
-                      <a:endParaRPr lang="en-US" sz="950" dirty="0">
+                      <a:endParaRPr lang="en-US" sz="1150" dirty="0">
                         <a:latin typeface="Calibri" charset="0"/>
                         <a:ea typeface="Calibri" charset="0"/>
                         <a:cs typeface="Calibri" charset="0"/>
@@ -3393,7 +2947,7 @@
                   </a:tcPr>
                 </a:tc>
               </a:tr>
-              <a:tr h="310896">
+              <a:tr h="384048">
                 <a:tc>
                   <a:txBody>
                     <a:bodyPr/>
@@ -3403,7 +2957,7 @@
                         <a:buNone/>
                       </a:pPr>
                       <a:r>
-                        <a:rPr lang="en-US" sz="1100" b="1" dirty="0">
+                        <a:rPr lang="en-US" sz="1150" b="1" dirty="0">
                           <a:solidFill>
                             <a:srgbClr val="000000"/>
                           </a:solidFill>
@@ -3413,7 +2967,7 @@
                         </a:rPr>
                         <a:t>Pelvic @ Parks</a:t>
                       </a:r>
-                      <a:endParaRPr lang="en-US" sz="1100" dirty="0">
+                      <a:endParaRPr lang="en-US" sz="1150" dirty="0">
                         <a:latin typeface="Calibri" charset="0"/>
                         <a:ea typeface="Calibri" charset="0"/>
                         <a:cs typeface="Calibri" charset="0"/>
@@ -3468,7 +3022,7 @@
                         <a:buNone/>
                       </a:pPr>
                       <a:r>
-                        <a:rPr lang="en-US" sz="1100" dirty="0">
+                        <a:rPr lang="en-US" sz="1150" dirty="0">
                           <a:solidFill>
                             <a:srgbClr val="6B7280"/>
                           </a:solidFill>
@@ -3478,7 +3032,7 @@
                         </a:rPr>
                         <a:t>666541</a:t>
                       </a:r>
-                      <a:endParaRPr lang="en-US" sz="1100" dirty="0">
+                      <a:endParaRPr lang="en-US" sz="1150" dirty="0">
                         <a:latin typeface="Calibri" charset="0"/>
                         <a:ea typeface="Calibri" charset="0"/>
                         <a:cs typeface="Calibri" charset="0"/>
@@ -3533,7 +3087,7 @@
                         <a:buNone/>
                       </a:pPr>
                       <a:r>
-                        <a:rPr lang="en-US" sz="1100" dirty="0">
+                        <a:rPr lang="en-US" sz="1150" dirty="0">
                           <a:solidFill>
                             <a:srgbClr val="000000"/>
                           </a:solidFill>
@@ -3543,7 +3097,7 @@
                         </a:rPr>
                         <a:t>46</a:t>
                       </a:r>
-                      <a:endParaRPr lang="en-US" sz="1100" dirty="0">
+                      <a:endParaRPr lang="en-US" sz="1150" dirty="0">
                         <a:latin typeface="Calibri" charset="0"/>
                         <a:ea typeface="Calibri" charset="0"/>
                         <a:cs typeface="Calibri" charset="0"/>
@@ -3598,7 +3152,7 @@
                         <a:buNone/>
                       </a:pPr>
                       <a:r>
-                        <a:rPr lang="en-US" sz="1100" dirty="0">
+                        <a:rPr lang="en-US" sz="1150" dirty="0">
                           <a:solidFill>
                             <a:srgbClr val="000000"/>
                           </a:solidFill>
@@ -3608,7 +3162,7 @@
                         </a:rPr>
                         <a:t>44</a:t>
                       </a:r>
-                      <a:endParaRPr lang="en-US" sz="1100" dirty="0">
+                      <a:endParaRPr lang="en-US" sz="1150" dirty="0">
                         <a:latin typeface="Calibri" charset="0"/>
                         <a:ea typeface="Calibri" charset="0"/>
                         <a:cs typeface="Calibri" charset="0"/>
@@ -3663,7 +3217,7 @@
                         <a:buNone/>
                       </a:pPr>
                       <a:r>
-                        <a:rPr lang="en-US" sz="1100" dirty="0">
+                        <a:rPr lang="en-US" sz="1150" dirty="0">
                           <a:solidFill>
                             <a:srgbClr val="000000"/>
                           </a:solidFill>
@@ -3673,7 +3227,7 @@
                         </a:rPr>
                         <a:t>2</a:t>
                       </a:r>
-                      <a:endParaRPr lang="en-US" sz="1100" dirty="0">
+                      <a:endParaRPr lang="en-US" sz="1150" dirty="0">
                         <a:latin typeface="Calibri" charset="0"/>
                         <a:ea typeface="Calibri" charset="0"/>
                         <a:cs typeface="Calibri" charset="0"/>
@@ -3728,7 +3282,7 @@
                         <a:buNone/>
                       </a:pPr>
                       <a:r>
-                        <a:rPr lang="en-US" sz="1100" b="1" dirty="0">
+                        <a:rPr lang="en-US" sz="1150" b="1" dirty="0">
                           <a:solidFill>
                             <a:srgbClr val="15803D"/>
                           </a:solidFill>
@@ -3738,7 +3292,7 @@
                         </a:rPr>
                         <a:t>95.65%</a:t>
                       </a:r>
-                      <a:endParaRPr lang="en-US" sz="1100" dirty="0">
+                      <a:endParaRPr lang="en-US" sz="1150" dirty="0">
                         <a:latin typeface="Calibri" charset="0"/>
                         <a:ea typeface="Calibri" charset="0"/>
                         <a:cs typeface="Calibri" charset="0"/>
@@ -3796,7 +3350,7 @@
                         <a:buNone/>
                       </a:pPr>
                       <a:r>
-                        <a:rPr lang="en-US" sz="950" dirty="0">
+                        <a:rPr lang="en-US" sz="1150" dirty="0">
                           <a:solidFill>
                             <a:srgbClr val="000000"/>
                           </a:solidFill>
@@ -3806,924 +3360,7 @@
                         </a:rPr>
                         <a:t>Bowel damage / separation (1)</a:t>
                       </a:r>
-                      <a:endParaRPr lang="en-US" sz="950" dirty="0">
-                        <a:latin typeface="Calibri" charset="0"/>
-                        <a:ea typeface="Calibri" charset="0"/>
-                        <a:cs typeface="Calibri" charset="0"/>
-                      </a:endParaRPr>
-                    </a:p>
-                  </a:txBody>
-                  <a:tcPr marL="91440" marR="91440" marT="45720" marB="45720" anchor="ctr">
-                    <a:lnL w="6350" cap="flat" cmpd="sng" algn="ctr">
-                      <a:solidFill>
-                        <a:srgbClr val="E5E7EB"/>
-                      </a:solidFill>
-                      <a:prstDash val="solid"/>
-                      <a:round/>
-                      <a:headEnd type="none" w="med" len="med"/>
-                      <a:tailEnd type="none" w="med" len="med"/>
-                    </a:lnL>
-                    <a:lnR w="6350" cap="flat" cmpd="sng" algn="ctr">
-                      <a:solidFill>
-                        <a:srgbClr val="E5E7EB"/>
-                      </a:solidFill>
-                      <a:prstDash val="solid"/>
-                      <a:round/>
-                      <a:headEnd type="none" w="med" len="med"/>
-                      <a:tailEnd type="none" w="med" len="med"/>
-                    </a:lnR>
-                    <a:lnT w="6350" cap="flat" cmpd="sng" algn="ctr">
-                      <a:solidFill>
-                        <a:srgbClr val="E5E7EB"/>
-                      </a:solidFill>
-                      <a:prstDash val="solid"/>
-                      <a:round/>
-                      <a:headEnd type="none" w="med" len="med"/>
-                      <a:tailEnd type="none" w="med" len="med"/>
-                    </a:lnT>
-                    <a:lnB w="6350" cap="flat" cmpd="sng" algn="ctr">
-                      <a:solidFill>
-                        <a:srgbClr val="E5E7EB"/>
-                      </a:solidFill>
-                      <a:prstDash val="solid"/>
-                      <a:round/>
-                      <a:headEnd type="none" w="med" len="med"/>
-                      <a:tailEnd type="none" w="med" len="med"/>
-                    </a:lnB>
-                  </a:tcPr>
-                </a:tc>
-              </a:tr>
-              <a:tr h="310896">
-                <a:tc>
-                  <a:txBody>
-                    <a:bodyPr/>
-                    <a:lstStyle/>
-                    <a:p>
-                      <a:pPr indent="0" marL="0">
-                        <a:buNone/>
-                      </a:pPr>
-                      <a:r>
-                        <a:rPr lang="en-US" sz="1100" b="1" dirty="0">
-                          <a:solidFill>
-                            <a:srgbClr val="000000"/>
-                          </a:solidFill>
-                          <a:latin typeface="Calibri" pitchFamily="34" charset="0"/>
-                          <a:ea typeface="Calibri" pitchFamily="34" charset="-122"/>
-                          <a:cs typeface="Calibri" pitchFamily="34" charset="-120"/>
-                        </a:rPr>
-                        <a:t>Pelvic @ Nahunta</a:t>
-                      </a:r>
-                      <a:endParaRPr lang="en-US" sz="1100" dirty="0">
-                        <a:latin typeface="Calibri" charset="0"/>
-                        <a:ea typeface="Calibri" charset="0"/>
-                        <a:cs typeface="Calibri" charset="0"/>
-                      </a:endParaRPr>
-                    </a:p>
-                  </a:txBody>
-                  <a:tcPr marL="91440" marR="91440" marT="45720" marB="45720" anchor="ctr">
-                    <a:lnL w="6350" cap="flat" cmpd="sng" algn="ctr">
-                      <a:solidFill>
-                        <a:srgbClr val="E5E7EB"/>
-                      </a:solidFill>
-                      <a:prstDash val="solid"/>
-                      <a:round/>
-                      <a:headEnd type="none" w="med" len="med"/>
-                      <a:tailEnd type="none" w="med" len="med"/>
-                    </a:lnL>
-                    <a:lnR w="6350" cap="flat" cmpd="sng" algn="ctr">
-                      <a:solidFill>
-                        <a:srgbClr val="E5E7EB"/>
-                      </a:solidFill>
-                      <a:prstDash val="solid"/>
-                      <a:round/>
-                      <a:headEnd type="none" w="med" len="med"/>
-                      <a:tailEnd type="none" w="med" len="med"/>
-                    </a:lnR>
-                    <a:lnT w="6350" cap="flat" cmpd="sng" algn="ctr">
-                      <a:solidFill>
-                        <a:srgbClr val="E5E7EB"/>
-                      </a:solidFill>
-                      <a:prstDash val="solid"/>
-                      <a:round/>
-                      <a:headEnd type="none" w="med" len="med"/>
-                      <a:tailEnd type="none" w="med" len="med"/>
-                    </a:lnT>
-                    <a:lnB w="6350" cap="flat" cmpd="sng" algn="ctr">
-                      <a:solidFill>
-                        <a:srgbClr val="E5E7EB"/>
-                      </a:solidFill>
-                      <a:prstDash val="solid"/>
-                      <a:round/>
-                      <a:headEnd type="none" w="med" len="med"/>
-                      <a:tailEnd type="none" w="med" len="med"/>
-                    </a:lnB>
-                  </a:tcPr>
-                </a:tc>
-                <a:tc>
-                  <a:txBody>
-                    <a:bodyPr/>
-                    <a:lstStyle/>
-                    <a:p>
-                      <a:pPr indent="0" marL="0">
-                        <a:buNone/>
-                      </a:pPr>
-                      <a:r>
-                        <a:rPr lang="en-US" sz="1100" dirty="0">
-                          <a:solidFill>
-                            <a:srgbClr val="6B7280"/>
-                          </a:solidFill>
-                          <a:latin typeface="Calibri" pitchFamily="34" charset="0"/>
-                          <a:ea typeface="Calibri" pitchFamily="34" charset="-122"/>
-                          <a:cs typeface="Calibri" pitchFamily="34" charset="-120"/>
-                        </a:rPr>
-                        <a:t>666541</a:t>
-                      </a:r>
-                      <a:endParaRPr lang="en-US" sz="1100" dirty="0">
-                        <a:latin typeface="Calibri" charset="0"/>
-                        <a:ea typeface="Calibri" charset="0"/>
-                        <a:cs typeface="Calibri" charset="0"/>
-                      </a:endParaRPr>
-                    </a:p>
-                  </a:txBody>
-                  <a:tcPr marL="91440" marR="91440" marT="45720" marB="45720" anchor="ctr">
-                    <a:lnL w="6350" cap="flat" cmpd="sng" algn="ctr">
-                      <a:solidFill>
-                        <a:srgbClr val="E5E7EB"/>
-                      </a:solidFill>
-                      <a:prstDash val="solid"/>
-                      <a:round/>
-                      <a:headEnd type="none" w="med" len="med"/>
-                      <a:tailEnd type="none" w="med" len="med"/>
-                    </a:lnL>
-                    <a:lnR w="6350" cap="flat" cmpd="sng" algn="ctr">
-                      <a:solidFill>
-                        <a:srgbClr val="E5E7EB"/>
-                      </a:solidFill>
-                      <a:prstDash val="solid"/>
-                      <a:round/>
-                      <a:headEnd type="none" w="med" len="med"/>
-                      <a:tailEnd type="none" w="med" len="med"/>
-                    </a:lnR>
-                    <a:lnT w="6350" cap="flat" cmpd="sng" algn="ctr">
-                      <a:solidFill>
-                        <a:srgbClr val="E5E7EB"/>
-                      </a:solidFill>
-                      <a:prstDash val="solid"/>
-                      <a:round/>
-                      <a:headEnd type="none" w="med" len="med"/>
-                      <a:tailEnd type="none" w="med" len="med"/>
-                    </a:lnT>
-                    <a:lnB w="6350" cap="flat" cmpd="sng" algn="ctr">
-                      <a:solidFill>
-                        <a:srgbClr val="E5E7EB"/>
-                      </a:solidFill>
-                      <a:prstDash val="solid"/>
-                      <a:round/>
-                      <a:headEnd type="none" w="med" len="med"/>
-                      <a:tailEnd type="none" w="med" len="med"/>
-                    </a:lnB>
-                  </a:tcPr>
-                </a:tc>
-                <a:tc>
-                  <a:txBody>
-                    <a:bodyPr/>
-                    <a:lstStyle/>
-                    <a:p>
-                      <a:pPr algn="r" indent="0" marL="0">
-                        <a:buNone/>
-                      </a:pPr>
-                      <a:r>
-                        <a:rPr lang="en-US" sz="1100" dirty="0">
-                          <a:solidFill>
-                            <a:srgbClr val="000000"/>
-                          </a:solidFill>
-                          <a:latin typeface="Calibri" pitchFamily="34" charset="0"/>
-                          <a:ea typeface="Calibri" pitchFamily="34" charset="-122"/>
-                          <a:cs typeface="Calibri" pitchFamily="34" charset="-120"/>
-                        </a:rPr>
-                        <a:t>13</a:t>
-                      </a:r>
-                      <a:endParaRPr lang="en-US" sz="1100" dirty="0">
-                        <a:latin typeface="Calibri" charset="0"/>
-                        <a:ea typeface="Calibri" charset="0"/>
-                        <a:cs typeface="Calibri" charset="0"/>
-                      </a:endParaRPr>
-                    </a:p>
-                  </a:txBody>
-                  <a:tcPr marL="91440" marR="91440" marT="45720" marB="45720" anchor="ctr">
-                    <a:lnL w="6350" cap="flat" cmpd="sng" algn="ctr">
-                      <a:solidFill>
-                        <a:srgbClr val="E5E7EB"/>
-                      </a:solidFill>
-                      <a:prstDash val="solid"/>
-                      <a:round/>
-                      <a:headEnd type="none" w="med" len="med"/>
-                      <a:tailEnd type="none" w="med" len="med"/>
-                    </a:lnL>
-                    <a:lnR w="6350" cap="flat" cmpd="sng" algn="ctr">
-                      <a:solidFill>
-                        <a:srgbClr val="E5E7EB"/>
-                      </a:solidFill>
-                      <a:prstDash val="solid"/>
-                      <a:round/>
-                      <a:headEnd type="none" w="med" len="med"/>
-                      <a:tailEnd type="none" w="med" len="med"/>
-                    </a:lnR>
-                    <a:lnT w="6350" cap="flat" cmpd="sng" algn="ctr">
-                      <a:solidFill>
-                        <a:srgbClr val="E5E7EB"/>
-                      </a:solidFill>
-                      <a:prstDash val="solid"/>
-                      <a:round/>
-                      <a:headEnd type="none" w="med" len="med"/>
-                      <a:tailEnd type="none" w="med" len="med"/>
-                    </a:lnT>
-                    <a:lnB w="6350" cap="flat" cmpd="sng" algn="ctr">
-                      <a:solidFill>
-                        <a:srgbClr val="E5E7EB"/>
-                      </a:solidFill>
-                      <a:prstDash val="solid"/>
-                      <a:round/>
-                      <a:headEnd type="none" w="med" len="med"/>
-                      <a:tailEnd type="none" w="med" len="med"/>
-                    </a:lnB>
-                  </a:tcPr>
-                </a:tc>
-                <a:tc>
-                  <a:txBody>
-                    <a:bodyPr/>
-                    <a:lstStyle/>
-                    <a:p>
-                      <a:pPr algn="r" indent="0" marL="0">
-                        <a:buNone/>
-                      </a:pPr>
-                      <a:r>
-                        <a:rPr lang="en-US" sz="1100" dirty="0">
-                          <a:solidFill>
-                            <a:srgbClr val="000000"/>
-                          </a:solidFill>
-                          <a:latin typeface="Calibri" pitchFamily="34" charset="0"/>
-                          <a:ea typeface="Calibri" pitchFamily="34" charset="-122"/>
-                          <a:cs typeface="Calibri" pitchFamily="34" charset="-120"/>
-                        </a:rPr>
-                        <a:t>1</a:t>
-                      </a:r>
-                      <a:endParaRPr lang="en-US" sz="1100" dirty="0">
-                        <a:latin typeface="Calibri" charset="0"/>
-                        <a:ea typeface="Calibri" charset="0"/>
-                        <a:cs typeface="Calibri" charset="0"/>
-                      </a:endParaRPr>
-                    </a:p>
-                  </a:txBody>
-                  <a:tcPr marL="91440" marR="91440" marT="45720" marB="45720" anchor="ctr">
-                    <a:lnL w="6350" cap="flat" cmpd="sng" algn="ctr">
-                      <a:solidFill>
-                        <a:srgbClr val="E5E7EB"/>
-                      </a:solidFill>
-                      <a:prstDash val="solid"/>
-                      <a:round/>
-                      <a:headEnd type="none" w="med" len="med"/>
-                      <a:tailEnd type="none" w="med" len="med"/>
-                    </a:lnL>
-                    <a:lnR w="6350" cap="flat" cmpd="sng" algn="ctr">
-                      <a:solidFill>
-                        <a:srgbClr val="E5E7EB"/>
-                      </a:solidFill>
-                      <a:prstDash val="solid"/>
-                      <a:round/>
-                      <a:headEnd type="none" w="med" len="med"/>
-                      <a:tailEnd type="none" w="med" len="med"/>
-                    </a:lnR>
-                    <a:lnT w="6350" cap="flat" cmpd="sng" algn="ctr">
-                      <a:solidFill>
-                        <a:srgbClr val="E5E7EB"/>
-                      </a:solidFill>
-                      <a:prstDash val="solid"/>
-                      <a:round/>
-                      <a:headEnd type="none" w="med" len="med"/>
-                      <a:tailEnd type="none" w="med" len="med"/>
-                    </a:lnT>
-                    <a:lnB w="6350" cap="flat" cmpd="sng" algn="ctr">
-                      <a:solidFill>
-                        <a:srgbClr val="E5E7EB"/>
-                      </a:solidFill>
-                      <a:prstDash val="solid"/>
-                      <a:round/>
-                      <a:headEnd type="none" w="med" len="med"/>
-                      <a:tailEnd type="none" w="med" len="med"/>
-                    </a:lnB>
-                  </a:tcPr>
-                </a:tc>
-                <a:tc>
-                  <a:txBody>
-                    <a:bodyPr/>
-                    <a:lstStyle/>
-                    <a:p>
-                      <a:pPr algn="r" indent="0" marL="0">
-                        <a:buNone/>
-                      </a:pPr>
-                      <a:r>
-                        <a:rPr lang="en-US" sz="1100" b="1" dirty="0">
-                          <a:solidFill>
-                            <a:srgbClr val="000000"/>
-                          </a:solidFill>
-                          <a:latin typeface="Calibri" pitchFamily="34" charset="0"/>
-                          <a:ea typeface="Calibri" pitchFamily="34" charset="-122"/>
-                          <a:cs typeface="Calibri" pitchFamily="34" charset="-120"/>
-                        </a:rPr>
-                        <a:t>12</a:t>
-                      </a:r>
-                      <a:endParaRPr lang="en-US" sz="1100" dirty="0">
-                        <a:latin typeface="Calibri" charset="0"/>
-                        <a:ea typeface="Calibri" charset="0"/>
-                        <a:cs typeface="Calibri" charset="0"/>
-                      </a:endParaRPr>
-                    </a:p>
-                  </a:txBody>
-                  <a:tcPr marL="91440" marR="91440" marT="45720" marB="45720" anchor="ctr">
-                    <a:lnL w="6350" cap="flat" cmpd="sng" algn="ctr">
-                      <a:solidFill>
-                        <a:srgbClr val="E5E7EB"/>
-                      </a:solidFill>
-                      <a:prstDash val="solid"/>
-                      <a:round/>
-                      <a:headEnd type="none" w="med" len="med"/>
-                      <a:tailEnd type="none" w="med" len="med"/>
-                    </a:lnL>
-                    <a:lnR w="6350" cap="flat" cmpd="sng" algn="ctr">
-                      <a:solidFill>
-                        <a:srgbClr val="E5E7EB"/>
-                      </a:solidFill>
-                      <a:prstDash val="solid"/>
-                      <a:round/>
-                      <a:headEnd type="none" w="med" len="med"/>
-                      <a:tailEnd type="none" w="med" len="med"/>
-                    </a:lnR>
-                    <a:lnT w="6350" cap="flat" cmpd="sng" algn="ctr">
-                      <a:solidFill>
-                        <a:srgbClr val="E5E7EB"/>
-                      </a:solidFill>
-                      <a:prstDash val="solid"/>
-                      <a:round/>
-                      <a:headEnd type="none" w="med" len="med"/>
-                      <a:tailEnd type="none" w="med" len="med"/>
-                    </a:lnT>
-                    <a:lnB w="6350" cap="flat" cmpd="sng" algn="ctr">
-                      <a:solidFill>
-                        <a:srgbClr val="E5E7EB"/>
-                      </a:solidFill>
-                      <a:prstDash val="solid"/>
-                      <a:round/>
-                      <a:headEnd type="none" w="med" len="med"/>
-                      <a:tailEnd type="none" w="med" len="med"/>
-                    </a:lnB>
-                  </a:tcPr>
-                </a:tc>
-                <a:tc>
-                  <a:txBody>
-                    <a:bodyPr/>
-                    <a:lstStyle/>
-                    <a:p>
-                      <a:pPr algn="ctr" indent="0" marL="0">
-                        <a:buNone/>
-                      </a:pPr>
-                      <a:r>
-                        <a:rPr lang="en-US" sz="1100" i="1" dirty="0">
-                          <a:solidFill>
-                            <a:srgbClr val="6B7280"/>
-                          </a:solidFill>
-                          <a:latin typeface="Calibri" pitchFamily="34" charset="0"/>
-                          <a:ea typeface="Calibri" pitchFamily="34" charset="-122"/>
-                          <a:cs typeface="Calibri" pitchFamily="34" charset="-120"/>
-                        </a:rPr>
-                        <a:t>n/a — pre-receipt</a:t>
-                      </a:r>
-                      <a:endParaRPr lang="en-US" sz="1100" dirty="0">
-                        <a:latin typeface="Calibri" charset="0"/>
-                        <a:ea typeface="Calibri" charset="0"/>
-                        <a:cs typeface="Calibri" charset="0"/>
-                      </a:endParaRPr>
-                    </a:p>
-                  </a:txBody>
-                  <a:tcPr marL="91440" marR="91440" marT="45720" marB="45720" anchor="ctr">
-                    <a:lnL w="6350" cap="flat" cmpd="sng" algn="ctr">
-                      <a:solidFill>
-                        <a:srgbClr val="E5E7EB"/>
-                      </a:solidFill>
-                      <a:prstDash val="solid"/>
-                      <a:round/>
-                      <a:headEnd type="none" w="med" len="med"/>
-                      <a:tailEnd type="none" w="med" len="med"/>
-                    </a:lnL>
-                    <a:lnR w="6350" cap="flat" cmpd="sng" algn="ctr">
-                      <a:solidFill>
-                        <a:srgbClr val="E5E7EB"/>
-                      </a:solidFill>
-                      <a:prstDash val="solid"/>
-                      <a:round/>
-                      <a:headEnd type="none" w="med" len="med"/>
-                      <a:tailEnd type="none" w="med" len="med"/>
-                    </a:lnR>
-                    <a:lnT w="6350" cap="flat" cmpd="sng" algn="ctr">
-                      <a:solidFill>
-                        <a:srgbClr val="E5E7EB"/>
-                      </a:solidFill>
-                      <a:prstDash val="solid"/>
-                      <a:round/>
-                      <a:headEnd type="none" w="med" len="med"/>
-                      <a:tailEnd type="none" w="med" len="med"/>
-                    </a:lnT>
-                    <a:lnB w="6350" cap="flat" cmpd="sng" algn="ctr">
-                      <a:solidFill>
-                        <a:srgbClr val="E5E7EB"/>
-                      </a:solidFill>
-                      <a:prstDash val="solid"/>
-                      <a:round/>
-                      <a:headEnd type="none" w="med" len="med"/>
-                      <a:tailEnd type="none" w="med" len="med"/>
-                    </a:lnB>
-                  </a:tcPr>
-                </a:tc>
-                <a:tc>
-                  <a:txBody>
-                    <a:bodyPr/>
-                    <a:lstStyle/>
-                    <a:p>
-                      <a:pPr indent="0" marL="0">
-                        <a:buNone/>
-                      </a:pPr>
-                      <a:r>
-                        <a:rPr lang="en-US" sz="950" dirty="0">
-                          <a:solidFill>
-                            <a:srgbClr val="000000"/>
-                          </a:solidFill>
-                          <a:latin typeface="Calibri" pitchFamily="34" charset="0"/>
-                          <a:ea typeface="Calibri" pitchFamily="34" charset="-122"/>
-                          <a:cs typeface="Calibri" pitchFamily="34" charset="-120"/>
-                        </a:rPr>
-                        <a:t>Pre-receipt screen — inspected prior to receipt (see note)</a:t>
-                      </a:r>
-                      <a:endParaRPr lang="en-US" sz="950" dirty="0">
-                        <a:latin typeface="Calibri" charset="0"/>
-                        <a:ea typeface="Calibri" charset="0"/>
-                        <a:cs typeface="Calibri" charset="0"/>
-                      </a:endParaRPr>
-                    </a:p>
-                  </a:txBody>
-                  <a:tcPr marL="91440" marR="91440" marT="45720" marB="45720" anchor="ctr">
-                    <a:lnL w="6350" cap="flat" cmpd="sng" algn="ctr">
-                      <a:solidFill>
-                        <a:srgbClr val="E5E7EB"/>
-                      </a:solidFill>
-                      <a:prstDash val="solid"/>
-                      <a:round/>
-                      <a:headEnd type="none" w="med" len="med"/>
-                      <a:tailEnd type="none" w="med" len="med"/>
-                    </a:lnL>
-                    <a:lnR w="6350" cap="flat" cmpd="sng" algn="ctr">
-                      <a:solidFill>
-                        <a:srgbClr val="E5E7EB"/>
-                      </a:solidFill>
-                      <a:prstDash val="solid"/>
-                      <a:round/>
-                      <a:headEnd type="none" w="med" len="med"/>
-                      <a:tailEnd type="none" w="med" len="med"/>
-                    </a:lnR>
-                    <a:lnT w="6350" cap="flat" cmpd="sng" algn="ctr">
-                      <a:solidFill>
-                        <a:srgbClr val="E5E7EB"/>
-                      </a:solidFill>
-                      <a:prstDash val="solid"/>
-                      <a:round/>
-                      <a:headEnd type="none" w="med" len="med"/>
-                      <a:tailEnd type="none" w="med" len="med"/>
-                    </a:lnT>
-                    <a:lnB w="6350" cap="flat" cmpd="sng" algn="ctr">
-                      <a:solidFill>
-                        <a:srgbClr val="E5E7EB"/>
-                      </a:solidFill>
-                      <a:prstDash val="solid"/>
-                      <a:round/>
-                      <a:headEnd type="none" w="med" len="med"/>
-                      <a:tailEnd type="none" w="med" len="med"/>
-                    </a:lnB>
-                  </a:tcPr>
-                </a:tc>
-              </a:tr>
-              <a:tr h="310896">
-                <a:tc>
-                  <a:txBody>
-                    <a:bodyPr/>
-                    <a:lstStyle/>
-                    <a:p>
-                      <a:pPr indent="0" marL="0">
-                        <a:buNone/>
-                      </a:pPr>
-                      <a:r>
-                        <a:rPr lang="en-US" sz="1100" b="1" dirty="0">
-                          <a:solidFill>
-                            <a:srgbClr val="000000"/>
-                          </a:solidFill>
-                          <a:latin typeface="Calibri" pitchFamily="34" charset="0"/>
-                          <a:ea typeface="Calibri" pitchFamily="34" charset="-122"/>
-                          <a:cs typeface="Calibri" pitchFamily="34" charset="-120"/>
-                        </a:rPr>
-                        <a:t>Thoracic @ Nahunta</a:t>
-                      </a:r>
-                      <a:endParaRPr lang="en-US" sz="1100" dirty="0">
-                        <a:latin typeface="Calibri" charset="0"/>
-                        <a:ea typeface="Calibri" charset="0"/>
-                        <a:cs typeface="Calibri" charset="0"/>
-                      </a:endParaRPr>
-                    </a:p>
-                  </a:txBody>
-                  <a:tcPr marL="91440" marR="91440" marT="45720" marB="45720" anchor="ctr">
-                    <a:lnL w="6350" cap="flat" cmpd="sng" algn="ctr">
-                      <a:solidFill>
-                        <a:srgbClr val="E5E7EB"/>
-                      </a:solidFill>
-                      <a:prstDash val="solid"/>
-                      <a:round/>
-                      <a:headEnd type="none" w="med" len="med"/>
-                      <a:tailEnd type="none" w="med" len="med"/>
-                    </a:lnL>
-                    <a:lnR w="6350" cap="flat" cmpd="sng" algn="ctr">
-                      <a:solidFill>
-                        <a:srgbClr val="E5E7EB"/>
-                      </a:solidFill>
-                      <a:prstDash val="solid"/>
-                      <a:round/>
-                      <a:headEnd type="none" w="med" len="med"/>
-                      <a:tailEnd type="none" w="med" len="med"/>
-                    </a:lnR>
-                    <a:lnT w="6350" cap="flat" cmpd="sng" algn="ctr">
-                      <a:solidFill>
-                        <a:srgbClr val="E5E7EB"/>
-                      </a:solidFill>
-                      <a:prstDash val="solid"/>
-                      <a:round/>
-                      <a:headEnd type="none" w="med" len="med"/>
-                      <a:tailEnd type="none" w="med" len="med"/>
-                    </a:lnT>
-                    <a:lnB w="6350" cap="flat" cmpd="sng" algn="ctr">
-                      <a:solidFill>
-                        <a:srgbClr val="E5E7EB"/>
-                      </a:solidFill>
-                      <a:prstDash val="solid"/>
-                      <a:round/>
-                      <a:headEnd type="none" w="med" len="med"/>
-                      <a:tailEnd type="none" w="med" len="med"/>
-                    </a:lnB>
-                  </a:tcPr>
-                </a:tc>
-                <a:tc>
-                  <a:txBody>
-                    <a:bodyPr/>
-                    <a:lstStyle/>
-                    <a:p>
-                      <a:pPr indent="0" marL="0">
-                        <a:buNone/>
-                      </a:pPr>
-                      <a:r>
-                        <a:rPr lang="en-US" sz="1100" dirty="0">
-                          <a:solidFill>
-                            <a:srgbClr val="6B7280"/>
-                          </a:solidFill>
-                          <a:latin typeface="Calibri" pitchFamily="34" charset="0"/>
-                          <a:ea typeface="Calibri" pitchFamily="34" charset="-122"/>
-                          <a:cs typeface="Calibri" pitchFamily="34" charset="-120"/>
-                        </a:rPr>
-                        <a:t>666521</a:t>
-                      </a:r>
-                      <a:endParaRPr lang="en-US" sz="1100" dirty="0">
-                        <a:latin typeface="Calibri" charset="0"/>
-                        <a:ea typeface="Calibri" charset="0"/>
-                        <a:cs typeface="Calibri" charset="0"/>
-                      </a:endParaRPr>
-                    </a:p>
-                  </a:txBody>
-                  <a:tcPr marL="91440" marR="91440" marT="45720" marB="45720" anchor="ctr">
-                    <a:lnL w="6350" cap="flat" cmpd="sng" algn="ctr">
-                      <a:solidFill>
-                        <a:srgbClr val="E5E7EB"/>
-                      </a:solidFill>
-                      <a:prstDash val="solid"/>
-                      <a:round/>
-                      <a:headEnd type="none" w="med" len="med"/>
-                      <a:tailEnd type="none" w="med" len="med"/>
-                    </a:lnL>
-                    <a:lnR w="6350" cap="flat" cmpd="sng" algn="ctr">
-                      <a:solidFill>
-                        <a:srgbClr val="E5E7EB"/>
-                      </a:solidFill>
-                      <a:prstDash val="solid"/>
-                      <a:round/>
-                      <a:headEnd type="none" w="med" len="med"/>
-                      <a:tailEnd type="none" w="med" len="med"/>
-                    </a:lnR>
-                    <a:lnT w="6350" cap="flat" cmpd="sng" algn="ctr">
-                      <a:solidFill>
-                        <a:srgbClr val="E5E7EB"/>
-                      </a:solidFill>
-                      <a:prstDash val="solid"/>
-                      <a:round/>
-                      <a:headEnd type="none" w="med" len="med"/>
-                      <a:tailEnd type="none" w="med" len="med"/>
-                    </a:lnT>
-                    <a:lnB w="6350" cap="flat" cmpd="sng" algn="ctr">
-                      <a:solidFill>
-                        <a:srgbClr val="E5E7EB"/>
-                      </a:solidFill>
-                      <a:prstDash val="solid"/>
-                      <a:round/>
-                      <a:headEnd type="none" w="med" len="med"/>
-                      <a:tailEnd type="none" w="med" len="med"/>
-                    </a:lnB>
-                  </a:tcPr>
-                </a:tc>
-                <a:tc>
-                  <a:txBody>
-                    <a:bodyPr/>
-                    <a:lstStyle/>
-                    <a:p>
-                      <a:pPr algn="r" indent="0" marL="0">
-                        <a:buNone/>
-                      </a:pPr>
-                      <a:r>
-                        <a:rPr lang="en-US" sz="1100" dirty="0">
-                          <a:solidFill>
-                            <a:srgbClr val="000000"/>
-                          </a:solidFill>
-                          <a:latin typeface="Calibri" pitchFamily="34" charset="0"/>
-                          <a:ea typeface="Calibri" pitchFamily="34" charset="-122"/>
-                          <a:cs typeface="Calibri" pitchFamily="34" charset="-120"/>
-                        </a:rPr>
-                        <a:t>66</a:t>
-                      </a:r>
-                      <a:endParaRPr lang="en-US" sz="1100" dirty="0">
-                        <a:latin typeface="Calibri" charset="0"/>
-                        <a:ea typeface="Calibri" charset="0"/>
-                        <a:cs typeface="Calibri" charset="0"/>
-                      </a:endParaRPr>
-                    </a:p>
-                  </a:txBody>
-                  <a:tcPr marL="91440" marR="91440" marT="45720" marB="45720" anchor="ctr">
-                    <a:lnL w="6350" cap="flat" cmpd="sng" algn="ctr">
-                      <a:solidFill>
-                        <a:srgbClr val="E5E7EB"/>
-                      </a:solidFill>
-                      <a:prstDash val="solid"/>
-                      <a:round/>
-                      <a:headEnd type="none" w="med" len="med"/>
-                      <a:tailEnd type="none" w="med" len="med"/>
-                    </a:lnL>
-                    <a:lnR w="6350" cap="flat" cmpd="sng" algn="ctr">
-                      <a:solidFill>
-                        <a:srgbClr val="E5E7EB"/>
-                      </a:solidFill>
-                      <a:prstDash val="solid"/>
-                      <a:round/>
-                      <a:headEnd type="none" w="med" len="med"/>
-                      <a:tailEnd type="none" w="med" len="med"/>
-                    </a:lnR>
-                    <a:lnT w="6350" cap="flat" cmpd="sng" algn="ctr">
-                      <a:solidFill>
-                        <a:srgbClr val="E5E7EB"/>
-                      </a:solidFill>
-                      <a:prstDash val="solid"/>
-                      <a:round/>
-                      <a:headEnd type="none" w="med" len="med"/>
-                      <a:tailEnd type="none" w="med" len="med"/>
-                    </a:lnT>
-                    <a:lnB w="6350" cap="flat" cmpd="sng" algn="ctr">
-                      <a:solidFill>
-                        <a:srgbClr val="E5E7EB"/>
-                      </a:solidFill>
-                      <a:prstDash val="solid"/>
-                      <a:round/>
-                      <a:headEnd type="none" w="med" len="med"/>
-                      <a:tailEnd type="none" w="med" len="med"/>
-                    </a:lnB>
-                  </a:tcPr>
-                </a:tc>
-                <a:tc>
-                  <a:txBody>
-                    <a:bodyPr/>
-                    <a:lstStyle/>
-                    <a:p>
-                      <a:pPr algn="r" indent="0" marL="0">
-                        <a:buNone/>
-                      </a:pPr>
-                      <a:r>
-                        <a:rPr lang="en-US" sz="1100" dirty="0">
-                          <a:solidFill>
-                            <a:srgbClr val="000000"/>
-                          </a:solidFill>
-                          <a:latin typeface="Calibri" pitchFamily="34" charset="0"/>
-                          <a:ea typeface="Calibri" pitchFamily="34" charset="-122"/>
-                          <a:cs typeface="Calibri" pitchFamily="34" charset="-120"/>
-                        </a:rPr>
-                        <a:t>16</a:t>
-                      </a:r>
-                      <a:endParaRPr lang="en-US" sz="1100" dirty="0">
-                        <a:latin typeface="Calibri" charset="0"/>
-                        <a:ea typeface="Calibri" charset="0"/>
-                        <a:cs typeface="Calibri" charset="0"/>
-                      </a:endParaRPr>
-                    </a:p>
-                  </a:txBody>
-                  <a:tcPr marL="91440" marR="91440" marT="45720" marB="45720" anchor="ctr">
-                    <a:lnL w="6350" cap="flat" cmpd="sng" algn="ctr">
-                      <a:solidFill>
-                        <a:srgbClr val="E5E7EB"/>
-                      </a:solidFill>
-                      <a:prstDash val="solid"/>
-                      <a:round/>
-                      <a:headEnd type="none" w="med" len="med"/>
-                      <a:tailEnd type="none" w="med" len="med"/>
-                    </a:lnL>
-                    <a:lnR w="6350" cap="flat" cmpd="sng" algn="ctr">
-                      <a:solidFill>
-                        <a:srgbClr val="E5E7EB"/>
-                      </a:solidFill>
-                      <a:prstDash val="solid"/>
-                      <a:round/>
-                      <a:headEnd type="none" w="med" len="med"/>
-                      <a:tailEnd type="none" w="med" len="med"/>
-                    </a:lnR>
-                    <a:lnT w="6350" cap="flat" cmpd="sng" algn="ctr">
-                      <a:solidFill>
-                        <a:srgbClr val="E5E7EB"/>
-                      </a:solidFill>
-                      <a:prstDash val="solid"/>
-                      <a:round/>
-                      <a:headEnd type="none" w="med" len="med"/>
-                      <a:tailEnd type="none" w="med" len="med"/>
-                    </a:lnT>
-                    <a:lnB w="6350" cap="flat" cmpd="sng" algn="ctr">
-                      <a:solidFill>
-                        <a:srgbClr val="E5E7EB"/>
-                      </a:solidFill>
-                      <a:prstDash val="solid"/>
-                      <a:round/>
-                      <a:headEnd type="none" w="med" len="med"/>
-                      <a:tailEnd type="none" w="med" len="med"/>
-                    </a:lnB>
-                  </a:tcPr>
-                </a:tc>
-                <a:tc>
-                  <a:txBody>
-                    <a:bodyPr/>
-                    <a:lstStyle/>
-                    <a:p>
-                      <a:pPr algn="r" indent="0" marL="0">
-                        <a:buNone/>
-                      </a:pPr>
-                      <a:r>
-                        <a:rPr lang="en-US" sz="1100" b="1" dirty="0">
-                          <a:solidFill>
-                            <a:srgbClr val="000000"/>
-                          </a:solidFill>
-                          <a:latin typeface="Calibri" pitchFamily="34" charset="0"/>
-                          <a:ea typeface="Calibri" pitchFamily="34" charset="-122"/>
-                          <a:cs typeface="Calibri" pitchFamily="34" charset="-120"/>
-                        </a:rPr>
-                        <a:t>50</a:t>
-                      </a:r>
-                      <a:endParaRPr lang="en-US" sz="1100" dirty="0">
-                        <a:latin typeface="Calibri" charset="0"/>
-                        <a:ea typeface="Calibri" charset="0"/>
-                        <a:cs typeface="Calibri" charset="0"/>
-                      </a:endParaRPr>
-                    </a:p>
-                  </a:txBody>
-                  <a:tcPr marL="91440" marR="91440" marT="45720" marB="45720" anchor="ctr">
-                    <a:lnL w="6350" cap="flat" cmpd="sng" algn="ctr">
-                      <a:solidFill>
-                        <a:srgbClr val="E5E7EB"/>
-                      </a:solidFill>
-                      <a:prstDash val="solid"/>
-                      <a:round/>
-                      <a:headEnd type="none" w="med" len="med"/>
-                      <a:tailEnd type="none" w="med" len="med"/>
-                    </a:lnL>
-                    <a:lnR w="6350" cap="flat" cmpd="sng" algn="ctr">
-                      <a:solidFill>
-                        <a:srgbClr val="E5E7EB"/>
-                      </a:solidFill>
-                      <a:prstDash val="solid"/>
-                      <a:round/>
-                      <a:headEnd type="none" w="med" len="med"/>
-                      <a:tailEnd type="none" w="med" len="med"/>
-                    </a:lnR>
-                    <a:lnT w="6350" cap="flat" cmpd="sng" algn="ctr">
-                      <a:solidFill>
-                        <a:srgbClr val="E5E7EB"/>
-                      </a:solidFill>
-                      <a:prstDash val="solid"/>
-                      <a:round/>
-                      <a:headEnd type="none" w="med" len="med"/>
-                      <a:tailEnd type="none" w="med" len="med"/>
-                    </a:lnT>
-                    <a:lnB w="6350" cap="flat" cmpd="sng" algn="ctr">
-                      <a:solidFill>
-                        <a:srgbClr val="E5E7EB"/>
-                      </a:solidFill>
-                      <a:prstDash val="solid"/>
-                      <a:round/>
-                      <a:headEnd type="none" w="med" len="med"/>
-                      <a:tailEnd type="none" w="med" len="med"/>
-                    </a:lnB>
-                  </a:tcPr>
-                </a:tc>
-                <a:tc>
-                  <a:txBody>
-                    <a:bodyPr/>
-                    <a:lstStyle/>
-                    <a:p>
-                      <a:pPr algn="ctr" indent="0" marL="0">
-                        <a:buNone/>
-                      </a:pPr>
-                      <a:r>
-                        <a:rPr lang="en-US" sz="1100" b="1" dirty="0">
-                          <a:solidFill>
-                            <a:srgbClr val="DC2626"/>
-                          </a:solidFill>
-                          <a:latin typeface="Calibri" pitchFamily="34" charset="0"/>
-                          <a:ea typeface="Calibri" pitchFamily="34" charset="-122"/>
-                          <a:cs typeface="Calibri" pitchFamily="34" charset="-120"/>
-                        </a:rPr>
-                        <a:t>24.24%</a:t>
-                      </a:r>
-                      <a:endParaRPr lang="en-US" sz="1100" dirty="0">
-                        <a:latin typeface="Calibri" charset="0"/>
-                        <a:ea typeface="Calibri" charset="0"/>
-                        <a:cs typeface="Calibri" charset="0"/>
-                      </a:endParaRPr>
-                    </a:p>
-                  </a:txBody>
-                  <a:tcPr marL="91440" marR="91440" marT="45720" marB="45720" anchor="ctr">
-                    <a:lnL w="6350" cap="flat" cmpd="sng" algn="ctr">
-                      <a:solidFill>
-                        <a:srgbClr val="E5E7EB"/>
-                      </a:solidFill>
-                      <a:prstDash val="solid"/>
-                      <a:round/>
-                      <a:headEnd type="none" w="med" len="med"/>
-                      <a:tailEnd type="none" w="med" len="med"/>
-                    </a:lnL>
-                    <a:lnR w="6350" cap="flat" cmpd="sng" algn="ctr">
-                      <a:solidFill>
-                        <a:srgbClr val="E5E7EB"/>
-                      </a:solidFill>
-                      <a:prstDash val="solid"/>
-                      <a:round/>
-                      <a:headEnd type="none" w="med" len="med"/>
-                      <a:tailEnd type="none" w="med" len="med"/>
-                    </a:lnR>
-                    <a:lnT w="6350" cap="flat" cmpd="sng" algn="ctr">
-                      <a:solidFill>
-                        <a:srgbClr val="E5E7EB"/>
-                      </a:solidFill>
-                      <a:prstDash val="solid"/>
-                      <a:round/>
-                      <a:headEnd type="none" w="med" len="med"/>
-                      <a:tailEnd type="none" w="med" len="med"/>
-                    </a:lnT>
-                    <a:lnB w="6350" cap="flat" cmpd="sng" algn="ctr">
-                      <a:solidFill>
-                        <a:srgbClr val="E5E7EB"/>
-                      </a:solidFill>
-                      <a:prstDash val="solid"/>
-                      <a:round/>
-                      <a:headEnd type="none" w="med" len="med"/>
-                      <a:tailEnd type="none" w="med" len="med"/>
-                    </a:lnB>
-                    <a:solidFill>
-                      <a:srgbClr val="FDEAEA"/>
-                    </a:solidFill>
-                  </a:tcPr>
-                </a:tc>
-                <a:tc>
-                  <a:txBody>
-                    <a:bodyPr/>
-                    <a:lstStyle/>
-                    <a:p>
-                      <a:pPr indent="0" marL="0">
-                        <a:buNone/>
-                      </a:pPr>
-                      <a:r>
-                        <a:rPr lang="en-US" sz="950" dirty="0">
-                          <a:solidFill>
-                            <a:srgbClr val="000000"/>
-                          </a:solidFill>
-                          <a:latin typeface="Calibri" pitchFamily="34" charset="0"/>
-                          <a:ea typeface="Calibri" pitchFamily="34" charset="-122"/>
-                          <a:cs typeface="Calibri" pitchFamily="34" charset="-120"/>
-                        </a:rPr>
-                        <a:t>Lung laceration (31)</a:t>
-                      </a:r>
-                      <a:endParaRPr lang="en-US" sz="950" dirty="0">
+                      <a:endParaRPr lang="en-US" sz="1150" dirty="0">
                         <a:latin typeface="Calibri" charset="0"/>
                         <a:ea typeface="Calibri" charset="0"/>
                         <a:cs typeface="Calibri" charset="0"/>
@@ -4776,14 +3413,41 @@
       </p:graphicFrame>
       <p:sp>
         <p:nvSpPr>
-          <p:cNvPr id="5" name="Text 2"/>
+          <p:cNvPr id="5" name="Shape 2"/>
           <p:cNvSpPr/>
           <p:nvPr/>
         </p:nvSpPr>
         <p:spPr>
           <a:xfrm>
-            <a:off x="502920" y="2999232"/>
-            <a:ext cx="11155680" cy="310896"/>
+            <a:off x="502920" y="3246120"/>
+            <a:ext cx="5486400" cy="1783080"/>
+          </a:xfrm>
+          <a:prstGeom prst="roundRect">
+            <a:avLst>
+              <a:gd name="adj" fmla="val 3077"/>
+            </a:avLst>
+          </a:prstGeom>
+          <a:solidFill>
+            <a:srgbClr val="F3F4F6"/>
+          </a:solidFill>
+          <a:ln w="9525">
+            <a:solidFill>
+              <a:srgbClr val="E5E7EB"/>
+            </a:solidFill>
+            <a:prstDash val="solid"/>
+          </a:ln>
+        </p:spPr>
+      </p:sp>
+      <p:sp>
+        <p:nvSpPr>
+          <p:cNvPr id="6" name="Text 3"/>
+          <p:cNvSpPr/>
+          <p:nvPr/>
+        </p:nvSpPr>
+        <p:spPr>
+          <a:xfrm>
+            <a:off x="667512" y="3346704"/>
+            <a:ext cx="5157216" cy="310896"/>
           </a:xfrm>
           <a:prstGeom prst="rect">
             <a:avLst/>
@@ -4799,7 +3463,94 @@
               <a:buNone/>
             </a:pPr>
             <a:r>
-              <a:rPr lang="en-US" sz="820" i="1" dirty="0">
+              <a:rPr lang="en-US" sz="1150" b="1" dirty="0">
+                <a:solidFill>
+                  <a:srgbClr val="1F2937"/>
+                </a:solidFill>
+                <a:latin typeface="Calibri" pitchFamily="34" charset="0"/>
+                <a:ea typeface="Calibri" pitchFamily="34" charset="-122"/>
+                <a:cs typeface="Calibri" pitchFamily="34" charset="-120"/>
+              </a:rPr>
+              <a:t>Pelvic @ Martins · 666541 — 8 fails of 198 inspected</a:t>
+            </a:r>
+            <a:endParaRPr lang="en-US" sz="1150" dirty="0"/>
+          </a:p>
+        </p:txBody>
+      </p:sp>
+      <p:sp>
+        <p:nvSpPr>
+          <p:cNvPr id="7" name="Shape 4"/>
+          <p:cNvSpPr/>
+          <p:nvPr/>
+        </p:nvSpPr>
+        <p:spPr>
+          <a:xfrm>
+            <a:off x="667512" y="3785616"/>
+            <a:ext cx="1280160" cy="137160"/>
+          </a:xfrm>
+          <a:prstGeom prst="rect">
+            <a:avLst/>
+          </a:prstGeom>
+          <a:solidFill>
+            <a:srgbClr val="0E7490"/>
+          </a:solidFill>
+          <a:ln/>
+        </p:spPr>
+      </p:sp>
+      <p:sp>
+        <p:nvSpPr>
+          <p:cNvPr id="8" name="Text 5"/>
+          <p:cNvSpPr/>
+          <p:nvPr/>
+        </p:nvSpPr>
+        <p:spPr>
+          <a:xfrm>
+            <a:off x="2103120" y="3730752"/>
+            <a:ext cx="3703320" cy="256032"/>
+          </a:xfrm>
+          <a:prstGeom prst="rect">
+            <a:avLst/>
+          </a:prstGeom>
+          <a:noFill/>
+          <a:ln/>
+        </p:spPr>
+        <p:txBody>
+          <a:bodyPr wrap="square" lIns="0" tIns="0" rIns="0" bIns="0" rtlCol="0" anchor="ctr"/>
+          <a:lstStyle/>
+          <a:p>
+            <a:pPr indent="0" marL="0">
+              <a:buNone/>
+            </a:pPr>
+            <a:r>
+              <a:rPr lang="en-US" sz="1050" dirty="0">
+                <a:solidFill>
+                  <a:srgbClr val="1F2937"/>
+                </a:solidFill>
+                <a:latin typeface="Calibri" pitchFamily="34" charset="0"/>
+                <a:ea typeface="Calibri" pitchFamily="34" charset="-122"/>
+                <a:cs typeface="Calibri" pitchFamily="34" charset="-120"/>
+              </a:rPr>
+              <a:t>1. Urethra / bladder damage  </a:t>
+            </a:r>
+            <a:pPr indent="0" marL="0">
+              <a:buNone/>
+            </a:pPr>
+            <a:r>
+              <a:rPr lang="en-US" sz="1050" b="1" dirty="0">
+                <a:solidFill>
+                  <a:srgbClr val="000000"/>
+                </a:solidFill>
+                <a:latin typeface="Calibri" pitchFamily="34" charset="0"/>
+                <a:ea typeface="Calibri" pitchFamily="34" charset="-122"/>
+                <a:cs typeface="Calibri" pitchFamily="34" charset="-120"/>
+              </a:rPr>
+              <a:t>3</a:t>
+            </a:r>
+            <a:pPr indent="0" marL="0">
+              <a:buNone/>
+            </a:pPr>
+            <a:r>
+              <a:rPr lang="en-US" sz="1050" dirty="0">
                 <a:solidFill>
                   <a:srgbClr val="6B7280"/>
                 </a:solidFill>
@@ -4807,26 +3558,200 @@
                 <a:ea typeface="Calibri" pitchFamily="34" charset="-122"/>
                 <a:cs typeface="Calibri" pitchFamily="34" charset="-120"/>
               </a:rPr>
-              <a:t>Note: the Pelvic @ Nahunta 8/12 line was inspected PRIOR TO RECEIVING the tissue (before the harvesting tech got it) — its 12 rejects never became received product, so it is not graded as incoming FPY. Thoracic # columns for the 8/26 two-inspection visit are our QC inspection of harvest-passed blocks.</a:t>
+              <a:t>  ·  37.50%</a:t>
             </a:r>
-            <a:endParaRPr lang="en-US" sz="820" dirty="0"/>
+            <a:endParaRPr lang="en-US" sz="1050" dirty="0"/>
           </a:p>
         </p:txBody>
       </p:sp>
       <p:sp>
         <p:nvSpPr>
-          <p:cNvPr id="6" name="Shape 3"/>
+          <p:cNvPr id="9" name="Shape 6"/>
           <p:cNvSpPr/>
           <p:nvPr/>
         </p:nvSpPr>
         <p:spPr>
           <a:xfrm>
-            <a:off x="502920" y="3401568"/>
-            <a:ext cx="3611880" cy="1645920"/>
+            <a:off x="667512" y="4169664"/>
+            <a:ext cx="1280160" cy="137160"/>
+          </a:xfrm>
+          <a:prstGeom prst="rect">
+            <a:avLst/>
+          </a:prstGeom>
+          <a:solidFill>
+            <a:srgbClr val="0E7490"/>
+          </a:solidFill>
+          <a:ln/>
+        </p:spPr>
+      </p:sp>
+      <p:sp>
+        <p:nvSpPr>
+          <p:cNvPr id="10" name="Text 7"/>
+          <p:cNvSpPr/>
+          <p:nvPr/>
+        </p:nvSpPr>
+        <p:spPr>
+          <a:xfrm>
+            <a:off x="2103120" y="4114800"/>
+            <a:ext cx="3703320" cy="256032"/>
+          </a:xfrm>
+          <a:prstGeom prst="rect">
+            <a:avLst/>
+          </a:prstGeom>
+          <a:noFill/>
+          <a:ln/>
+        </p:spPr>
+        <p:txBody>
+          <a:bodyPr wrap="square" lIns="0" tIns="0" rIns="0" bIns="0" rtlCol="0" anchor="ctr"/>
+          <a:lstStyle/>
+          <a:p>
+            <a:pPr indent="0" marL="0">
+              <a:buNone/>
+            </a:pPr>
+            <a:r>
+              <a:rPr lang="en-US" sz="1050" dirty="0">
+                <a:solidFill>
+                  <a:srgbClr val="1F2937"/>
+                </a:solidFill>
+                <a:latin typeface="Calibri" pitchFamily="34" charset="0"/>
+                <a:ea typeface="Calibri" pitchFamily="34" charset="-122"/>
+                <a:cs typeface="Calibri" pitchFamily="34" charset="-120"/>
+              </a:rPr>
+              <a:t>2. Membrane damage  </a:t>
+            </a:r>
+            <a:pPr indent="0" marL="0">
+              <a:buNone/>
+            </a:pPr>
+            <a:r>
+              <a:rPr lang="en-US" sz="1050" b="1" dirty="0">
+                <a:solidFill>
+                  <a:srgbClr val="000000"/>
+                </a:solidFill>
+                <a:latin typeface="Calibri" pitchFamily="34" charset="0"/>
+                <a:ea typeface="Calibri" pitchFamily="34" charset="-122"/>
+                <a:cs typeface="Calibri" pitchFamily="34" charset="-120"/>
+              </a:rPr>
+              <a:t>3</a:t>
+            </a:r>
+            <a:pPr indent="0" marL="0">
+              <a:buNone/>
+            </a:pPr>
+            <a:r>
+              <a:rPr lang="en-US" sz="1050" dirty="0">
+                <a:solidFill>
+                  <a:srgbClr val="6B7280"/>
+                </a:solidFill>
+                <a:latin typeface="Calibri" pitchFamily="34" charset="0"/>
+                <a:ea typeface="Calibri" pitchFamily="34" charset="-122"/>
+                <a:cs typeface="Calibri" pitchFamily="34" charset="-120"/>
+              </a:rPr>
+              <a:t>  ·  37.50%</a:t>
+            </a:r>
+            <a:endParaRPr lang="en-US" sz="1050" dirty="0"/>
+          </a:p>
+        </p:txBody>
+      </p:sp>
+      <p:sp>
+        <p:nvSpPr>
+          <p:cNvPr id="11" name="Shape 8"/>
+          <p:cNvSpPr/>
+          <p:nvPr/>
+        </p:nvSpPr>
+        <p:spPr>
+          <a:xfrm>
+            <a:off x="667512" y="4553712"/>
+            <a:ext cx="853440" cy="137160"/>
+          </a:xfrm>
+          <a:prstGeom prst="rect">
+            <a:avLst/>
+          </a:prstGeom>
+          <a:solidFill>
+            <a:srgbClr val="0E7490"/>
+          </a:solidFill>
+          <a:ln/>
+        </p:spPr>
+      </p:sp>
+      <p:sp>
+        <p:nvSpPr>
+          <p:cNvPr id="12" name="Text 9"/>
+          <p:cNvSpPr/>
+          <p:nvPr/>
+        </p:nvSpPr>
+        <p:spPr>
+          <a:xfrm>
+            <a:off x="2103120" y="4498848"/>
+            <a:ext cx="3703320" cy="256032"/>
+          </a:xfrm>
+          <a:prstGeom prst="rect">
+            <a:avLst/>
+          </a:prstGeom>
+          <a:noFill/>
+          <a:ln/>
+        </p:spPr>
+        <p:txBody>
+          <a:bodyPr wrap="square" lIns="0" tIns="0" rIns="0" bIns="0" rtlCol="0" anchor="ctr"/>
+          <a:lstStyle/>
+          <a:p>
+            <a:pPr indent="0" marL="0">
+              <a:buNone/>
+            </a:pPr>
+            <a:r>
+              <a:rPr lang="en-US" sz="1050" dirty="0">
+                <a:solidFill>
+                  <a:srgbClr val="1F2937"/>
+                </a:solidFill>
+                <a:latin typeface="Calibri" pitchFamily="34" charset="0"/>
+                <a:ea typeface="Calibri" pitchFamily="34" charset="-122"/>
+                <a:cs typeface="Calibri" pitchFamily="34" charset="-120"/>
+              </a:rPr>
+              <a:t>3. Bowel damage / separation  </a:t>
+            </a:r>
+            <a:pPr indent="0" marL="0">
+              <a:buNone/>
+            </a:pPr>
+            <a:r>
+              <a:rPr lang="en-US" sz="1050" b="1" dirty="0">
+                <a:solidFill>
+                  <a:srgbClr val="000000"/>
+                </a:solidFill>
+                <a:latin typeface="Calibri" pitchFamily="34" charset="0"/>
+                <a:ea typeface="Calibri" pitchFamily="34" charset="-122"/>
+                <a:cs typeface="Calibri" pitchFamily="34" charset="-120"/>
+              </a:rPr>
+              <a:t>2</a:t>
+            </a:r>
+            <a:pPr indent="0" marL="0">
+              <a:buNone/>
+            </a:pPr>
+            <a:r>
+              <a:rPr lang="en-US" sz="1050" dirty="0">
+                <a:solidFill>
+                  <a:srgbClr val="6B7280"/>
+                </a:solidFill>
+                <a:latin typeface="Calibri" pitchFamily="34" charset="0"/>
+                <a:ea typeface="Calibri" pitchFamily="34" charset="-122"/>
+                <a:cs typeface="Calibri" pitchFamily="34" charset="-120"/>
+              </a:rPr>
+              <a:t>  ·  25.00%</a:t>
+            </a:r>
+            <a:endParaRPr lang="en-US" sz="1050" dirty="0"/>
+          </a:p>
+        </p:txBody>
+      </p:sp>
+      <p:sp>
+        <p:nvSpPr>
+          <p:cNvPr id="13" name="Shape 10"/>
+          <p:cNvSpPr/>
+          <p:nvPr/>
+        </p:nvSpPr>
+        <p:spPr>
+          <a:xfrm>
+            <a:off x="6199632" y="3246120"/>
+            <a:ext cx="5486400" cy="1783080"/>
           </a:xfrm>
           <a:prstGeom prst="roundRect">
             <a:avLst>
-              <a:gd name="adj" fmla="val 3333"/>
+              <a:gd name="adj" fmla="val 3077"/>
             </a:avLst>
           </a:prstGeom>
           <a:solidFill>
@@ -4842,14 +3767,14 @@
       </p:sp>
       <p:sp>
         <p:nvSpPr>
-          <p:cNvPr id="7" name="Text 4"/>
+          <p:cNvPr id="14" name="Text 11"/>
           <p:cNvSpPr/>
           <p:nvPr/>
         </p:nvSpPr>
         <p:spPr>
           <a:xfrm>
-            <a:off x="640080" y="3483864"/>
-            <a:ext cx="3337560" cy="310896"/>
+            <a:off x="6364224" y="3346704"/>
+            <a:ext cx="5157216" cy="310896"/>
           </a:xfrm>
           <a:prstGeom prst="rect">
             <a:avLst/>
@@ -4865,7 +3790,7 @@
               <a:buNone/>
             </a:pPr>
             <a:r>
-              <a:rPr lang="en-US" sz="1050" b="1" dirty="0">
+              <a:rPr lang="en-US" sz="1150" b="1" dirty="0">
                 <a:solidFill>
                   <a:srgbClr val="1F2937"/>
                 </a:solidFill>
@@ -4873,22 +3798,22 @@
                 <a:ea typeface="Calibri" pitchFamily="34" charset="-122"/>
                 <a:cs typeface="Calibri" pitchFamily="34" charset="-120"/>
               </a:rPr>
-              <a:t>Pelvic @ Martins · 666541 — 8 fails of 198</a:t>
+              <a:t>Pelvic @ Parks · 666541 — 2 fails of 46 inspected</a:t>
             </a:r>
-            <a:endParaRPr lang="en-US" sz="1050" dirty="0"/>
+            <a:endParaRPr lang="en-US" sz="1150" dirty="0"/>
           </a:p>
         </p:txBody>
       </p:sp>
       <p:sp>
         <p:nvSpPr>
-          <p:cNvPr id="8" name="Shape 5"/>
+          <p:cNvPr id="15" name="Shape 12"/>
           <p:cNvSpPr/>
           <p:nvPr/>
         </p:nvSpPr>
         <p:spPr>
           <a:xfrm>
-            <a:off x="640080" y="3863340"/>
-            <a:ext cx="92915" cy="118872"/>
+            <a:off x="6364224" y="3785616"/>
+            <a:ext cx="426720" cy="137160"/>
           </a:xfrm>
           <a:prstGeom prst="rect">
             <a:avLst/>
@@ -4901,14 +3826,14 @@
       </p:sp>
       <p:sp>
         <p:nvSpPr>
-          <p:cNvPr id="9" name="Text 6"/>
+          <p:cNvPr id="16" name="Text 13"/>
           <p:cNvSpPr/>
           <p:nvPr/>
         </p:nvSpPr>
         <p:spPr>
           <a:xfrm>
-            <a:off x="1691640" y="3813048"/>
-            <a:ext cx="2286000" cy="237744"/>
+            <a:off x="7799832" y="3730752"/>
+            <a:ext cx="3703320" cy="256032"/>
           </a:xfrm>
           <a:prstGeom prst="rect">
             <a:avLst/>
@@ -4924,7 +3849,7 @@
               <a:buNone/>
             </a:pPr>
             <a:r>
-              <a:rPr lang="en-US" sz="950" dirty="0">
+              <a:rPr lang="en-US" sz="1050" dirty="0">
                 <a:solidFill>
                   <a:srgbClr val="1F2937"/>
                 </a:solidFill>
@@ -4932,13 +3857,13 @@
                 <a:ea typeface="Calibri" pitchFamily="34" charset="-122"/>
                 <a:cs typeface="Calibri" pitchFamily="34" charset="-120"/>
               </a:rPr>
-              <a:t>1. Urethra / bladder damage  </a:t>
+              <a:t>1. Bowel damage / separation  </a:t>
             </a:r>
             <a:pPr indent="0" marL="0">
               <a:buNone/>
             </a:pPr>
             <a:r>
-              <a:rPr lang="en-US" sz="950" b="1" dirty="0">
+              <a:rPr lang="en-US" sz="1050" b="1" dirty="0">
                 <a:solidFill>
                   <a:srgbClr val="000000"/>
                 </a:solidFill>
@@ -4946,13 +3871,13 @@
                 <a:ea typeface="Calibri" pitchFamily="34" charset="-122"/>
                 <a:cs typeface="Calibri" pitchFamily="34" charset="-120"/>
               </a:rPr>
-              <a:t>3</a:t>
+              <a:t>1</a:t>
             </a:r>
             <a:pPr indent="0" marL="0">
               <a:buNone/>
             </a:pPr>
             <a:r>
-              <a:rPr lang="en-US" sz="950" dirty="0">
+              <a:rPr lang="en-US" sz="1050" dirty="0">
                 <a:solidFill>
                   <a:srgbClr val="6B7280"/>
                 </a:solidFill>
@@ -4960,22 +3885,22 @@
                 <a:ea typeface="Calibri" pitchFamily="34" charset="-122"/>
                 <a:cs typeface="Calibri" pitchFamily="34" charset="-120"/>
               </a:rPr>
-              <a:t>  ·  37.50%</a:t>
+              <a:t>  ·  50.00%</a:t>
             </a:r>
-            <a:endParaRPr lang="en-US" sz="950" dirty="0"/>
+            <a:endParaRPr lang="en-US" sz="1050" dirty="0"/>
           </a:p>
         </p:txBody>
       </p:sp>
       <p:sp>
         <p:nvSpPr>
-          <p:cNvPr id="10" name="Shape 7"/>
+          <p:cNvPr id="17" name="Shape 14"/>
           <p:cNvSpPr/>
           <p:nvPr/>
         </p:nvSpPr>
         <p:spPr>
           <a:xfrm>
-            <a:off x="640080" y="4192524"/>
-            <a:ext cx="92915" cy="118872"/>
+            <a:off x="6364224" y="4169664"/>
+            <a:ext cx="426720" cy="137160"/>
           </a:xfrm>
           <a:prstGeom prst="rect">
             <a:avLst/>
@@ -4988,14 +3913,14 @@
       </p:sp>
       <p:sp>
         <p:nvSpPr>
-          <p:cNvPr id="11" name="Text 8"/>
+          <p:cNvPr id="18" name="Text 15"/>
           <p:cNvSpPr/>
           <p:nvPr/>
         </p:nvSpPr>
         <p:spPr>
           <a:xfrm>
-            <a:off x="1691640" y="4142232"/>
-            <a:ext cx="2286000" cy="237744"/>
+            <a:off x="7799832" y="4114800"/>
+            <a:ext cx="3703320" cy="256032"/>
           </a:xfrm>
           <a:prstGeom prst="rect">
             <a:avLst/>
@@ -5011,7 +3936,7 @@
               <a:buNone/>
             </a:pPr>
             <a:r>
-              <a:rPr lang="en-US" sz="950" dirty="0">
+              <a:rPr lang="en-US" sz="1050" dirty="0">
                 <a:solidFill>
                   <a:srgbClr val="1F2937"/>
                 </a:solidFill>
@@ -5019,253 +3944,13 @@
                 <a:ea typeface="Calibri" pitchFamily="34" charset="-122"/>
                 <a:cs typeface="Calibri" pitchFamily="34" charset="-120"/>
               </a:rPr>
-              <a:t>2. Membrane damage  </a:t>
+              <a:t>2. Critical-area laceration  </a:t>
             </a:r>
             <a:pPr indent="0" marL="0">
               <a:buNone/>
             </a:pPr>
             <a:r>
-              <a:rPr lang="en-US" sz="950" b="1" dirty="0">
-                <a:solidFill>
-                  <a:srgbClr val="000000"/>
-                </a:solidFill>
-                <a:latin typeface="Calibri" pitchFamily="34" charset="0"/>
-                <a:ea typeface="Calibri" pitchFamily="34" charset="-122"/>
-                <a:cs typeface="Calibri" pitchFamily="34" charset="-120"/>
-              </a:rPr>
-              <a:t>3</a:t>
-            </a:r>
-            <a:pPr indent="0" marL="0">
-              <a:buNone/>
-            </a:pPr>
-            <a:r>
-              <a:rPr lang="en-US" sz="950" dirty="0">
-                <a:solidFill>
-                  <a:srgbClr val="6B7280"/>
-                </a:solidFill>
-                <a:latin typeface="Calibri" pitchFamily="34" charset="0"/>
-                <a:ea typeface="Calibri" pitchFamily="34" charset="-122"/>
-                <a:cs typeface="Calibri" pitchFamily="34" charset="-120"/>
-              </a:rPr>
-              <a:t>  ·  37.50%</a:t>
-            </a:r>
-            <a:endParaRPr lang="en-US" sz="950" dirty="0"/>
-          </a:p>
-        </p:txBody>
-      </p:sp>
-      <p:sp>
-        <p:nvSpPr>
-          <p:cNvPr id="12" name="Shape 9"/>
-          <p:cNvSpPr/>
-          <p:nvPr/>
-        </p:nvSpPr>
-        <p:spPr>
-          <a:xfrm>
-            <a:off x="640080" y="4521708"/>
-            <a:ext cx="61943" cy="118872"/>
-          </a:xfrm>
-          <a:prstGeom prst="rect">
-            <a:avLst/>
-          </a:prstGeom>
-          <a:solidFill>
-            <a:srgbClr val="0E7490"/>
-          </a:solidFill>
-          <a:ln/>
-        </p:spPr>
-      </p:sp>
-      <p:sp>
-        <p:nvSpPr>
-          <p:cNvPr id="13" name="Text 10"/>
-          <p:cNvSpPr/>
-          <p:nvPr/>
-        </p:nvSpPr>
-        <p:spPr>
-          <a:xfrm>
-            <a:off x="1691640" y="4471416"/>
-            <a:ext cx="2286000" cy="237744"/>
-          </a:xfrm>
-          <a:prstGeom prst="rect">
-            <a:avLst/>
-          </a:prstGeom>
-          <a:noFill/>
-          <a:ln/>
-        </p:spPr>
-        <p:txBody>
-          <a:bodyPr wrap="square" lIns="0" tIns="0" rIns="0" bIns="0" rtlCol="0" anchor="ctr"/>
-          <a:lstStyle/>
-          <a:p>
-            <a:pPr indent="0" marL="0">
-              <a:buNone/>
-            </a:pPr>
-            <a:r>
-              <a:rPr lang="en-US" sz="950" dirty="0">
-                <a:solidFill>
-                  <a:srgbClr val="1F2937"/>
-                </a:solidFill>
-                <a:latin typeface="Calibri" pitchFamily="34" charset="0"/>
-                <a:ea typeface="Calibri" pitchFamily="34" charset="-122"/>
-                <a:cs typeface="Calibri" pitchFamily="34" charset="-120"/>
-              </a:rPr>
-              <a:t>3. Bowel damage / separation  </a:t>
-            </a:r>
-            <a:pPr indent="0" marL="0">
-              <a:buNone/>
-            </a:pPr>
-            <a:r>
-              <a:rPr lang="en-US" sz="950" b="1" dirty="0">
-                <a:solidFill>
-                  <a:srgbClr val="000000"/>
-                </a:solidFill>
-                <a:latin typeface="Calibri" pitchFamily="34" charset="0"/>
-                <a:ea typeface="Calibri" pitchFamily="34" charset="-122"/>
-                <a:cs typeface="Calibri" pitchFamily="34" charset="-120"/>
-              </a:rPr>
-              <a:t>2</a:t>
-            </a:r>
-            <a:pPr indent="0" marL="0">
-              <a:buNone/>
-            </a:pPr>
-            <a:r>
-              <a:rPr lang="en-US" sz="950" dirty="0">
-                <a:solidFill>
-                  <a:srgbClr val="6B7280"/>
-                </a:solidFill>
-                <a:latin typeface="Calibri" pitchFamily="34" charset="0"/>
-                <a:ea typeface="Calibri" pitchFamily="34" charset="-122"/>
-                <a:cs typeface="Calibri" pitchFamily="34" charset="-120"/>
-              </a:rPr>
-              <a:t>  ·  25.00%</a:t>
-            </a:r>
-            <a:endParaRPr lang="en-US" sz="950" dirty="0"/>
-          </a:p>
-        </p:txBody>
-      </p:sp>
-      <p:sp>
-        <p:nvSpPr>
-          <p:cNvPr id="14" name="Shape 11"/>
-          <p:cNvSpPr/>
-          <p:nvPr/>
-        </p:nvSpPr>
-        <p:spPr>
-          <a:xfrm>
-            <a:off x="4288536" y="3401568"/>
-            <a:ext cx="3611880" cy="1645920"/>
-          </a:xfrm>
-          <a:prstGeom prst="roundRect">
-            <a:avLst>
-              <a:gd name="adj" fmla="val 3333"/>
-            </a:avLst>
-          </a:prstGeom>
-          <a:solidFill>
-            <a:srgbClr val="F3F4F6"/>
-          </a:solidFill>
-          <a:ln w="9525">
-            <a:solidFill>
-              <a:srgbClr val="E5E7EB"/>
-            </a:solidFill>
-            <a:prstDash val="solid"/>
-          </a:ln>
-        </p:spPr>
-      </p:sp>
-      <p:sp>
-        <p:nvSpPr>
-          <p:cNvPr id="15" name="Text 12"/>
-          <p:cNvSpPr/>
-          <p:nvPr/>
-        </p:nvSpPr>
-        <p:spPr>
-          <a:xfrm>
-            <a:off x="4425696" y="3483864"/>
-            <a:ext cx="3337560" cy="310896"/>
-          </a:xfrm>
-          <a:prstGeom prst="rect">
-            <a:avLst/>
-          </a:prstGeom>
-          <a:noFill/>
-          <a:ln/>
-        </p:spPr>
-        <p:txBody>
-          <a:bodyPr wrap="square" lIns="0" tIns="0" rIns="0" bIns="0" rtlCol="0" anchor="ctr"/>
-          <a:lstStyle/>
-          <a:p>
-            <a:pPr indent="0" marL="0">
-              <a:buNone/>
-            </a:pPr>
-            <a:r>
               <a:rPr lang="en-US" sz="1050" b="1" dirty="0">
-                <a:solidFill>
-                  <a:srgbClr val="1F2937"/>
-                </a:solidFill>
-                <a:latin typeface="Calibri" pitchFamily="34" charset="0"/>
-                <a:ea typeface="Calibri" pitchFamily="34" charset="-122"/>
-                <a:cs typeface="Calibri" pitchFamily="34" charset="-120"/>
-              </a:rPr>
-              <a:t>Pelvic @ Parks · 666541 — 2 fails of 46</a:t>
-            </a:r>
-            <a:endParaRPr lang="en-US" sz="1050" dirty="0"/>
-          </a:p>
-        </p:txBody>
-      </p:sp>
-      <p:sp>
-        <p:nvSpPr>
-          <p:cNvPr id="16" name="Shape 13"/>
-          <p:cNvSpPr/>
-          <p:nvPr/>
-        </p:nvSpPr>
-        <p:spPr>
-          <a:xfrm>
-            <a:off x="4425696" y="3863340"/>
-            <a:ext cx="54864" cy="118872"/>
-          </a:xfrm>
-          <a:prstGeom prst="rect">
-            <a:avLst/>
-          </a:prstGeom>
-          <a:solidFill>
-            <a:srgbClr val="0E7490"/>
-          </a:solidFill>
-          <a:ln/>
-        </p:spPr>
-      </p:sp>
-      <p:sp>
-        <p:nvSpPr>
-          <p:cNvPr id="17" name="Text 14"/>
-          <p:cNvSpPr/>
-          <p:nvPr/>
-        </p:nvSpPr>
-        <p:spPr>
-          <a:xfrm>
-            <a:off x="5477256" y="3813048"/>
-            <a:ext cx="2286000" cy="237744"/>
-          </a:xfrm>
-          <a:prstGeom prst="rect">
-            <a:avLst/>
-          </a:prstGeom>
-          <a:noFill/>
-          <a:ln/>
-        </p:spPr>
-        <p:txBody>
-          <a:bodyPr wrap="square" lIns="0" tIns="0" rIns="0" bIns="0" rtlCol="0" anchor="ctr"/>
-          <a:lstStyle/>
-          <a:p>
-            <a:pPr indent="0" marL="0">
-              <a:buNone/>
-            </a:pPr>
-            <a:r>
-              <a:rPr lang="en-US" sz="950" dirty="0">
-                <a:solidFill>
-                  <a:srgbClr val="1F2937"/>
-                </a:solidFill>
-                <a:latin typeface="Calibri" pitchFamily="34" charset="0"/>
-                <a:ea typeface="Calibri" pitchFamily="34" charset="-122"/>
-                <a:cs typeface="Calibri" pitchFamily="34" charset="-120"/>
-              </a:rPr>
-              <a:t>1. Bowel damage / separation  </a:t>
-            </a:r>
-            <a:pPr indent="0" marL="0">
-              <a:buNone/>
-            </a:pPr>
-            <a:r>
-              <a:rPr lang="en-US" sz="950" b="1" dirty="0">
                 <a:solidFill>
                   <a:srgbClr val="000000"/>
                 </a:solidFill>
@@ -5279,7 +3964,7 @@
               <a:buNone/>
             </a:pPr>
             <a:r>
-              <a:rPr lang="en-US" sz="950" dirty="0">
+              <a:rPr lang="en-US" sz="1050" dirty="0">
                 <a:solidFill>
                   <a:srgbClr val="6B7280"/>
                 </a:solidFill>
@@ -5289,438 +3974,24 @@
               </a:rPr>
               <a:t>  ·  50.00%</a:t>
             </a:r>
-            <a:endParaRPr lang="en-US" sz="950" dirty="0"/>
-          </a:p>
-        </p:txBody>
-      </p:sp>
-      <p:sp>
-        <p:nvSpPr>
-          <p:cNvPr id="18" name="Shape 15"/>
-          <p:cNvSpPr/>
-          <p:nvPr/>
-        </p:nvSpPr>
-        <p:spPr>
-          <a:xfrm>
-            <a:off x="4425696" y="4192524"/>
-            <a:ext cx="54864" cy="118872"/>
-          </a:xfrm>
-          <a:prstGeom prst="rect">
-            <a:avLst/>
-          </a:prstGeom>
-          <a:solidFill>
-            <a:srgbClr val="0E7490"/>
-          </a:solidFill>
-          <a:ln/>
-        </p:spPr>
-      </p:sp>
-      <p:sp>
-        <p:nvSpPr>
-          <p:cNvPr id="19" name="Text 16"/>
-          <p:cNvSpPr/>
-          <p:nvPr/>
-        </p:nvSpPr>
-        <p:spPr>
-          <a:xfrm>
-            <a:off x="5477256" y="4142232"/>
-            <a:ext cx="2286000" cy="237744"/>
-          </a:xfrm>
-          <a:prstGeom prst="rect">
-            <a:avLst/>
-          </a:prstGeom>
-          <a:noFill/>
-          <a:ln/>
-        </p:spPr>
-        <p:txBody>
-          <a:bodyPr wrap="square" lIns="0" tIns="0" rIns="0" bIns="0" rtlCol="0" anchor="ctr"/>
-          <a:lstStyle/>
-          <a:p>
-            <a:pPr indent="0" marL="0">
-              <a:buNone/>
-            </a:pPr>
-            <a:r>
-              <a:rPr lang="en-US" sz="950" dirty="0">
-                <a:solidFill>
-                  <a:srgbClr val="1F2937"/>
-                </a:solidFill>
-                <a:latin typeface="Calibri" pitchFamily="34" charset="0"/>
-                <a:ea typeface="Calibri" pitchFamily="34" charset="-122"/>
-                <a:cs typeface="Calibri" pitchFamily="34" charset="-120"/>
-              </a:rPr>
-              <a:t>2. Critical-area laceration  </a:t>
-            </a:r>
-            <a:pPr indent="0" marL="0">
-              <a:buNone/>
-            </a:pPr>
-            <a:r>
-              <a:rPr lang="en-US" sz="950" b="1" dirty="0">
-                <a:solidFill>
-                  <a:srgbClr val="000000"/>
-                </a:solidFill>
-                <a:latin typeface="Calibri" pitchFamily="34" charset="0"/>
-                <a:ea typeface="Calibri" pitchFamily="34" charset="-122"/>
-                <a:cs typeface="Calibri" pitchFamily="34" charset="-120"/>
-              </a:rPr>
-              <a:t>1</a:t>
-            </a:r>
-            <a:pPr indent="0" marL="0">
-              <a:buNone/>
-            </a:pPr>
-            <a:r>
-              <a:rPr lang="en-US" sz="950" dirty="0">
-                <a:solidFill>
-                  <a:srgbClr val="6B7280"/>
-                </a:solidFill>
-                <a:latin typeface="Calibri" pitchFamily="34" charset="0"/>
-                <a:ea typeface="Calibri" pitchFamily="34" charset="-122"/>
-                <a:cs typeface="Calibri" pitchFamily="34" charset="-120"/>
-              </a:rPr>
-              <a:t>  ·  50.00%</a:t>
-            </a:r>
-            <a:endParaRPr lang="en-US" sz="950" dirty="0"/>
-          </a:p>
-        </p:txBody>
-      </p:sp>
-      <p:sp>
-        <p:nvSpPr>
-          <p:cNvPr id="20" name="Shape 17"/>
-          <p:cNvSpPr/>
-          <p:nvPr/>
-        </p:nvSpPr>
-        <p:spPr>
-          <a:xfrm>
-            <a:off x="8074152" y="3401568"/>
-            <a:ext cx="3611880" cy="1645920"/>
-          </a:xfrm>
-          <a:prstGeom prst="roundRect">
-            <a:avLst>
-              <a:gd name="adj" fmla="val 3333"/>
-            </a:avLst>
-          </a:prstGeom>
-          <a:solidFill>
-            <a:srgbClr val="F3F4F6"/>
-          </a:solidFill>
-          <a:ln w="9525">
-            <a:solidFill>
-              <a:srgbClr val="E5E7EB"/>
-            </a:solidFill>
-            <a:prstDash val="solid"/>
-          </a:ln>
-        </p:spPr>
-      </p:sp>
-      <p:sp>
-        <p:nvSpPr>
-          <p:cNvPr id="21" name="Text 18"/>
-          <p:cNvSpPr/>
-          <p:nvPr/>
-        </p:nvSpPr>
-        <p:spPr>
-          <a:xfrm>
-            <a:off x="8211312" y="3483864"/>
-            <a:ext cx="3337560" cy="310896"/>
-          </a:xfrm>
-          <a:prstGeom prst="rect">
-            <a:avLst/>
-          </a:prstGeom>
-          <a:noFill/>
-          <a:ln/>
-        </p:spPr>
-        <p:txBody>
-          <a:bodyPr wrap="square" lIns="0" tIns="0" rIns="0" bIns="0" rtlCol="0" anchor="ctr"/>
-          <a:lstStyle/>
-          <a:p>
-            <a:pPr indent="0" marL="0">
-              <a:buNone/>
-            </a:pPr>
-            <a:r>
-              <a:rPr lang="en-US" sz="1050" b="1" dirty="0">
-                <a:solidFill>
-                  <a:srgbClr val="1F2937"/>
-                </a:solidFill>
-                <a:latin typeface="Calibri" pitchFamily="34" charset="0"/>
-                <a:ea typeface="Calibri" pitchFamily="34" charset="-122"/>
-                <a:cs typeface="Calibri" pitchFamily="34" charset="-120"/>
-              </a:rPr>
-              <a:t>Thoracic @ Nahunta · 666521 — 50 fails of 66</a:t>
-            </a:r>
             <a:endParaRPr lang="en-US" sz="1050" dirty="0"/>
           </a:p>
         </p:txBody>
       </p:sp>
       <p:sp>
         <p:nvSpPr>
-          <p:cNvPr id="22" name="Shape 19"/>
+          <p:cNvPr id="19" name="Shape 16"/>
           <p:cNvSpPr/>
           <p:nvPr/>
         </p:nvSpPr>
         <p:spPr>
           <a:xfrm>
-            <a:off x="8211312" y="3863340"/>
-            <a:ext cx="960120" cy="118872"/>
-          </a:xfrm>
-          <a:prstGeom prst="rect">
-            <a:avLst/>
-          </a:prstGeom>
-          <a:solidFill>
-            <a:srgbClr val="0E7490"/>
-          </a:solidFill>
-          <a:ln/>
-        </p:spPr>
-      </p:sp>
-      <p:sp>
-        <p:nvSpPr>
-          <p:cNvPr id="23" name="Text 20"/>
-          <p:cNvSpPr/>
-          <p:nvPr/>
-        </p:nvSpPr>
-        <p:spPr>
-          <a:xfrm>
-            <a:off x="9262872" y="3813048"/>
-            <a:ext cx="2286000" cy="237744"/>
-          </a:xfrm>
-          <a:prstGeom prst="rect">
-            <a:avLst/>
-          </a:prstGeom>
-          <a:noFill/>
-          <a:ln/>
-        </p:spPr>
-        <p:txBody>
-          <a:bodyPr wrap="square" lIns="0" tIns="0" rIns="0" bIns="0" rtlCol="0" anchor="ctr"/>
-          <a:lstStyle/>
-          <a:p>
-            <a:pPr indent="0" marL="0">
-              <a:buNone/>
-            </a:pPr>
-            <a:r>
-              <a:rPr lang="en-US" sz="950" dirty="0">
-                <a:solidFill>
-                  <a:srgbClr val="1F2937"/>
-                </a:solidFill>
-                <a:latin typeface="Calibri" pitchFamily="34" charset="0"/>
-                <a:ea typeface="Calibri" pitchFamily="34" charset="-122"/>
-                <a:cs typeface="Calibri" pitchFamily="34" charset="-120"/>
-              </a:rPr>
-              <a:t>1. Lung laceration  </a:t>
-            </a:r>
-            <a:pPr indent="0" marL="0">
-              <a:buNone/>
-            </a:pPr>
-            <a:r>
-              <a:rPr lang="en-US" sz="950" b="1" dirty="0">
-                <a:solidFill>
-                  <a:srgbClr val="000000"/>
-                </a:solidFill>
-                <a:latin typeface="Calibri" pitchFamily="34" charset="0"/>
-                <a:ea typeface="Calibri" pitchFamily="34" charset="-122"/>
-                <a:cs typeface="Calibri" pitchFamily="34" charset="-120"/>
-              </a:rPr>
-              <a:t>31</a:t>
-            </a:r>
-            <a:pPr indent="0" marL="0">
-              <a:buNone/>
-            </a:pPr>
-            <a:r>
-              <a:rPr lang="en-US" sz="950" dirty="0">
-                <a:solidFill>
-                  <a:srgbClr val="6B7280"/>
-                </a:solidFill>
-                <a:latin typeface="Calibri" pitchFamily="34" charset="0"/>
-                <a:ea typeface="Calibri" pitchFamily="34" charset="-122"/>
-                <a:cs typeface="Calibri" pitchFamily="34" charset="-120"/>
-              </a:rPr>
-              <a:t>  ·  62.00%</a:t>
-            </a:r>
-            <a:endParaRPr lang="en-US" sz="950" dirty="0"/>
-          </a:p>
-        </p:txBody>
-      </p:sp>
-      <p:sp>
-        <p:nvSpPr>
-          <p:cNvPr id="24" name="Shape 21"/>
-          <p:cNvSpPr/>
-          <p:nvPr/>
-        </p:nvSpPr>
-        <p:spPr>
-          <a:xfrm>
-            <a:off x="8211312" y="4192524"/>
-            <a:ext cx="588461" cy="118872"/>
-          </a:xfrm>
-          <a:prstGeom prst="rect">
-            <a:avLst/>
-          </a:prstGeom>
-          <a:solidFill>
-            <a:srgbClr val="0E7490"/>
-          </a:solidFill>
-          <a:ln/>
-        </p:spPr>
-      </p:sp>
-      <p:sp>
-        <p:nvSpPr>
-          <p:cNvPr id="25" name="Text 22"/>
-          <p:cNvSpPr/>
-          <p:nvPr/>
-        </p:nvSpPr>
-        <p:spPr>
-          <a:xfrm>
-            <a:off x="9262872" y="4142232"/>
-            <a:ext cx="2286000" cy="237744"/>
-          </a:xfrm>
-          <a:prstGeom prst="rect">
-            <a:avLst/>
-          </a:prstGeom>
-          <a:noFill/>
-          <a:ln/>
-        </p:spPr>
-        <p:txBody>
-          <a:bodyPr wrap="square" lIns="0" tIns="0" rIns="0" bIns="0" rtlCol="0" anchor="ctr"/>
-          <a:lstStyle/>
-          <a:p>
-            <a:pPr indent="0" marL="0">
-              <a:buNone/>
-            </a:pPr>
-            <a:r>
-              <a:rPr lang="en-US" sz="950" dirty="0">
-                <a:solidFill>
-                  <a:srgbClr val="1F2937"/>
-                </a:solidFill>
-                <a:latin typeface="Calibri" pitchFamily="34" charset="0"/>
-                <a:ea typeface="Calibri" pitchFamily="34" charset="-122"/>
-                <a:cs typeface="Calibri" pitchFamily="34" charset="-120"/>
-              </a:rPr>
-              <a:t>2. Heart damage  </a:t>
-            </a:r>
-            <a:pPr indent="0" marL="0">
-              <a:buNone/>
-            </a:pPr>
-            <a:r>
-              <a:rPr lang="en-US" sz="950" b="1" dirty="0">
-                <a:solidFill>
-                  <a:srgbClr val="000000"/>
-                </a:solidFill>
-                <a:latin typeface="Calibri" pitchFamily="34" charset="0"/>
-                <a:ea typeface="Calibri" pitchFamily="34" charset="-122"/>
-                <a:cs typeface="Calibri" pitchFamily="34" charset="-120"/>
-              </a:rPr>
-              <a:t>19</a:t>
-            </a:r>
-            <a:pPr indent="0" marL="0">
-              <a:buNone/>
-            </a:pPr>
-            <a:r>
-              <a:rPr lang="en-US" sz="950" dirty="0">
-                <a:solidFill>
-                  <a:srgbClr val="6B7280"/>
-                </a:solidFill>
-                <a:latin typeface="Calibri" pitchFamily="34" charset="0"/>
-                <a:ea typeface="Calibri" pitchFamily="34" charset="-122"/>
-                <a:cs typeface="Calibri" pitchFamily="34" charset="-120"/>
-              </a:rPr>
-              <a:t>  ·  38.00%</a:t>
-            </a:r>
-            <a:endParaRPr lang="en-US" sz="950" dirty="0"/>
-          </a:p>
-        </p:txBody>
-      </p:sp>
-      <p:sp>
-        <p:nvSpPr>
-          <p:cNvPr id="26" name="Shape 23"/>
-          <p:cNvSpPr/>
-          <p:nvPr/>
-        </p:nvSpPr>
-        <p:spPr>
-          <a:xfrm>
-            <a:off x="8211312" y="4521708"/>
-            <a:ext cx="54864" cy="118872"/>
-          </a:xfrm>
-          <a:prstGeom prst="rect">
-            <a:avLst/>
-          </a:prstGeom>
-          <a:solidFill>
-            <a:srgbClr val="0E7490"/>
-          </a:solidFill>
-          <a:ln/>
-        </p:spPr>
-      </p:sp>
-      <p:sp>
-        <p:nvSpPr>
-          <p:cNvPr id="27" name="Text 24"/>
-          <p:cNvSpPr/>
-          <p:nvPr/>
-        </p:nvSpPr>
-        <p:spPr>
-          <a:xfrm>
-            <a:off x="9262872" y="4471416"/>
-            <a:ext cx="2286000" cy="237744"/>
-          </a:xfrm>
-          <a:prstGeom prst="rect">
-            <a:avLst/>
-          </a:prstGeom>
-          <a:noFill/>
-          <a:ln/>
-        </p:spPr>
-        <p:txBody>
-          <a:bodyPr wrap="square" lIns="0" tIns="0" rIns="0" bIns="0" rtlCol="0" anchor="ctr"/>
-          <a:lstStyle/>
-          <a:p>
-            <a:pPr indent="0" marL="0">
-              <a:buNone/>
-            </a:pPr>
-            <a:r>
-              <a:rPr lang="en-US" sz="950" dirty="0">
-                <a:solidFill>
-                  <a:srgbClr val="1F2937"/>
-                </a:solidFill>
-                <a:latin typeface="Calibri" pitchFamily="34" charset="0"/>
-                <a:ea typeface="Calibri" pitchFamily="34" charset="-122"/>
-                <a:cs typeface="Calibri" pitchFamily="34" charset="-120"/>
-              </a:rPr>
-              <a:t>3. Undocumented / not itemized  </a:t>
-            </a:r>
-            <a:pPr indent="0" marL="0">
-              <a:buNone/>
-            </a:pPr>
-            <a:r>
-              <a:rPr lang="en-US" sz="950" b="1" dirty="0">
-                <a:solidFill>
-                  <a:srgbClr val="000000"/>
-                </a:solidFill>
-                <a:latin typeface="Calibri" pitchFamily="34" charset="0"/>
-                <a:ea typeface="Calibri" pitchFamily="34" charset="-122"/>
-                <a:cs typeface="Calibri" pitchFamily="34" charset="-120"/>
-              </a:rPr>
-              <a:t>1</a:t>
-            </a:r>
-            <a:pPr indent="0" marL="0">
-              <a:buNone/>
-            </a:pPr>
-            <a:r>
-              <a:rPr lang="en-US" sz="950" dirty="0">
-                <a:solidFill>
-                  <a:srgbClr val="6B7280"/>
-                </a:solidFill>
-                <a:latin typeface="Calibri" pitchFamily="34" charset="0"/>
-                <a:ea typeface="Calibri" pitchFamily="34" charset="-122"/>
-                <a:cs typeface="Calibri" pitchFamily="34" charset="-120"/>
-              </a:rPr>
-              <a:t>  ·  2.00%</a:t>
-            </a:r>
-            <a:endParaRPr lang="en-US" sz="950" dirty="0"/>
-          </a:p>
-        </p:txBody>
-      </p:sp>
-      <p:sp>
-        <p:nvSpPr>
-          <p:cNvPr id="28" name="Shape 25"/>
-          <p:cNvSpPr/>
-          <p:nvPr/>
-        </p:nvSpPr>
-        <p:spPr>
-          <a:xfrm>
-            <a:off x="502920" y="5138928"/>
-            <a:ext cx="11183112" cy="1261872"/>
+            <a:off x="502920" y="5303520"/>
+            <a:ext cx="11183112" cy="1051560"/>
           </a:xfrm>
           <a:prstGeom prst="roundRect">
             <a:avLst>
-              <a:gd name="adj" fmla="val 3623"/>
+              <a:gd name="adj" fmla="val 4348"/>
             </a:avLst>
           </a:prstGeom>
           <a:solidFill>
@@ -5731,13 +4002,13 @@
       </p:sp>
       <p:sp>
         <p:nvSpPr>
-          <p:cNvPr id="29" name="Text 26"/>
+          <p:cNvPr id="20" name="Text 17"/>
           <p:cNvSpPr/>
           <p:nvPr/>
         </p:nvSpPr>
         <p:spPr>
           <a:xfrm>
-            <a:off x="685800" y="5212080"/>
+            <a:off x="685800" y="5394960"/>
             <a:ext cx="3657600" cy="219456"/>
           </a:xfrm>
           <a:prstGeom prst="rect">
@@ -5754,7 +4025,7 @@
               <a:buNone/>
             </a:pPr>
             <a:r>
-              <a:rPr lang="en-US" sz="1050" b="1" dirty="0">
+              <a:rPr lang="en-US" sz="1100" b="1" dirty="0">
                 <a:solidFill>
                   <a:srgbClr val="0E7490"/>
                 </a:solidFill>
@@ -5764,20 +4035,20 @@
               </a:rPr>
               <a:t>Key takeaways</a:t>
             </a:r>
-            <a:endParaRPr lang="en-US" sz="1050" dirty="0"/>
+            <a:endParaRPr lang="en-US" sz="1100" dirty="0"/>
           </a:p>
         </p:txBody>
       </p:sp>
       <p:sp>
         <p:nvSpPr>
-          <p:cNvPr id="30" name="Text 27"/>
+          <p:cNvPr id="21" name="Text 18"/>
           <p:cNvSpPr/>
           <p:nvPr/>
         </p:nvSpPr>
         <p:spPr>
           <a:xfrm>
-            <a:off x="713232" y="5440680"/>
-            <a:ext cx="10835640" cy="914400"/>
+            <a:off x="713232" y="5632704"/>
+            <a:ext cx="10835640" cy="658368"/>
           </a:xfrm>
           <a:prstGeom prst="rect">
             <a:avLst/>
@@ -5791,13 +4062,13 @@
           <a:p>
             <a:pPr marL="342900" indent="-342900">
               <a:spcAft>
-                <a:spcPts val="200"/>
+                <a:spcPts val="300"/>
               </a:spcAft>
               <a:buSzPct val="100000"/>
               <a:buChar char="➢"/>
             </a:pPr>
             <a:r>
-              <a:rPr lang="en-US" sz="820" dirty="0">
+              <a:rPr lang="en-US" sz="1000" dirty="0">
                 <a:solidFill>
                   <a:srgbClr val="1F2937"/>
                 </a:solidFill>
@@ -5807,18 +4078,18 @@
               </a:rPr>
               <a:t>666541 (Pelvic @ Martins): 96.0% FPY on 198 — clean month; scattered singles (bowel, urethra, membrane).</a:t>
             </a:r>
-            <a:endParaRPr lang="en-US" sz="820" dirty="0"/>
+            <a:endParaRPr lang="en-US" sz="1000" dirty="0"/>
           </a:p>
           <a:p>
             <a:pPr marL="342900" indent="-342900">
               <a:spcAft>
-                <a:spcPts val="200"/>
+                <a:spcPts val="300"/>
               </a:spcAft>
               <a:buSzPct val="100000"/>
               <a:buChar char="➢"/>
             </a:pPr>
             <a:r>
-              <a:rPr lang="en-US" sz="820" dirty="0">
+              <a:rPr lang="en-US" sz="1000" dirty="0">
                 <a:solidFill>
                   <a:srgbClr val="1F2937"/>
                 </a:solidFill>
@@ -5828,18 +4099,18 @@
               </a:rPr>
               <a:t>666506 (Pelvic @ Martins): 100% FPY on 20 — no failures.</a:t>
             </a:r>
-            <a:endParaRPr lang="en-US" sz="820" dirty="0"/>
+            <a:endParaRPr lang="en-US" sz="1000" dirty="0"/>
           </a:p>
           <a:p>
             <a:pPr marL="342900" indent="-342900">
               <a:spcAft>
-                <a:spcPts val="200"/>
+                <a:spcPts val="300"/>
               </a:spcAft>
               <a:buSzPct val="100000"/>
               <a:buChar char="➢"/>
             </a:pPr>
             <a:r>
-              <a:rPr lang="en-US" sz="820" dirty="0">
+              <a:rPr lang="en-US" sz="1000" dirty="0">
                 <a:solidFill>
                   <a:srgbClr val="1F2937"/>
                 </a:solidFill>
@@ -5849,76 +4120,13 @@
               </a:rPr>
               <a:t>666541 (Pelvic @ Parks): 95.7% FPY on 46 — strong start on the new spec after the 518 → 541 transition (8/10).</a:t>
             </a:r>
-            <a:endParaRPr lang="en-US" sz="820" dirty="0"/>
-          </a:p>
-          <a:p>
-            <a:pPr marL="342900" indent="-342900">
-              <a:spcAft>
-                <a:spcPts val="200"/>
-              </a:spcAft>
-              <a:buSzPct val="100000"/>
-              <a:buChar char="➢"/>
-            </a:pPr>
-            <a:r>
-              <a:rPr lang="en-US" sz="820" dirty="0">
-                <a:solidFill>
-                  <a:srgbClr val="1F2937"/>
-                </a:solidFill>
-                <a:latin typeface="Calibri" pitchFamily="34" charset="0"/>
-                <a:ea typeface="Calibri" pitchFamily="34" charset="-122"/>
-                <a:cs typeface="Calibri" pitchFamily="34" charset="-120"/>
-              </a:rPr>
-              <a:t>666521 (Thoracic @ Nahunta): 24.2% QC FPY on 66 across 4 visits — lung lacerations (31) + heart damage (19). 8/26 two-inspection visit: our QC passed 8 of the 9 blocks Jordan passed (88.9%); it took 18 at harvest to get those 8 good ones — rebound credited to Francisco's team.</a:t>
-            </a:r>
-            <a:endParaRPr lang="en-US" sz="820" dirty="0"/>
-          </a:p>
-          <a:p>
-            <a:pPr marL="342900" indent="-342900">
-              <a:spcAft>
-                <a:spcPts val="200"/>
-              </a:spcAft>
-              <a:buSzPct val="100000"/>
-              <a:buChar char="➢"/>
-            </a:pPr>
-            <a:r>
-              <a:rPr lang="en-US" sz="820" dirty="0">
-                <a:solidFill>
-                  <a:srgbClr val="1F2937"/>
-                </a:solidFill>
-                <a:latin typeface="Calibri" pitchFamily="34" charset="0"/>
-                <a:ea typeface="Calibri" pitchFamily="34" charset="-122"/>
-                <a:cs typeface="Calibri" pitchFamily="34" charset="-120"/>
-              </a:rPr>
-              <a:t>666541 (Pelvic @ Nahunta): 8/12 was a pre-receipt screen — 13 blocks inspected prior to receiving them; the 12 rejects never became received product (not graded as FPY; excluded from defect charts).</a:t>
-            </a:r>
-            <a:endParaRPr lang="en-US" sz="820" dirty="0"/>
-          </a:p>
-          <a:p>
-            <a:pPr marL="342900" indent="-342900">
-              <a:spcAft>
-                <a:spcPts val="200"/>
-              </a:spcAft>
-              <a:buSzPct val="100000"/>
-              <a:buChar char="➢"/>
-            </a:pPr>
-            <a:r>
-              <a:rPr lang="en-US" sz="820" dirty="0">
-                <a:solidFill>
-                  <a:srgbClr val="1F2937"/>
-                </a:solidFill>
-                <a:latin typeface="Calibri" pitchFamily="34" charset="0"/>
-                <a:ea typeface="Calibri" pitchFamily="34" charset="-122"/>
-                <a:cs typeface="Calibri" pitchFamily="34" charset="-120"/>
-              </a:rPr>
-              <a:t>September to date (9/9, two-inspection visit): our QC passed both blocks Jordan passed (2/2, 100%); it took 19 at harvest to get them — 17 rejected incl. 9 MISSING TRACHEA (tracheas harvested for another buyer).</a:t>
-            </a:r>
-            <a:endParaRPr lang="en-US" sz="820" dirty="0"/>
+            <a:endParaRPr lang="en-US" sz="1000" dirty="0"/>
           </a:p>
         </p:txBody>
       </p:sp>
       <p:sp>
         <p:nvSpPr>
-          <p:cNvPr id="31" name="Text 28"/>
+          <p:cNvPr id="22" name="Text 19"/>
           <p:cNvSpPr/>
           <p:nvPr/>
         </p:nvSpPr>
@@ -5957,7 +4165,7 @@
       </p:sp>
       <p:sp>
         <p:nvSpPr>
-          <p:cNvPr id="32" name="Text 29"/>
+          <p:cNvPr id="23" name="Text 20"/>
           <p:cNvSpPr/>
           <p:nvPr/>
         </p:nvSpPr>
@@ -6112,8 +4320,8 @@
         </p:nvSpPr>
         <p:spPr>
           <a:xfrm>
-            <a:off x="502920" y="1152144"/>
-            <a:ext cx="3657600" cy="237744"/>
+            <a:off x="502920" y="1207008"/>
+            <a:ext cx="3657600" cy="256032"/>
           </a:xfrm>
           <a:prstGeom prst="rect">
             <a:avLst/>
@@ -6129,7 +4337,7 @@
               <a:buNone/>
             </a:pPr>
             <a:r>
-              <a:rPr lang="en-US" sz="1250" b="1" dirty="0">
+              <a:rPr lang="en-US" sz="1300" b="1" dirty="0">
                 <a:solidFill>
                   <a:srgbClr val="0E7490"/>
                 </a:solidFill>
@@ -6139,7 +4347,7 @@
               </a:rPr>
               <a:t>PELVIC</a:t>
             </a:r>
-            <a:endParaRPr lang="en-US" sz="1250" dirty="0"/>
+            <a:endParaRPr lang="en-US" sz="1300" dirty="0"/>
           </a:p>
         </p:txBody>
       </p:sp>
@@ -6151,8 +4359,8 @@
         </p:nvSpPr>
         <p:spPr>
           <a:xfrm>
-            <a:off x="502920" y="1426464"/>
-            <a:ext cx="5394960" cy="219456"/>
+            <a:off x="502920" y="1572768"/>
+            <a:ext cx="5394960" cy="256032"/>
           </a:xfrm>
           <a:prstGeom prst="rect">
             <a:avLst/>
@@ -6168,7 +4376,7 @@
               <a:buNone/>
             </a:pPr>
             <a:r>
-              <a:rPr lang="en-US" sz="1000" b="1" dirty="0">
+              <a:rPr lang="en-US" sz="1200" b="1" dirty="0">
                 <a:solidFill>
                   <a:srgbClr val="1F2937"/>
                 </a:solidFill>
@@ -6176,9 +4384,9 @@
                 <a:ea typeface="Calibri" pitchFamily="34" charset="-122"/>
                 <a:cs typeface="Calibri" pitchFamily="34" charset="-120"/>
               </a:rPr>
-              <a:t>SH issues — 10 (August)</a:t>
+              <a:t>SH floor — 10 rejects (August)</a:t>
             </a:r>
-            <a:endParaRPr lang="en-US" sz="1000" dirty="0"/>
+            <a:endParaRPr lang="en-US" sz="1200" dirty="0"/>
           </a:p>
         </p:txBody>
       </p:sp>
@@ -6189,8 +4397,8 @@
           <p:nvPr/>
         </p:nvGraphicFramePr>
         <p:xfrm>
-          <a:off x="502920" y="1645920"/>
-          <a:ext cx="5394960" cy="1691640"/>
+          <a:off x="502920" y="1847088"/>
+          <a:ext cx="5394960" cy="3291840"/>
         </p:xfrm>
         <a:graphic xmlns:a="http://schemas.openxmlformats.org/drawingml/2006/main">
           <a:graphicData uri="http://schemas.openxmlformats.org/drawingml/2006/chart">
@@ -6206,8 +4414,8 @@
         </p:nvSpPr>
         <p:spPr>
           <a:xfrm>
-            <a:off x="6263640" y="1426464"/>
-            <a:ext cx="5394960" cy="219456"/>
+            <a:off x="6263640" y="1572768"/>
+            <a:ext cx="5394960" cy="256032"/>
           </a:xfrm>
           <a:prstGeom prst="rect">
             <a:avLst/>
@@ -6223,7 +4431,7 @@
               <a:buNone/>
             </a:pPr>
             <a:r>
-              <a:rPr lang="en-US" sz="1000" b="1" dirty="0">
+              <a:rPr lang="en-US" sz="1200" b="1" dirty="0">
                 <a:solidFill>
                   <a:srgbClr val="1F2937"/>
                 </a:solidFill>
@@ -6231,9 +4439,9 @@
                 <a:ea typeface="Calibri" pitchFamily="34" charset="-122"/>
                 <a:cs typeface="Calibri" pitchFamily="34" charset="-120"/>
               </a:rPr>
-              <a:t>ATM scrap — 40 units · matched batches, all quality</a:t>
+              <a:t>ATM receipt — 40 units scrapped (all quality codes)</a:t>
             </a:r>
-            <a:endParaRPr lang="en-US" sz="1000" dirty="0"/>
+            <a:endParaRPr lang="en-US" sz="1200" dirty="0"/>
           </a:p>
         </p:txBody>
       </p:sp>
@@ -6244,8 +4452,8 @@
           <p:nvPr/>
         </p:nvGraphicFramePr>
         <p:xfrm>
-          <a:off x="6263640" y="1645920"/>
-          <a:ext cx="5394960" cy="1691640"/>
+          <a:off x="6263640" y="1847088"/>
+          <a:ext cx="5394960" cy="3291840"/>
         </p:xfrm>
         <a:graphic xmlns:a="http://schemas.openxmlformats.org/drawingml/2006/main">
           <a:graphicData uri="http://schemas.openxmlformats.org/drawingml/2006/chart">
@@ -6261,8 +4469,8 @@
         </p:nvSpPr>
         <p:spPr>
           <a:xfrm>
-            <a:off x="502920" y="3310128"/>
-            <a:ext cx="11155680" cy="201168"/>
+            <a:off x="502920" y="5257800"/>
+            <a:ext cx="11155680" cy="457200"/>
           </a:xfrm>
           <a:prstGeom prst="rect">
             <a:avLst/>
@@ -6278,17 +4486,17 @@
               <a:buNone/>
             </a:pPr>
             <a:r>
-              <a:rPr lang="en-US" sz="820" i="1" dirty="0">
+              <a:rPr lang="en-US" sz="1000" dirty="0">
                 <a:solidFill>
-                  <a:srgbClr val="6B7280"/>
+                  <a:srgbClr val="1F2937"/>
                 </a:solidFill>
                 <a:latin typeface="Calibri" pitchFamily="34" charset="0"/>
                 <a:ea typeface="Calibri" pitchFamily="34" charset="-122"/>
                 <a:cs typeface="Calibri" pitchFamily="34" charset="-120"/>
               </a:rPr>
-              <a:t>Not charted: the Nahunta 8/12 line (12 rejects) — a pre-receipt screen, inspected prior to receiving the tissue; not incoming-QC fails and no reasons itemized.</a:t>
+              <a:t>Read: ATM's dominant code 9972 Laceration/Cut is the downstream face of the urethra/bladder and membrane cut damage flagged on the SH floor; Exposed Urethra and Bladder Length map to the same themes, while Blood Clots only surface post-freeze.</a:t>
             </a:r>
-            <a:endParaRPr lang="en-US" sz="820" dirty="0"/>
+            <a:endParaRPr lang="en-US" sz="1000" dirty="0"/>
           </a:p>
         </p:txBody>
       </p:sp>
@@ -6300,196 +4508,8 @@
         </p:nvSpPr>
         <p:spPr>
           <a:xfrm>
-            <a:off x="502920" y="3639312"/>
-            <a:ext cx="3657600" cy="237744"/>
-          </a:xfrm>
-          <a:prstGeom prst="rect">
-            <a:avLst/>
-          </a:prstGeom>
-          <a:noFill/>
-          <a:ln/>
-        </p:spPr>
-        <p:txBody>
-          <a:bodyPr wrap="square" lIns="0" tIns="0" rIns="0" bIns="0" rtlCol="0" anchor="ctr"/>
-          <a:lstStyle/>
-          <a:p>
-            <a:pPr indent="0" marL="0">
-              <a:buNone/>
-            </a:pPr>
-            <a:r>
-              <a:rPr lang="en-US" sz="1250" b="1" dirty="0">
-                <a:solidFill>
-                  <a:srgbClr val="0E7490"/>
-                </a:solidFill>
-                <a:latin typeface="Calibri" pitchFamily="34" charset="0"/>
-                <a:ea typeface="Calibri" pitchFamily="34" charset="-122"/>
-                <a:cs typeface="Calibri" pitchFamily="34" charset="-120"/>
-              </a:rPr>
-              <a:t>THORACIC</a:t>
-            </a:r>
-            <a:endParaRPr lang="en-US" sz="1250" dirty="0"/>
-          </a:p>
-        </p:txBody>
-      </p:sp>
-      <p:sp>
-        <p:nvSpPr>
-          <p:cNvPr id="11" name="Text 7"/>
-          <p:cNvSpPr/>
-          <p:nvPr/>
-        </p:nvSpPr>
-        <p:spPr>
-          <a:xfrm>
-            <a:off x="502920" y="3913632"/>
-            <a:ext cx="5394960" cy="219456"/>
-          </a:xfrm>
-          <a:prstGeom prst="rect">
-            <a:avLst/>
-          </a:prstGeom>
-          <a:noFill/>
-          <a:ln/>
-        </p:spPr>
-        <p:txBody>
-          <a:bodyPr wrap="square" lIns="0" tIns="0" rIns="0" bIns="0" rtlCol="0" anchor="ctr"/>
-          <a:lstStyle/>
-          <a:p>
-            <a:pPr indent="0" marL="0">
-              <a:buNone/>
-            </a:pPr>
-            <a:r>
-              <a:rPr lang="en-US" sz="1000" b="1" dirty="0">
-                <a:solidFill>
-                  <a:srgbClr val="1F2937"/>
-                </a:solidFill>
-                <a:latin typeface="Calibri" pitchFamily="34" charset="0"/>
-                <a:ea typeface="Calibri" pitchFamily="34" charset="-122"/>
-                <a:cs typeface="Calibri" pitchFamily="34" charset="-120"/>
-              </a:rPr>
-              <a:t>SH issues — 51 tags on 50 QC fails (August)</a:t>
-            </a:r>
-            <a:endParaRPr lang="en-US" sz="1000" dirty="0"/>
-          </a:p>
-        </p:txBody>
-      </p:sp>
-      <p:graphicFrame>
-        <p:nvGraphicFramePr>
-          <p:cNvPr id="12" name="Chart 2" descr=""/>
-          <p:cNvGraphicFramePr/>
-          <p:nvPr/>
-        </p:nvGraphicFramePr>
-        <p:xfrm>
-          <a:off x="502920" y="4133088"/>
-          <a:ext cx="5394960" cy="1417320"/>
-        </p:xfrm>
-        <a:graphic xmlns:a="http://schemas.openxmlformats.org/drawingml/2006/main">
-          <a:graphicData uri="http://schemas.openxmlformats.org/drawingml/2006/chart">
-            <c:chart xmlns:c="http://schemas.openxmlformats.org/drawingml/2006/chart" r:id="rId3"/>
-          </a:graphicData>
-        </a:graphic>
-      </p:graphicFrame>
-      <p:sp>
-        <p:nvSpPr>
-          <p:cNvPr id="13" name="Text 8"/>
-          <p:cNvSpPr/>
-          <p:nvPr/>
-        </p:nvSpPr>
-        <p:spPr>
-          <a:xfrm>
-            <a:off x="6263640" y="3913632"/>
-            <a:ext cx="5394960" cy="219456"/>
-          </a:xfrm>
-          <a:prstGeom prst="rect">
-            <a:avLst/>
-          </a:prstGeom>
-          <a:noFill/>
-          <a:ln/>
-        </p:spPr>
-        <p:txBody>
-          <a:bodyPr wrap="square" lIns="0" tIns="0" rIns="0" bIns="0" rtlCol="0" anchor="ctr"/>
-          <a:lstStyle/>
-          <a:p>
-            <a:pPr indent="0" marL="0">
-              <a:buNone/>
-            </a:pPr>
-            <a:r>
-              <a:rPr lang="en-US" sz="1000" b="1" dirty="0">
-                <a:solidFill>
-                  <a:srgbClr val="1F2937"/>
-                </a:solidFill>
-                <a:latin typeface="Calibri" pitchFamily="34" charset="0"/>
-                <a:ea typeface="Calibri" pitchFamily="34" charset="-122"/>
-                <a:cs typeface="Calibri" pitchFamily="34" charset="-120"/>
-              </a:rPr>
-              <a:t>ATM scrap — 24 units · matched batches, all quality</a:t>
-            </a:r>
-            <a:endParaRPr lang="en-US" sz="1000" dirty="0"/>
-          </a:p>
-        </p:txBody>
-      </p:sp>
-      <p:graphicFrame>
-        <p:nvGraphicFramePr>
-          <p:cNvPr id="14" name="Chart 3" descr=""/>
-          <p:cNvGraphicFramePr/>
-          <p:nvPr/>
-        </p:nvGraphicFramePr>
-        <p:xfrm>
-          <a:off x="6263640" y="4133088"/>
-          <a:ext cx="5394960" cy="1417320"/>
-        </p:xfrm>
-        <a:graphic xmlns:a="http://schemas.openxmlformats.org/drawingml/2006/main">
-          <a:graphicData uri="http://schemas.openxmlformats.org/drawingml/2006/chart">
-            <c:chart xmlns:c="http://schemas.openxmlformats.org/drawingml/2006/chart" r:id="rId4"/>
-          </a:graphicData>
-        </a:graphic>
-      </p:graphicFrame>
-      <p:sp>
-        <p:nvSpPr>
-          <p:cNvPr id="15" name="Text 9"/>
-          <p:cNvSpPr/>
-          <p:nvPr/>
-        </p:nvSpPr>
-        <p:spPr>
-          <a:xfrm>
-            <a:off x="502920" y="5541264"/>
-            <a:ext cx="11155680" cy="201168"/>
-          </a:xfrm>
-          <a:prstGeom prst="rect">
-            <a:avLst/>
-          </a:prstGeom>
-          <a:noFill/>
-          <a:ln/>
-        </p:spPr>
-        <p:txBody>
-          <a:bodyPr wrap="square" lIns="0" tIns="0" rIns="0" bIns="0" rtlCol="0" anchor="ctr"/>
-          <a:lstStyle/>
-          <a:p>
-            <a:pPr indent="0" marL="0">
-              <a:buNone/>
-            </a:pPr>
-            <a:r>
-              <a:rPr lang="en-US" sz="820" i="1" dirty="0">
-                <a:solidFill>
-                  <a:srgbClr val="6B7280"/>
-                </a:solidFill>
-                <a:latin typeface="Calibri" pitchFamily="34" charset="0"/>
-                <a:ea typeface="Calibri" pitchFamily="34" charset="-122"/>
-                <a:cs typeface="Calibri" pitchFamily="34" charset="-120"/>
-              </a:rPr>
-              <a:t>Not charted: harvest-stage rejects at Nahunta's two-inspection visits — it took 18 blocks at harvest to get 8 good ones on 8/26, and 19 to get 2 on 9/9 (17 rejected incl. 9 MISSING TRACHEA: tracheas harvested for another buyer).</a:t>
-            </a:r>
-            <a:endParaRPr lang="en-US" sz="820" dirty="0"/>
-          </a:p>
-        </p:txBody>
-      </p:sp>
-      <p:sp>
-        <p:nvSpPr>
-          <p:cNvPr id="16" name="Text 10"/>
-          <p:cNvSpPr/>
-          <p:nvPr/>
-        </p:nvSpPr>
-        <p:spPr>
-          <a:xfrm>
-            <a:off x="502920" y="5943600"/>
-            <a:ext cx="11155680" cy="365760"/>
+            <a:off x="502920" y="5897880"/>
+            <a:ext cx="11155680" cy="411480"/>
           </a:xfrm>
           <a:prstGeom prst="rect">
             <a:avLst/>
@@ -6513,7 +4533,7 @@
                 <a:ea typeface="Calibri" pitchFamily="34" charset="-122"/>
                 <a:cs typeface="Calibri" pitchFamily="34" charset="-120"/>
               </a:rPr>
-              <a:t>ATM side counts only batches that were inspected at the slaughterhouses (matched lots), postings 08/01–09/16 net of reversals. ATM scrap in this window reflects batches harvested ~1–1.5 months earlier; thoracic ATM units are the survivors of already-failing SH lots.</a:t>
+              <a:t>ATM side counts only batches that were inspected at the slaughterhouses (matched lots), postings 08/01–09/16 net of reversals. ATM scrap in this window reflects batches harvested ~1–1.5 months earlier. SH counts are floor samples; ATM counts are full received quantities.</a:t>
             </a:r>
             <a:endParaRPr lang="en-US" sz="850" dirty="0"/>
           </a:p>
@@ -6521,7 +4541,7 @@
       </p:sp>
       <p:sp>
         <p:nvSpPr>
-          <p:cNvPr id="17" name="Text 11"/>
+          <p:cNvPr id="11" name="Text 7"/>
           <p:cNvSpPr/>
           <p:nvPr/>
         </p:nvSpPr>
@@ -6560,7 +4580,7 @@
       </p:sp>
       <p:sp>
         <p:nvSpPr>
-          <p:cNvPr id="18" name="Text 12"/>
+          <p:cNvPr id="12" name="Text 8"/>
           <p:cNvSpPr/>
           <p:nvPr/>
         </p:nvSpPr>

</xml_diff>